<commit_message>
Split KPI slide into two tiers: adoption + extraction quality
Tier 1 (adoption): packets generated, unique suppliers queried,
avg gen time, daily volume, per-supplier frequency.
Tier 2 (extraction quality): the original 5 KPIs §1-§5.
Both tiers map to their SQLite columns.

Co-Authored-By: Claude Sonnet 4.6 <noreply@anthropic.com>
</commit_message>
<xml_diff>
--- a/docs/strauss_fde_deck.pptx
+++ b/docs/strauss_fde_deck.pptx
@@ -5046,7 +5046,7 @@
                 </a:solidFill>
                 <a:latin typeface="Calibri"/>
               </a:rPr>
-              <a:t>Five KPIs — Measurable in 90 Days</a:t>
+              <a:t>KPIs — Two Tiers, Both Tracked</a:t>
             </a:r>
           </a:p>
         </p:txBody>
@@ -5089,7 +5089,7 @@
                 </a:solidFill>
                 <a:latin typeface="Calibri"/>
               </a:rPr>
-              <a:t>Defined in metrics.md · Captured per packet in SQLite · Visible in FDE dashboard</a:t>
+              <a:t>Adoption tells you if people use it. Extraction quality tells you if it's worth using.</a:t>
             </a:r>
           </a:p>
         </p:txBody>
@@ -5182,25 +5182,66 @@
       </p:sp>
       <p:sp>
         <p:nvSpPr>
-          <p:cNvPr id="7" name="Rectangle 6"/>
+          <p:cNvPr id="7" name="TextBox 6"/>
+          <p:cNvSpPr txBox="1"/>
+          <p:nvPr/>
+        </p:nvSpPr>
+        <p:spPr>
+          <a:xfrm>
+            <a:off x="182880" y="1170432"/>
+            <a:ext cx="4114800" cy="292608"/>
+          </a:xfrm>
+          <a:prstGeom prst="rect">
+            <a:avLst/>
+          </a:prstGeom>
+          <a:noFill/>
+        </p:spPr>
+        <p:txBody>
+          <a:bodyPr wrap="none">
+            <a:spAutoFit/>
+          </a:bodyPr>
+          <a:lstStyle/>
+          <a:p/>
+          <a:p>
+            <a:pPr algn="l">
+              <a:spcBef>
+                <a:spcPts val="0"/>
+              </a:spcBef>
+              <a:spcAft>
+                <a:spcPts val="0"/>
+              </a:spcAft>
+            </a:pPr>
+            <a:r>
+              <a:rPr sz="1000" b="1">
+                <a:solidFill>
+                  <a:srgbClr val="FFFFFF"/>
+                </a:solidFill>
+                <a:latin typeface="Calibri"/>
+              </a:rPr>
+              <a:t>TIER 1  —  ADOPTION  (is it being used?)</a:t>
+            </a:r>
+          </a:p>
+        </p:txBody>
+      </p:sp>
+      <p:sp>
+        <p:nvSpPr>
+          <p:cNvPr id="8" name="Rectangle 7"/>
           <p:cNvSpPr/>
           <p:nvPr/>
         </p:nvSpPr>
         <p:spPr>
           <a:xfrm>
             <a:off x="182880" y="1170432"/>
-            <a:ext cx="457200" cy="347472"/>
+            <a:ext cx="11841480" cy="292608"/>
           </a:xfrm>
           <a:prstGeom prst="rect">
             <a:avLst/>
           </a:prstGeom>
           <a:solidFill>
-            <a:srgbClr val="C8102E"/>
+            <a:srgbClr val="1A1A1A"/>
           </a:solidFill>
           <a:ln>
-            <a:solidFill>
-              <a:srgbClr val="DDDDDD"/>
-            </a:solidFill>
+            <a:noFill/>
           </a:ln>
         </p:spPr>
         <p:style>
@@ -5227,59 +5268,14 @@
       </p:sp>
       <p:sp>
         <p:nvSpPr>
-          <p:cNvPr id="8" name="Rectangle 7"/>
-          <p:cNvSpPr/>
-          <p:nvPr/>
-        </p:nvSpPr>
-        <p:spPr>
-          <a:xfrm>
-            <a:off x="731520" y="1170432"/>
-            <a:ext cx="4114800" cy="347472"/>
-          </a:xfrm>
-          <a:prstGeom prst="rect">
-            <a:avLst/>
-          </a:prstGeom>
-          <a:solidFill>
-            <a:srgbClr val="C8102E"/>
-          </a:solidFill>
-          <a:ln>
-            <a:solidFill>
-              <a:srgbClr val="DDDDDD"/>
-            </a:solidFill>
-          </a:ln>
-        </p:spPr>
-        <p:style>
-          <a:lnRef idx="1">
-            <a:schemeClr val="accent1"/>
-          </a:lnRef>
-          <a:fillRef idx="3">
-            <a:schemeClr val="accent1"/>
-          </a:fillRef>
-          <a:effectRef idx="2">
-            <a:schemeClr val="accent1"/>
-          </a:effectRef>
-          <a:fontRef idx="minor">
-            <a:schemeClr val="lt1"/>
-          </a:fontRef>
-        </p:style>
-        <p:txBody>
-          <a:bodyPr rtlCol="0" anchor="ctr"/>
-          <a:lstStyle/>
-          <a:p>
-            <a:pPr algn="ctr"/>
-          </a:p>
-        </p:txBody>
-      </p:sp>
-      <p:sp>
-        <p:nvSpPr>
           <p:cNvPr id="9" name="TextBox 8"/>
           <p:cNvSpPr txBox="1"/>
           <p:nvPr/>
         </p:nvSpPr>
         <p:spPr>
           <a:xfrm>
-            <a:off x="777240" y="1188720"/>
-            <a:ext cx="4041648" cy="310896"/>
+            <a:off x="274320" y="1179576"/>
+            <a:ext cx="11612880" cy="256032"/>
           </a:xfrm>
           <a:prstGeom prst="rect">
             <a:avLst/>
@@ -5308,7 +5304,7 @@
                 </a:solidFill>
                 <a:latin typeface="Calibri"/>
               </a:rPr>
-              <a:t>Definition &amp; formula</a:t>
+              <a:t>TIER 1  —  ADOPTION  (is it being used?)</a:t>
             </a:r>
           </a:p>
         </p:txBody>
@@ -5321,272 +5317,8 @@
         </p:nvSpPr>
         <p:spPr>
           <a:xfrm>
-            <a:off x="4937760" y="1170432"/>
-            <a:ext cx="3200400" cy="347472"/>
-          </a:xfrm>
-          <a:prstGeom prst="rect">
-            <a:avLst/>
-          </a:prstGeom>
-          <a:solidFill>
-            <a:srgbClr val="C8102E"/>
-          </a:solidFill>
-          <a:ln>
-            <a:solidFill>
-              <a:srgbClr val="DDDDDD"/>
-            </a:solidFill>
-          </a:ln>
-        </p:spPr>
-        <p:style>
-          <a:lnRef idx="1">
-            <a:schemeClr val="accent1"/>
-          </a:lnRef>
-          <a:fillRef idx="3">
-            <a:schemeClr val="accent1"/>
-          </a:fillRef>
-          <a:effectRef idx="2">
-            <a:schemeClr val="accent1"/>
-          </a:effectRef>
-          <a:fontRef idx="minor">
-            <a:schemeClr val="lt1"/>
-          </a:fontRef>
-        </p:style>
-        <p:txBody>
-          <a:bodyPr rtlCol="0" anchor="ctr"/>
-          <a:lstStyle/>
-          <a:p>
-            <a:pPr algn="ctr"/>
-          </a:p>
-        </p:txBody>
-      </p:sp>
-      <p:sp>
-        <p:nvSpPr>
-          <p:cNvPr id="11" name="TextBox 10"/>
-          <p:cNvSpPr txBox="1"/>
-          <p:nvPr/>
-        </p:nvSpPr>
-        <p:spPr>
-          <a:xfrm>
-            <a:off x="4983480" y="1188720"/>
-            <a:ext cx="3127248" cy="310896"/>
-          </a:xfrm>
-          <a:prstGeom prst="rect">
-            <a:avLst/>
-          </a:prstGeom>
-          <a:noFill/>
-        </p:spPr>
-        <p:txBody>
-          <a:bodyPr wrap="none">
-            <a:spAutoFit/>
-          </a:bodyPr>
-          <a:lstStyle/>
-          <a:p/>
-          <a:p>
-            <a:pPr algn="l">
-              <a:spcBef>
-                <a:spcPts val="0"/>
-              </a:spcBef>
-              <a:spcAft>
-                <a:spcPts val="0"/>
-              </a:spcAft>
-            </a:pPr>
-            <a:r>
-              <a:rPr sz="1000" b="1">
-                <a:solidFill>
-                  <a:srgbClr val="FFFFFF"/>
-                </a:solidFill>
-                <a:latin typeface="Calibri"/>
-              </a:rPr>
-              <a:t>How it is computed</a:t>
-            </a:r>
-          </a:p>
-        </p:txBody>
-      </p:sp>
-      <p:sp>
-        <p:nvSpPr>
-          <p:cNvPr id="12" name="Rectangle 11"/>
-          <p:cNvSpPr/>
-          <p:nvPr/>
-        </p:nvSpPr>
-        <p:spPr>
-          <a:xfrm>
-            <a:off x="8229600" y="1170432"/>
-            <a:ext cx="1828800" cy="347472"/>
-          </a:xfrm>
-          <a:prstGeom prst="rect">
-            <a:avLst/>
-          </a:prstGeom>
-          <a:solidFill>
-            <a:srgbClr val="C8102E"/>
-          </a:solidFill>
-          <a:ln>
-            <a:solidFill>
-              <a:srgbClr val="DDDDDD"/>
-            </a:solidFill>
-          </a:ln>
-        </p:spPr>
-        <p:style>
-          <a:lnRef idx="1">
-            <a:schemeClr val="accent1"/>
-          </a:lnRef>
-          <a:fillRef idx="3">
-            <a:schemeClr val="accent1"/>
-          </a:fillRef>
-          <a:effectRef idx="2">
-            <a:schemeClr val="accent1"/>
-          </a:effectRef>
-          <a:fontRef idx="minor">
-            <a:schemeClr val="lt1"/>
-          </a:fontRef>
-        </p:style>
-        <p:txBody>
-          <a:bodyPr rtlCol="0" anchor="ctr"/>
-          <a:lstStyle/>
-          <a:p>
-            <a:pPr algn="ctr"/>
-          </a:p>
-        </p:txBody>
-      </p:sp>
-      <p:sp>
-        <p:nvSpPr>
-          <p:cNvPr id="13" name="TextBox 12"/>
-          <p:cNvSpPr txBox="1"/>
-          <p:nvPr/>
-        </p:nvSpPr>
-        <p:spPr>
-          <a:xfrm>
-            <a:off x="8275320" y="1188720"/>
-            <a:ext cx="1755648" cy="310896"/>
-          </a:xfrm>
-          <a:prstGeom prst="rect">
-            <a:avLst/>
-          </a:prstGeom>
-          <a:noFill/>
-        </p:spPr>
-        <p:txBody>
-          <a:bodyPr wrap="none">
-            <a:spAutoFit/>
-          </a:bodyPr>
-          <a:lstStyle/>
-          <a:p/>
-          <a:p>
-            <a:pPr algn="l">
-              <a:spcBef>
-                <a:spcPts val="0"/>
-              </a:spcBef>
-              <a:spcAft>
-                <a:spcPts val="0"/>
-              </a:spcAft>
-            </a:pPr>
-            <a:r>
-              <a:rPr sz="1000" b="1">
-                <a:solidFill>
-                  <a:srgbClr val="FFFFFF"/>
-                </a:solidFill>
-                <a:latin typeface="Calibri"/>
-              </a:rPr>
-              <a:t>Live example</a:t>
-            </a:r>
-          </a:p>
-        </p:txBody>
-      </p:sp>
-      <p:sp>
-        <p:nvSpPr>
-          <p:cNvPr id="14" name="Rectangle 13"/>
-          <p:cNvSpPr/>
-          <p:nvPr/>
-        </p:nvSpPr>
-        <p:spPr>
-          <a:xfrm>
-            <a:off x="10149840" y="1170432"/>
-            <a:ext cx="1828800" cy="347472"/>
-          </a:xfrm>
-          <a:prstGeom prst="rect">
-            <a:avLst/>
-          </a:prstGeom>
-          <a:solidFill>
-            <a:srgbClr val="C8102E"/>
-          </a:solidFill>
-          <a:ln>
-            <a:solidFill>
-              <a:srgbClr val="DDDDDD"/>
-            </a:solidFill>
-          </a:ln>
-        </p:spPr>
-        <p:style>
-          <a:lnRef idx="1">
-            <a:schemeClr val="accent1"/>
-          </a:lnRef>
-          <a:fillRef idx="3">
-            <a:schemeClr val="accent1"/>
-          </a:fillRef>
-          <a:effectRef idx="2">
-            <a:schemeClr val="accent1"/>
-          </a:effectRef>
-          <a:fontRef idx="minor">
-            <a:schemeClr val="lt1"/>
-          </a:fontRef>
-        </p:style>
-        <p:txBody>
-          <a:bodyPr rtlCol="0" anchor="ctr"/>
-          <a:lstStyle/>
-          <a:p>
-            <a:pPr algn="ctr"/>
-          </a:p>
-        </p:txBody>
-      </p:sp>
-      <p:sp>
-        <p:nvSpPr>
-          <p:cNvPr id="15" name="TextBox 14"/>
-          <p:cNvSpPr txBox="1"/>
-          <p:nvPr/>
-        </p:nvSpPr>
-        <p:spPr>
-          <a:xfrm>
-            <a:off x="10195560" y="1188720"/>
-            <a:ext cx="1755648" cy="310896"/>
-          </a:xfrm>
-          <a:prstGeom prst="rect">
-            <a:avLst/>
-          </a:prstGeom>
-          <a:noFill/>
-        </p:spPr>
-        <p:txBody>
-          <a:bodyPr wrap="none">
-            <a:spAutoFit/>
-          </a:bodyPr>
-          <a:lstStyle/>
-          <a:p/>
-          <a:p>
-            <a:pPr algn="l">
-              <a:spcBef>
-                <a:spcPts val="0"/>
-              </a:spcBef>
-              <a:spcAft>
-                <a:spcPts val="0"/>
-              </a:spcAft>
-            </a:pPr>
-            <a:r>
-              <a:rPr sz="1000" b="1">
-                <a:solidFill>
-                  <a:srgbClr val="FFFFFF"/>
-                </a:solidFill>
-                <a:latin typeface="Calibri"/>
-              </a:rPr>
-              <a:t>FDE tracking</a:t>
-            </a:r>
-          </a:p>
-        </p:txBody>
-      </p:sp>
-      <p:sp>
-        <p:nvSpPr>
-          <p:cNvPr id="16" name="Rectangle 15"/>
-          <p:cNvSpPr/>
-          <p:nvPr/>
-        </p:nvSpPr>
-        <p:spPr>
-          <a:xfrm>
-            <a:off x="182880" y="1572768"/>
-            <a:ext cx="457200" cy="987552"/>
+            <a:off x="182880" y="1508760"/>
+            <a:ext cx="2286000" cy="1417320"/>
           </a:xfrm>
           <a:prstGeom prst="rect">
             <a:avLst/>
@@ -5624,14 +5356,317 @@
       </p:sp>
       <p:sp>
         <p:nvSpPr>
-          <p:cNvPr id="17" name="Rectangle 16"/>
+          <p:cNvPr id="11" name="TextBox 10"/>
+          <p:cNvSpPr txBox="1"/>
+          <p:nvPr/>
+        </p:nvSpPr>
+        <p:spPr>
+          <a:xfrm>
+            <a:off x="274320" y="1536192"/>
+            <a:ext cx="2103120" cy="292608"/>
+          </a:xfrm>
+          <a:prstGeom prst="rect">
+            <a:avLst/>
+          </a:prstGeom>
+          <a:noFill/>
+        </p:spPr>
+        <p:txBody>
+          <a:bodyPr wrap="none">
+            <a:spAutoFit/>
+          </a:bodyPr>
+          <a:lstStyle/>
+          <a:p/>
+          <a:p>
+            <a:pPr algn="l">
+              <a:spcBef>
+                <a:spcPts val="0"/>
+              </a:spcBef>
+              <a:spcAft>
+                <a:spcPts val="0"/>
+              </a:spcAft>
+            </a:pPr>
+            <a:r>
+              <a:rPr sz="1000" b="1">
+                <a:solidFill>
+                  <a:srgbClr val="1A1A1A"/>
+                </a:solidFill>
+                <a:latin typeface="Calibri"/>
+              </a:rPr>
+              <a:t>Packets generated</a:t>
+            </a:r>
+          </a:p>
+        </p:txBody>
+      </p:sp>
+      <p:sp>
+        <p:nvSpPr>
+          <p:cNvPr id="12" name="TextBox 11"/>
+          <p:cNvSpPr txBox="1"/>
+          <p:nvPr/>
+        </p:nvSpPr>
+        <p:spPr>
+          <a:xfrm>
+            <a:off x="274320" y="1828800"/>
+            <a:ext cx="2103120" cy="822960"/>
+          </a:xfrm>
+          <a:prstGeom prst="rect">
+            <a:avLst/>
+          </a:prstGeom>
+          <a:noFill/>
+        </p:spPr>
+        <p:txBody>
+          <a:bodyPr wrap="square">
+            <a:spAutoFit/>
+          </a:bodyPr>
+          <a:lstStyle/>
+          <a:p/>
+          <a:p>
+            <a:pPr algn="l">
+              <a:spcBef>
+                <a:spcPts val="0"/>
+              </a:spcBef>
+              <a:spcAft>
+                <a:spcPts val="0"/>
+              </a:spcAft>
+            </a:pPr>
+            <a:r>
+              <a:rPr sz="800" b="0">
+                <a:solidFill>
+                  <a:srgbClr val="1A1A1A"/>
+                </a:solidFill>
+                <a:latin typeface="Calibri"/>
+              </a:rPr>
+              <a:t>Total count of prep packets produced. Primary adoption signal — zero means the tool isn't being used.</a:t>
+            </a:r>
+          </a:p>
+        </p:txBody>
+      </p:sp>
+      <p:sp>
+        <p:nvSpPr>
+          <p:cNvPr id="13" name="TextBox 12"/>
+          <p:cNvSpPr txBox="1"/>
+          <p:nvPr/>
+        </p:nvSpPr>
+        <p:spPr>
+          <a:xfrm>
+            <a:off x="274320" y="2724912"/>
+            <a:ext cx="2103120" cy="182880"/>
+          </a:xfrm>
+          <a:prstGeom prst="rect">
+            <a:avLst/>
+          </a:prstGeom>
+          <a:noFill/>
+        </p:spPr>
+        <p:txBody>
+          <a:bodyPr wrap="none">
+            <a:spAutoFit/>
+          </a:bodyPr>
+          <a:lstStyle/>
+          <a:p/>
+          <a:p>
+            <a:pPr algn="l">
+              <a:spcBef>
+                <a:spcPts val="0"/>
+              </a:spcBef>
+              <a:spcAft>
+                <a:spcPts val="0"/>
+              </a:spcAft>
+            </a:pPr>
+            <a:r>
+              <a:rPr sz="700" b="0">
+                <a:solidFill>
+                  <a:srgbClr val="555555"/>
+                </a:solidFill>
+                <a:latin typeface="Calibri"/>
+              </a:rPr>
+              <a:t>total_packets in SQLite</a:t>
+            </a:r>
+          </a:p>
+        </p:txBody>
+      </p:sp>
+      <p:sp>
+        <p:nvSpPr>
+          <p:cNvPr id="14" name="Rectangle 13"/>
           <p:cNvSpPr/>
           <p:nvPr/>
         </p:nvSpPr>
         <p:spPr>
           <a:xfrm>
-            <a:off x="731520" y="1572768"/>
-            <a:ext cx="4114800" cy="987552"/>
+            <a:off x="2560320" y="1508760"/>
+            <a:ext cx="2286000" cy="1417320"/>
+          </a:xfrm>
+          <a:prstGeom prst="rect">
+            <a:avLst/>
+          </a:prstGeom>
+          <a:solidFill>
+            <a:srgbClr val="FFFFFF"/>
+          </a:solidFill>
+          <a:ln>
+            <a:solidFill>
+              <a:srgbClr val="DDDDDD"/>
+            </a:solidFill>
+          </a:ln>
+        </p:spPr>
+        <p:style>
+          <a:lnRef idx="1">
+            <a:schemeClr val="accent1"/>
+          </a:lnRef>
+          <a:fillRef idx="3">
+            <a:schemeClr val="accent1"/>
+          </a:fillRef>
+          <a:effectRef idx="2">
+            <a:schemeClr val="accent1"/>
+          </a:effectRef>
+          <a:fontRef idx="minor">
+            <a:schemeClr val="lt1"/>
+          </a:fontRef>
+        </p:style>
+        <p:txBody>
+          <a:bodyPr rtlCol="0" anchor="ctr"/>
+          <a:lstStyle/>
+          <a:p>
+            <a:pPr algn="ctr"/>
+          </a:p>
+        </p:txBody>
+      </p:sp>
+      <p:sp>
+        <p:nvSpPr>
+          <p:cNvPr id="15" name="TextBox 14"/>
+          <p:cNvSpPr txBox="1"/>
+          <p:nvPr/>
+        </p:nvSpPr>
+        <p:spPr>
+          <a:xfrm>
+            <a:off x="2651760" y="1536192"/>
+            <a:ext cx="2103120" cy="292608"/>
+          </a:xfrm>
+          <a:prstGeom prst="rect">
+            <a:avLst/>
+          </a:prstGeom>
+          <a:noFill/>
+        </p:spPr>
+        <p:txBody>
+          <a:bodyPr wrap="none">
+            <a:spAutoFit/>
+          </a:bodyPr>
+          <a:lstStyle/>
+          <a:p/>
+          <a:p>
+            <a:pPr algn="l">
+              <a:spcBef>
+                <a:spcPts val="0"/>
+              </a:spcBef>
+              <a:spcAft>
+                <a:spcPts val="0"/>
+              </a:spcAft>
+            </a:pPr>
+            <a:r>
+              <a:rPr sz="1000" b="1">
+                <a:solidFill>
+                  <a:srgbClr val="1A1A1A"/>
+                </a:solidFill>
+                <a:latin typeface="Calibri"/>
+              </a:rPr>
+              <a:t>Unique suppliers queried</a:t>
+            </a:r>
+          </a:p>
+        </p:txBody>
+      </p:sp>
+      <p:sp>
+        <p:nvSpPr>
+          <p:cNvPr id="16" name="TextBox 15"/>
+          <p:cNvSpPr txBox="1"/>
+          <p:nvPr/>
+        </p:nvSpPr>
+        <p:spPr>
+          <a:xfrm>
+            <a:off x="2651760" y="1828800"/>
+            <a:ext cx="2103120" cy="822960"/>
+          </a:xfrm>
+          <a:prstGeom prst="rect">
+            <a:avLst/>
+          </a:prstGeom>
+          <a:noFill/>
+        </p:spPr>
+        <p:txBody>
+          <a:bodyPr wrap="square">
+            <a:spAutoFit/>
+          </a:bodyPr>
+          <a:lstStyle/>
+          <a:p/>
+          <a:p>
+            <a:pPr algn="l">
+              <a:spcBef>
+                <a:spcPts val="0"/>
+              </a:spcBef>
+              <a:spcAft>
+                <a:spcPts val="0"/>
+              </a:spcAft>
+            </a:pPr>
+            <a:r>
+              <a:rPr sz="800" b="0">
+                <a:solidFill>
+                  <a:srgbClr val="1A1A1A"/>
+                </a:solidFill>
+                <a:latin typeface="Calibri"/>
+              </a:rPr>
+              <a:t>How many distinct suppliers have had a packet generated. Breadth of adoption across the supplier roster.</a:t>
+            </a:r>
+          </a:p>
+        </p:txBody>
+      </p:sp>
+      <p:sp>
+        <p:nvSpPr>
+          <p:cNvPr id="17" name="TextBox 16"/>
+          <p:cNvSpPr txBox="1"/>
+          <p:nvPr/>
+        </p:nvSpPr>
+        <p:spPr>
+          <a:xfrm>
+            <a:off x="2651760" y="2724912"/>
+            <a:ext cx="2103120" cy="182880"/>
+          </a:xfrm>
+          <a:prstGeom prst="rect">
+            <a:avLst/>
+          </a:prstGeom>
+          <a:noFill/>
+        </p:spPr>
+        <p:txBody>
+          <a:bodyPr wrap="none">
+            <a:spAutoFit/>
+          </a:bodyPr>
+          <a:lstStyle/>
+          <a:p/>
+          <a:p>
+            <a:pPr algn="l">
+              <a:spcBef>
+                <a:spcPts val="0"/>
+              </a:spcBef>
+              <a:spcAft>
+                <a:spcPts val="0"/>
+              </a:spcAft>
+            </a:pPr>
+            <a:r>
+              <a:rPr sz="700" b="0">
+                <a:solidFill>
+                  <a:srgbClr val="555555"/>
+                </a:solidFill>
+                <a:latin typeface="Calibri"/>
+              </a:rPr>
+              <a:t>unique_suppliers in SQLite</a:t>
+            </a:r>
+          </a:p>
+        </p:txBody>
+      </p:sp>
+      <p:sp>
+        <p:nvSpPr>
+          <p:cNvPr id="18" name="Rectangle 17"/>
+          <p:cNvSpPr/>
+          <p:nvPr/>
+        </p:nvSpPr>
+        <p:spPr>
+          <a:xfrm>
+            <a:off x="4937760" y="1508760"/>
+            <a:ext cx="2286000" cy="1417320"/>
           </a:xfrm>
           <a:prstGeom prst="rect">
             <a:avLst/>
@@ -5669,14 +5704,317 @@
       </p:sp>
       <p:sp>
         <p:nvSpPr>
-          <p:cNvPr id="18" name="Rectangle 17"/>
+          <p:cNvPr id="19" name="TextBox 18"/>
+          <p:cNvSpPr txBox="1"/>
+          <p:nvPr/>
+        </p:nvSpPr>
+        <p:spPr>
+          <a:xfrm>
+            <a:off x="5029200" y="1536192"/>
+            <a:ext cx="2103120" cy="292608"/>
+          </a:xfrm>
+          <a:prstGeom prst="rect">
+            <a:avLst/>
+          </a:prstGeom>
+          <a:noFill/>
+        </p:spPr>
+        <p:txBody>
+          <a:bodyPr wrap="none">
+            <a:spAutoFit/>
+          </a:bodyPr>
+          <a:lstStyle/>
+          <a:p/>
+          <a:p>
+            <a:pPr algn="l">
+              <a:spcBef>
+                <a:spcPts val="0"/>
+              </a:spcBef>
+              <a:spcAft>
+                <a:spcPts val="0"/>
+              </a:spcAft>
+            </a:pPr>
+            <a:r>
+              <a:rPr sz="1000" b="1">
+                <a:solidFill>
+                  <a:srgbClr val="1A1A1A"/>
+                </a:solidFill>
+                <a:latin typeface="Calibri"/>
+              </a:rPr>
+              <a:t>Avg generation time (s)</a:t>
+            </a:r>
+          </a:p>
+        </p:txBody>
+      </p:sp>
+      <p:sp>
+        <p:nvSpPr>
+          <p:cNvPr id="20" name="TextBox 19"/>
+          <p:cNvSpPr txBox="1"/>
+          <p:nvPr/>
+        </p:nvSpPr>
+        <p:spPr>
+          <a:xfrm>
+            <a:off x="5029200" y="1828800"/>
+            <a:ext cx="2103120" cy="822960"/>
+          </a:xfrm>
+          <a:prstGeom prst="rect">
+            <a:avLst/>
+          </a:prstGeom>
+          <a:noFill/>
+        </p:spPr>
+        <p:txBody>
+          <a:bodyPr wrap="square">
+            <a:spAutoFit/>
+          </a:bodyPr>
+          <a:lstStyle/>
+          <a:p/>
+          <a:p>
+            <a:pPr algn="l">
+              <a:spcBef>
+                <a:spcPts val="0"/>
+              </a:spcBef>
+              <a:spcAft>
+                <a:spcPts val="0"/>
+              </a:spcAft>
+            </a:pPr>
+            <a:r>
+              <a:rPr sz="800" b="0">
+                <a:solidFill>
+                  <a:srgbClr val="1A1A1A"/>
+                </a:solidFill>
+                <a:latin typeface="Calibri"/>
+              </a:rPr>
+              <a:t>Average seconds per packet. Tracks performance — target &lt;15s. Regression signal if it grows.</a:t>
+            </a:r>
+          </a:p>
+        </p:txBody>
+      </p:sp>
+      <p:sp>
+        <p:nvSpPr>
+          <p:cNvPr id="21" name="TextBox 20"/>
+          <p:cNvSpPr txBox="1"/>
+          <p:nvPr/>
+        </p:nvSpPr>
+        <p:spPr>
+          <a:xfrm>
+            <a:off x="5029200" y="2724912"/>
+            <a:ext cx="2103120" cy="182880"/>
+          </a:xfrm>
+          <a:prstGeom prst="rect">
+            <a:avLst/>
+          </a:prstGeom>
+          <a:noFill/>
+        </p:spPr>
+        <p:txBody>
+          <a:bodyPr wrap="none">
+            <a:spAutoFit/>
+          </a:bodyPr>
+          <a:lstStyle/>
+          <a:p/>
+          <a:p>
+            <a:pPr algn="l">
+              <a:spcBef>
+                <a:spcPts val="0"/>
+              </a:spcBef>
+              <a:spcAft>
+                <a:spcPts val="0"/>
+              </a:spcAft>
+            </a:pPr>
+            <a:r>
+              <a:rPr sz="700" b="0">
+                <a:solidFill>
+                  <a:srgbClr val="555555"/>
+                </a:solidFill>
+                <a:latin typeface="Calibri"/>
+              </a:rPr>
+              <a:t>avg_duration_sec in SQLite</a:t>
+            </a:r>
+          </a:p>
+        </p:txBody>
+      </p:sp>
+      <p:sp>
+        <p:nvSpPr>
+          <p:cNvPr id="22" name="Rectangle 21"/>
           <p:cNvSpPr/>
           <p:nvPr/>
         </p:nvSpPr>
         <p:spPr>
           <a:xfrm>
-            <a:off x="4937760" y="1572768"/>
-            <a:ext cx="3200400" cy="987552"/>
+            <a:off x="7315200" y="1508760"/>
+            <a:ext cx="2286000" cy="1417320"/>
+          </a:xfrm>
+          <a:prstGeom prst="rect">
+            <a:avLst/>
+          </a:prstGeom>
+          <a:solidFill>
+            <a:srgbClr val="FFFFFF"/>
+          </a:solidFill>
+          <a:ln>
+            <a:solidFill>
+              <a:srgbClr val="DDDDDD"/>
+            </a:solidFill>
+          </a:ln>
+        </p:spPr>
+        <p:style>
+          <a:lnRef idx="1">
+            <a:schemeClr val="accent1"/>
+          </a:lnRef>
+          <a:fillRef idx="3">
+            <a:schemeClr val="accent1"/>
+          </a:fillRef>
+          <a:effectRef idx="2">
+            <a:schemeClr val="accent1"/>
+          </a:effectRef>
+          <a:fontRef idx="minor">
+            <a:schemeClr val="lt1"/>
+          </a:fontRef>
+        </p:style>
+        <p:txBody>
+          <a:bodyPr rtlCol="0" anchor="ctr"/>
+          <a:lstStyle/>
+          <a:p>
+            <a:pPr algn="ctr"/>
+          </a:p>
+        </p:txBody>
+      </p:sp>
+      <p:sp>
+        <p:nvSpPr>
+          <p:cNvPr id="23" name="TextBox 22"/>
+          <p:cNvSpPr txBox="1"/>
+          <p:nvPr/>
+        </p:nvSpPr>
+        <p:spPr>
+          <a:xfrm>
+            <a:off x="7406640" y="1536192"/>
+            <a:ext cx="2103120" cy="292608"/>
+          </a:xfrm>
+          <a:prstGeom prst="rect">
+            <a:avLst/>
+          </a:prstGeom>
+          <a:noFill/>
+        </p:spPr>
+        <p:txBody>
+          <a:bodyPr wrap="none">
+            <a:spAutoFit/>
+          </a:bodyPr>
+          <a:lstStyle/>
+          <a:p/>
+          <a:p>
+            <a:pPr algn="l">
+              <a:spcBef>
+                <a:spcPts val="0"/>
+              </a:spcBef>
+              <a:spcAft>
+                <a:spcPts val="0"/>
+              </a:spcAft>
+            </a:pPr>
+            <a:r>
+              <a:rPr sz="1000" b="1">
+                <a:solidFill>
+                  <a:srgbClr val="1A1A1A"/>
+                </a:solidFill>
+                <a:latin typeface="Calibri"/>
+              </a:rPr>
+              <a:t>Daily generation volume</a:t>
+            </a:r>
+          </a:p>
+        </p:txBody>
+      </p:sp>
+      <p:sp>
+        <p:nvSpPr>
+          <p:cNvPr id="24" name="TextBox 23"/>
+          <p:cNvSpPr txBox="1"/>
+          <p:nvPr/>
+        </p:nvSpPr>
+        <p:spPr>
+          <a:xfrm>
+            <a:off x="7406640" y="1828800"/>
+            <a:ext cx="2103120" cy="822960"/>
+          </a:xfrm>
+          <a:prstGeom prst="rect">
+            <a:avLst/>
+          </a:prstGeom>
+          <a:noFill/>
+        </p:spPr>
+        <p:txBody>
+          <a:bodyPr wrap="square">
+            <a:spAutoFit/>
+          </a:bodyPr>
+          <a:lstStyle/>
+          <a:p/>
+          <a:p>
+            <a:pPr algn="l">
+              <a:spcBef>
+                <a:spcPts val="0"/>
+              </a:spcBef>
+              <a:spcAft>
+                <a:spcPts val="0"/>
+              </a:spcAft>
+            </a:pPr>
+            <a:r>
+              <a:rPr sz="800" b="0">
+                <a:solidFill>
+                  <a:srgbClr val="1A1A1A"/>
+                </a:solidFill>
+                <a:latin typeface="Calibri"/>
+              </a:rPr>
+              <a:t>Packets per day over rolling 30 days. Reveals whether use is growing, flat, or dropping after initial curiosity.</a:t>
+            </a:r>
+          </a:p>
+        </p:txBody>
+      </p:sp>
+      <p:sp>
+        <p:nvSpPr>
+          <p:cNvPr id="25" name="TextBox 24"/>
+          <p:cNvSpPr txBox="1"/>
+          <p:nvPr/>
+        </p:nvSpPr>
+        <p:spPr>
+          <a:xfrm>
+            <a:off x="7406640" y="2724912"/>
+            <a:ext cx="2103120" cy="182880"/>
+          </a:xfrm>
+          <a:prstGeom prst="rect">
+            <a:avLst/>
+          </a:prstGeom>
+          <a:noFill/>
+        </p:spPr>
+        <p:txBody>
+          <a:bodyPr wrap="none">
+            <a:spAutoFit/>
+          </a:bodyPr>
+          <a:lstStyle/>
+          <a:p/>
+          <a:p>
+            <a:pPr algn="l">
+              <a:spcBef>
+                <a:spcPts val="0"/>
+              </a:spcBef>
+              <a:spcAft>
+                <a:spcPts val="0"/>
+              </a:spcAft>
+            </a:pPr>
+            <a:r>
+              <a:rPr sz="700" b="0">
+                <a:solidFill>
+                  <a:srgbClr val="555555"/>
+                </a:solidFill>
+                <a:latin typeface="Calibri"/>
+              </a:rPr>
+              <a:t>daily_breakdown table</a:t>
+            </a:r>
+          </a:p>
+        </p:txBody>
+      </p:sp>
+      <p:sp>
+        <p:nvSpPr>
+          <p:cNvPr id="26" name="Rectangle 25"/>
+          <p:cNvSpPr/>
+          <p:nvPr/>
+        </p:nvSpPr>
+        <p:spPr>
+          <a:xfrm>
+            <a:off x="9692640" y="1508760"/>
+            <a:ext cx="2286000" cy="1417320"/>
           </a:xfrm>
           <a:prstGeom prst="rect">
             <a:avLst/>
@@ -5714,14 +6052,229 @@
       </p:sp>
       <p:sp>
         <p:nvSpPr>
-          <p:cNvPr id="19" name="Rectangle 18"/>
+          <p:cNvPr id="27" name="TextBox 26"/>
+          <p:cNvSpPr txBox="1"/>
+          <p:nvPr/>
+        </p:nvSpPr>
+        <p:spPr>
+          <a:xfrm>
+            <a:off x="9784080" y="1536192"/>
+            <a:ext cx="2103120" cy="292608"/>
+          </a:xfrm>
+          <a:prstGeom prst="rect">
+            <a:avLst/>
+          </a:prstGeom>
+          <a:noFill/>
+        </p:spPr>
+        <p:txBody>
+          <a:bodyPr wrap="none">
+            <a:spAutoFit/>
+          </a:bodyPr>
+          <a:lstStyle/>
+          <a:p/>
+          <a:p>
+            <a:pPr algn="l">
+              <a:spcBef>
+                <a:spcPts val="0"/>
+              </a:spcBef>
+              <a:spcAft>
+                <a:spcPts val="0"/>
+              </a:spcAft>
+            </a:pPr>
+            <a:r>
+              <a:rPr sz="1000" b="1">
+                <a:solidFill>
+                  <a:srgbClr val="1A1A1A"/>
+                </a:solidFill>
+                <a:latin typeface="Calibri"/>
+              </a:rPr>
+              <a:t>Per-supplier frequency</a:t>
+            </a:r>
+          </a:p>
+        </p:txBody>
+      </p:sp>
+      <p:sp>
+        <p:nvSpPr>
+          <p:cNvPr id="28" name="TextBox 27"/>
+          <p:cNvSpPr txBox="1"/>
+          <p:nvPr/>
+        </p:nvSpPr>
+        <p:spPr>
+          <a:xfrm>
+            <a:off x="9784080" y="1828800"/>
+            <a:ext cx="2103120" cy="822960"/>
+          </a:xfrm>
+          <a:prstGeom prst="rect">
+            <a:avLst/>
+          </a:prstGeom>
+          <a:noFill/>
+        </p:spPr>
+        <p:txBody>
+          <a:bodyPr wrap="square">
+            <a:spAutoFit/>
+          </a:bodyPr>
+          <a:lstStyle/>
+          <a:p/>
+          <a:p>
+            <a:pPr algn="l">
+              <a:spcBef>
+                <a:spcPts val="0"/>
+              </a:spcBef>
+              <a:spcAft>
+                <a:spcPts val="0"/>
+              </a:spcAft>
+            </a:pPr>
+            <a:r>
+              <a:rPr sz="800" b="0">
+                <a:solidFill>
+                  <a:srgbClr val="1A1A1A"/>
+                </a:solidFill>
+                <a:latin typeface="Calibri"/>
+              </a:rPr>
+              <a:t>Which suppliers get prepped most often. Low frequency on a high-risk supplier = adoption gap.</a:t>
+            </a:r>
+          </a:p>
+        </p:txBody>
+      </p:sp>
+      <p:sp>
+        <p:nvSpPr>
+          <p:cNvPr id="29" name="TextBox 28"/>
+          <p:cNvSpPr txBox="1"/>
+          <p:nvPr/>
+        </p:nvSpPr>
+        <p:spPr>
+          <a:xfrm>
+            <a:off x="9784080" y="2724912"/>
+            <a:ext cx="2103120" cy="182880"/>
+          </a:xfrm>
+          <a:prstGeom prst="rect">
+            <a:avLst/>
+          </a:prstGeom>
+          <a:noFill/>
+        </p:spPr>
+        <p:txBody>
+          <a:bodyPr wrap="none">
+            <a:spAutoFit/>
+          </a:bodyPr>
+          <a:lstStyle/>
+          <a:p/>
+          <a:p>
+            <a:pPr algn="l">
+              <a:spcBef>
+                <a:spcPts val="0"/>
+              </a:spcBef>
+              <a:spcAft>
+                <a:spcPts val="0"/>
+              </a:spcAft>
+            </a:pPr>
+            <a:r>
+              <a:rPr sz="700" b="0">
+                <a:solidFill>
+                  <a:srgbClr val="555555"/>
+                </a:solidFill>
+                <a:latin typeface="Calibri"/>
+              </a:rPr>
+              <a:t>supplier_breakdown table</a:t>
+            </a:r>
+          </a:p>
+        </p:txBody>
+      </p:sp>
+      <p:sp>
+        <p:nvSpPr>
+          <p:cNvPr id="30" name="Rectangle 29"/>
           <p:cNvSpPr/>
           <p:nvPr/>
         </p:nvSpPr>
         <p:spPr>
           <a:xfrm>
-            <a:off x="8229600" y="1572768"/>
-            <a:ext cx="1828800" cy="987552"/>
+            <a:off x="182880" y="3035808"/>
+            <a:ext cx="11841480" cy="292608"/>
+          </a:xfrm>
+          <a:prstGeom prst="rect">
+            <a:avLst/>
+          </a:prstGeom>
+          <a:solidFill>
+            <a:srgbClr val="C8102E"/>
+          </a:solidFill>
+          <a:ln>
+            <a:noFill/>
+          </a:ln>
+        </p:spPr>
+        <p:style>
+          <a:lnRef idx="1">
+            <a:schemeClr val="accent1"/>
+          </a:lnRef>
+          <a:fillRef idx="3">
+            <a:schemeClr val="accent1"/>
+          </a:fillRef>
+          <a:effectRef idx="2">
+            <a:schemeClr val="accent1"/>
+          </a:effectRef>
+          <a:fontRef idx="minor">
+            <a:schemeClr val="lt1"/>
+          </a:fontRef>
+        </p:style>
+        <p:txBody>
+          <a:bodyPr rtlCol="0" anchor="ctr"/>
+          <a:lstStyle/>
+          <a:p>
+            <a:pPr algn="ctr"/>
+          </a:p>
+        </p:txBody>
+      </p:sp>
+      <p:sp>
+        <p:nvSpPr>
+          <p:cNvPr id="31" name="TextBox 30"/>
+          <p:cNvSpPr txBox="1"/>
+          <p:nvPr/>
+        </p:nvSpPr>
+        <p:spPr>
+          <a:xfrm>
+            <a:off x="274320" y="3044952"/>
+            <a:ext cx="11612880" cy="256032"/>
+          </a:xfrm>
+          <a:prstGeom prst="rect">
+            <a:avLst/>
+          </a:prstGeom>
+          <a:noFill/>
+        </p:spPr>
+        <p:txBody>
+          <a:bodyPr wrap="none">
+            <a:spAutoFit/>
+          </a:bodyPr>
+          <a:lstStyle/>
+          <a:p/>
+          <a:p>
+            <a:pPr algn="l">
+              <a:spcBef>
+                <a:spcPts val="0"/>
+              </a:spcBef>
+              <a:spcAft>
+                <a:spcPts val="0"/>
+              </a:spcAft>
+            </a:pPr>
+            <a:r>
+              <a:rPr sz="1000" b="1">
+                <a:solidFill>
+                  <a:srgbClr val="FFFFFF"/>
+                </a:solidFill>
+                <a:latin typeface="Calibri"/>
+              </a:rPr>
+              <a:t>TIER 2  —  EXTRACTION QUALITY  (is it worth using?)</a:t>
+            </a:r>
+          </a:p>
+        </p:txBody>
+      </p:sp>
+      <p:sp>
+        <p:nvSpPr>
+          <p:cNvPr id="32" name="Rectangle 31"/>
+          <p:cNvSpPr/>
+          <p:nvPr/>
+        </p:nvSpPr>
+        <p:spPr>
+          <a:xfrm>
+            <a:off x="182880" y="3364992"/>
+            <a:ext cx="2286000" cy="3246120"/>
           </a:xfrm>
           <a:prstGeom prst="rect">
             <a:avLst/>
@@ -5759,14 +6312,585 @@
       </p:sp>
       <p:sp>
         <p:nvSpPr>
-          <p:cNvPr id="20" name="Rectangle 19"/>
+          <p:cNvPr id="33" name="Rectangle 32"/>
           <p:cNvSpPr/>
           <p:nvPr/>
         </p:nvSpPr>
         <p:spPr>
           <a:xfrm>
-            <a:off x="10149840" y="1572768"/>
-            <a:ext cx="1828800" cy="987552"/>
+            <a:off x="274320" y="3410712"/>
+            <a:ext cx="384048" cy="237744"/>
+          </a:xfrm>
+          <a:prstGeom prst="rect">
+            <a:avLst/>
+          </a:prstGeom>
+          <a:solidFill>
+            <a:srgbClr val="C8102E"/>
+          </a:solidFill>
+          <a:ln>
+            <a:noFill/>
+          </a:ln>
+        </p:spPr>
+        <p:style>
+          <a:lnRef idx="1">
+            <a:schemeClr val="accent1"/>
+          </a:lnRef>
+          <a:fillRef idx="3">
+            <a:schemeClr val="accent1"/>
+          </a:fillRef>
+          <a:effectRef idx="2">
+            <a:schemeClr val="accent1"/>
+          </a:effectRef>
+          <a:fontRef idx="minor">
+            <a:schemeClr val="lt1"/>
+          </a:fontRef>
+        </p:style>
+        <p:txBody>
+          <a:bodyPr rtlCol="0" anchor="ctr"/>
+          <a:lstStyle/>
+          <a:p>
+            <a:pPr algn="ctr"/>
+          </a:p>
+        </p:txBody>
+      </p:sp>
+      <p:sp>
+        <p:nvSpPr>
+          <p:cNvPr id="34" name="TextBox 33"/>
+          <p:cNvSpPr txBox="1"/>
+          <p:nvPr/>
+        </p:nvSpPr>
+        <p:spPr>
+          <a:xfrm>
+            <a:off x="283464" y="3419856"/>
+            <a:ext cx="365760" cy="201168"/>
+          </a:xfrm>
+          <a:prstGeom prst="rect">
+            <a:avLst/>
+          </a:prstGeom>
+          <a:noFill/>
+        </p:spPr>
+        <p:txBody>
+          <a:bodyPr wrap="none">
+            <a:spAutoFit/>
+          </a:bodyPr>
+          <a:lstStyle/>
+          <a:p/>
+          <a:p>
+            <a:pPr algn="ctr">
+              <a:spcBef>
+                <a:spcPts val="0"/>
+              </a:spcBef>
+              <a:spcAft>
+                <a:spcPts val="0"/>
+              </a:spcAft>
+            </a:pPr>
+            <a:r>
+              <a:rPr sz="800" b="1">
+                <a:solidFill>
+                  <a:srgbClr val="FFFFFF"/>
+                </a:solidFill>
+                <a:latin typeface="Calibri"/>
+              </a:rPr>
+              <a:t>§1</a:t>
+            </a:r>
+          </a:p>
+        </p:txBody>
+      </p:sp>
+      <p:sp>
+        <p:nvSpPr>
+          <p:cNvPr id="35" name="TextBox 34"/>
+          <p:cNvSpPr txBox="1"/>
+          <p:nvPr/>
+        </p:nvSpPr>
+        <p:spPr>
+          <a:xfrm>
+            <a:off x="731520" y="3410712"/>
+            <a:ext cx="1645920" cy="256032"/>
+          </a:xfrm>
+          <a:prstGeom prst="rect">
+            <a:avLst/>
+          </a:prstGeom>
+          <a:noFill/>
+        </p:spPr>
+        <p:txBody>
+          <a:bodyPr wrap="none">
+            <a:spAutoFit/>
+          </a:bodyPr>
+          <a:lstStyle/>
+          <a:p/>
+          <a:p>
+            <a:pPr algn="l">
+              <a:spcBef>
+                <a:spcPts val="0"/>
+              </a:spcBef>
+              <a:spcAft>
+                <a:spcPts val="0"/>
+              </a:spcAft>
+            </a:pPr>
+            <a:r>
+              <a:rPr sz="1000" b="1">
+                <a:solidFill>
+                  <a:srgbClr val="1A1A1A"/>
+                </a:solidFill>
+                <a:latin typeface="Calibri"/>
+              </a:rPr>
+              <a:t>Response Time</a:t>
+            </a:r>
+          </a:p>
+        </p:txBody>
+      </p:sp>
+      <p:sp>
+        <p:nvSpPr>
+          <p:cNvPr id="36" name="TextBox 35"/>
+          <p:cNvSpPr txBox="1"/>
+          <p:nvPr/>
+        </p:nvSpPr>
+        <p:spPr>
+          <a:xfrm>
+            <a:off x="274320" y="3703320"/>
+            <a:ext cx="2103120" cy="1463040"/>
+          </a:xfrm>
+          <a:prstGeom prst="rect">
+            <a:avLst/>
+          </a:prstGeom>
+          <a:noFill/>
+        </p:spPr>
+        <p:txBody>
+          <a:bodyPr wrap="square">
+            <a:spAutoFit/>
+          </a:bodyPr>
+          <a:lstStyle/>
+          <a:p/>
+          <a:p>
+            <a:pPr algn="l">
+              <a:spcBef>
+                <a:spcPts val="0"/>
+              </a:spcBef>
+              <a:spcAft>
+                <a:spcPts val="0"/>
+              </a:spcAft>
+            </a:pPr>
+            <a:r>
+              <a:rPr sz="900" b="0">
+                <a:solidFill>
+                  <a:srgbClr val="1A1A1A"/>
+                </a:solidFill>
+                <a:latin typeface="Calibri"/>
+              </a:rPr>
+              <a:t>Avg days: Strauss outbound → first supplier reply</a:t>
+            </a:r>
+          </a:p>
+        </p:txBody>
+      </p:sp>
+      <p:sp>
+        <p:nvSpPr>
+          <p:cNvPr id="37" name="TextBox 36"/>
+          <p:cNvSpPr txBox="1"/>
+          <p:nvPr/>
+        </p:nvSpPr>
+        <p:spPr>
+          <a:xfrm>
+            <a:off x="274320" y="6263640"/>
+            <a:ext cx="2103120" cy="274320"/>
+          </a:xfrm>
+          <a:prstGeom prst="rect">
+            <a:avLst/>
+          </a:prstGeom>
+          <a:noFill/>
+        </p:spPr>
+        <p:txBody>
+          <a:bodyPr wrap="none">
+            <a:spAutoFit/>
+          </a:bodyPr>
+          <a:lstStyle/>
+          <a:p/>
+          <a:p>
+            <a:pPr algn="l">
+              <a:spcBef>
+                <a:spcPts val="0"/>
+              </a:spcBef>
+              <a:spcAft>
+                <a:spcPts val="0"/>
+              </a:spcAft>
+            </a:pPr>
+            <a:r>
+              <a:rPr sz="700" b="0">
+                <a:solidFill>
+                  <a:srgbClr val="555555"/>
+                </a:solidFill>
+                <a:latin typeface="Calibri"/>
+              </a:rPr>
+              <a:t>kpi_response_days</a:t>
+            </a:r>
+          </a:p>
+        </p:txBody>
+      </p:sp>
+      <p:sp>
+        <p:nvSpPr>
+          <p:cNvPr id="38" name="TextBox 37"/>
+          <p:cNvSpPr txBox="1"/>
+          <p:nvPr/>
+        </p:nvSpPr>
+        <p:spPr>
+          <a:xfrm>
+            <a:off x="274320" y="5212080"/>
+            <a:ext cx="2103120" cy="1005840"/>
+          </a:xfrm>
+          <a:prstGeom prst="rect">
+            <a:avLst/>
+          </a:prstGeom>
+          <a:noFill/>
+        </p:spPr>
+        <p:txBody>
+          <a:bodyPr wrap="square">
+            <a:spAutoFit/>
+          </a:bodyPr>
+          <a:lstStyle/>
+          <a:p/>
+          <a:p>
+            <a:pPr algn="l">
+              <a:spcBef>
+                <a:spcPts val="0"/>
+              </a:spcBef>
+              <a:spcAft>
+                <a:spcPts val="0"/>
+              </a:spcAft>
+            </a:pPr>
+            <a:r>
+              <a:rPr sz="800" b="0">
+                <a:solidFill>
+                  <a:srgbClr val="C8102E"/>
+                </a:solidFill>
+                <a:latin typeface="Calibri"/>
+              </a:rPr>
+              <a:t>Benchmark: &lt;5d healthy
+&gt;14d = relationship risk</a:t>
+            </a:r>
+            <a:br/>
+            <a:r>
+              <a:t>&gt;14d = relationship risk</a:t>
+            </a:r>
+          </a:p>
+        </p:txBody>
+      </p:sp>
+      <p:sp>
+        <p:nvSpPr>
+          <p:cNvPr id="39" name="Rectangle 38"/>
+          <p:cNvSpPr/>
+          <p:nvPr/>
+        </p:nvSpPr>
+        <p:spPr>
+          <a:xfrm>
+            <a:off x="2560320" y="3364992"/>
+            <a:ext cx="2286000" cy="3246120"/>
+          </a:xfrm>
+          <a:prstGeom prst="rect">
+            <a:avLst/>
+          </a:prstGeom>
+          <a:solidFill>
+            <a:srgbClr val="FFFFFF"/>
+          </a:solidFill>
+          <a:ln>
+            <a:solidFill>
+              <a:srgbClr val="DDDDDD"/>
+            </a:solidFill>
+          </a:ln>
+        </p:spPr>
+        <p:style>
+          <a:lnRef idx="1">
+            <a:schemeClr val="accent1"/>
+          </a:lnRef>
+          <a:fillRef idx="3">
+            <a:schemeClr val="accent1"/>
+          </a:fillRef>
+          <a:effectRef idx="2">
+            <a:schemeClr val="accent1"/>
+          </a:effectRef>
+          <a:fontRef idx="minor">
+            <a:schemeClr val="lt1"/>
+          </a:fontRef>
+        </p:style>
+        <p:txBody>
+          <a:bodyPr rtlCol="0" anchor="ctr"/>
+          <a:lstStyle/>
+          <a:p>
+            <a:pPr algn="ctr"/>
+          </a:p>
+        </p:txBody>
+      </p:sp>
+      <p:sp>
+        <p:nvSpPr>
+          <p:cNvPr id="40" name="Rectangle 39"/>
+          <p:cNvSpPr/>
+          <p:nvPr/>
+        </p:nvSpPr>
+        <p:spPr>
+          <a:xfrm>
+            <a:off x="2651760" y="3410712"/>
+            <a:ext cx="384048" cy="237744"/>
+          </a:xfrm>
+          <a:prstGeom prst="rect">
+            <a:avLst/>
+          </a:prstGeom>
+          <a:solidFill>
+            <a:srgbClr val="C8102E"/>
+          </a:solidFill>
+          <a:ln>
+            <a:noFill/>
+          </a:ln>
+        </p:spPr>
+        <p:style>
+          <a:lnRef idx="1">
+            <a:schemeClr val="accent1"/>
+          </a:lnRef>
+          <a:fillRef idx="3">
+            <a:schemeClr val="accent1"/>
+          </a:fillRef>
+          <a:effectRef idx="2">
+            <a:schemeClr val="accent1"/>
+          </a:effectRef>
+          <a:fontRef idx="minor">
+            <a:schemeClr val="lt1"/>
+          </a:fontRef>
+        </p:style>
+        <p:txBody>
+          <a:bodyPr rtlCol="0" anchor="ctr"/>
+          <a:lstStyle/>
+          <a:p>
+            <a:pPr algn="ctr"/>
+          </a:p>
+        </p:txBody>
+      </p:sp>
+      <p:sp>
+        <p:nvSpPr>
+          <p:cNvPr id="41" name="TextBox 40"/>
+          <p:cNvSpPr txBox="1"/>
+          <p:nvPr/>
+        </p:nvSpPr>
+        <p:spPr>
+          <a:xfrm>
+            <a:off x="2660904" y="3419856"/>
+            <a:ext cx="365760" cy="201168"/>
+          </a:xfrm>
+          <a:prstGeom prst="rect">
+            <a:avLst/>
+          </a:prstGeom>
+          <a:noFill/>
+        </p:spPr>
+        <p:txBody>
+          <a:bodyPr wrap="none">
+            <a:spAutoFit/>
+          </a:bodyPr>
+          <a:lstStyle/>
+          <a:p/>
+          <a:p>
+            <a:pPr algn="ctr">
+              <a:spcBef>
+                <a:spcPts val="0"/>
+              </a:spcBef>
+              <a:spcAft>
+                <a:spcPts val="0"/>
+              </a:spcAft>
+            </a:pPr>
+            <a:r>
+              <a:rPr sz="800" b="1">
+                <a:solidFill>
+                  <a:srgbClr val="FFFFFF"/>
+                </a:solidFill>
+                <a:latin typeface="Calibri"/>
+              </a:rPr>
+              <a:t>§2</a:t>
+            </a:r>
+          </a:p>
+        </p:txBody>
+      </p:sp>
+      <p:sp>
+        <p:nvSpPr>
+          <p:cNvPr id="42" name="TextBox 41"/>
+          <p:cNvSpPr txBox="1"/>
+          <p:nvPr/>
+        </p:nvSpPr>
+        <p:spPr>
+          <a:xfrm>
+            <a:off x="3108960" y="3410712"/>
+            <a:ext cx="1645920" cy="256032"/>
+          </a:xfrm>
+          <a:prstGeom prst="rect">
+            <a:avLst/>
+          </a:prstGeom>
+          <a:noFill/>
+        </p:spPr>
+        <p:txBody>
+          <a:bodyPr wrap="none">
+            <a:spAutoFit/>
+          </a:bodyPr>
+          <a:lstStyle/>
+          <a:p/>
+          <a:p>
+            <a:pPr algn="l">
+              <a:spcBef>
+                <a:spcPts val="0"/>
+              </a:spcBef>
+              <a:spcAft>
+                <a:spcPts val="0"/>
+              </a:spcAft>
+            </a:pPr>
+            <a:r>
+              <a:rPr sz="1000" b="1">
+                <a:solidFill>
+                  <a:srgbClr val="1A1A1A"/>
+                </a:solidFill>
+                <a:latin typeface="Calibri"/>
+              </a:rPr>
+              <a:t>Open Issues</a:t>
+            </a:r>
+          </a:p>
+        </p:txBody>
+      </p:sp>
+      <p:sp>
+        <p:nvSpPr>
+          <p:cNvPr id="43" name="TextBox 42"/>
+          <p:cNvSpPr txBox="1"/>
+          <p:nvPr/>
+        </p:nvSpPr>
+        <p:spPr>
+          <a:xfrm>
+            <a:off x="2651760" y="3703320"/>
+            <a:ext cx="2103120" cy="1463040"/>
+          </a:xfrm>
+          <a:prstGeom prst="rect">
+            <a:avLst/>
+          </a:prstGeom>
+          <a:noFill/>
+        </p:spPr>
+        <p:txBody>
+          <a:bodyPr wrap="square">
+            <a:spAutoFit/>
+          </a:bodyPr>
+          <a:lstStyle/>
+          <a:p/>
+          <a:p>
+            <a:pPr algn="l">
+              <a:spcBef>
+                <a:spcPts val="0"/>
+              </a:spcBef>
+              <a:spcAft>
+                <a:spcPts val="0"/>
+              </a:spcAft>
+            </a:pPr>
+            <a:r>
+              <a:rPr sz="900" b="0">
+                <a:solidFill>
+                  <a:srgbClr val="1A1A1A"/>
+                </a:solidFill>
+                <a:latin typeface="Calibri"/>
+              </a:rPr>
+              <a:t>Count of unresolved disputes, threads, contract gaps per supplier</a:t>
+            </a:r>
+          </a:p>
+        </p:txBody>
+      </p:sp>
+      <p:sp>
+        <p:nvSpPr>
+          <p:cNvPr id="44" name="TextBox 43"/>
+          <p:cNvSpPr txBox="1"/>
+          <p:nvPr/>
+        </p:nvSpPr>
+        <p:spPr>
+          <a:xfrm>
+            <a:off x="2651760" y="6263640"/>
+            <a:ext cx="2103120" cy="274320"/>
+          </a:xfrm>
+          <a:prstGeom prst="rect">
+            <a:avLst/>
+          </a:prstGeom>
+          <a:noFill/>
+        </p:spPr>
+        <p:txBody>
+          <a:bodyPr wrap="none">
+            <a:spAutoFit/>
+          </a:bodyPr>
+          <a:lstStyle/>
+          <a:p/>
+          <a:p>
+            <a:pPr algn="l">
+              <a:spcBef>
+                <a:spcPts val="0"/>
+              </a:spcBef>
+              <a:spcAft>
+                <a:spcPts val="0"/>
+              </a:spcAft>
+            </a:pPr>
+            <a:r>
+              <a:rPr sz="700" b="0">
+                <a:solidFill>
+                  <a:srgbClr val="555555"/>
+                </a:solidFill>
+                <a:latin typeface="Calibri"/>
+              </a:rPr>
+              <a:t>kpi_open_issues</a:t>
+            </a:r>
+          </a:p>
+        </p:txBody>
+      </p:sp>
+      <p:sp>
+        <p:nvSpPr>
+          <p:cNvPr id="45" name="TextBox 44"/>
+          <p:cNvSpPr txBox="1"/>
+          <p:nvPr/>
+        </p:nvSpPr>
+        <p:spPr>
+          <a:xfrm>
+            <a:off x="2651760" y="5212080"/>
+            <a:ext cx="2103120" cy="1005840"/>
+          </a:xfrm>
+          <a:prstGeom prst="rect">
+            <a:avLst/>
+          </a:prstGeom>
+          <a:noFill/>
+        </p:spPr>
+        <p:txBody>
+          <a:bodyPr wrap="square">
+            <a:spAutoFit/>
+          </a:bodyPr>
+          <a:lstStyle/>
+          <a:p/>
+          <a:p>
+            <a:pPr algn="l">
+              <a:spcBef>
+                <a:spcPts val="0"/>
+              </a:spcBef>
+              <a:spcAft>
+                <a:spcPts val="0"/>
+              </a:spcAft>
+            </a:pPr>
+            <a:r>
+              <a:rPr sz="800" b="0">
+                <a:solidFill>
+                  <a:srgbClr val="C8102E"/>
+                </a:solidFill>
+                <a:latin typeface="Calibri"/>
+              </a:rPr>
+              <a:t>Target: 0 open
+Each one costs prep time</a:t>
+            </a:r>
+            <a:br/>
+            <a:r>
+              <a:t>Each one costs prep time</a:t>
+            </a:r>
+          </a:p>
+        </p:txBody>
+      </p:sp>
+      <p:sp>
+        <p:nvSpPr>
+          <p:cNvPr id="46" name="Rectangle 45"/>
+          <p:cNvSpPr/>
+          <p:nvPr/>
+        </p:nvSpPr>
+        <p:spPr>
+          <a:xfrm>
+            <a:off x="4937760" y="3364992"/>
+            <a:ext cx="2286000" cy="3246120"/>
           </a:xfrm>
           <a:prstGeom prst="rect">
             <a:avLst/>
@@ -5804,14 +6928,14 @@
       </p:sp>
       <p:sp>
         <p:nvSpPr>
-          <p:cNvPr id="21" name="Rectangle 20"/>
+          <p:cNvPr id="47" name="Rectangle 46"/>
           <p:cNvSpPr/>
           <p:nvPr/>
         </p:nvSpPr>
         <p:spPr>
           <a:xfrm>
-            <a:off x="201168" y="1645920"/>
-            <a:ext cx="402336" cy="256032"/>
+            <a:off x="5029200" y="3410712"/>
+            <a:ext cx="384048" cy="237744"/>
           </a:xfrm>
           <a:prstGeom prst="rect">
             <a:avLst/>
@@ -5847,14 +6971,14 @@
       </p:sp>
       <p:sp>
         <p:nvSpPr>
-          <p:cNvPr id="22" name="TextBox 21"/>
-          <p:cNvSpPr txBox="1"/>
-          <p:nvPr/>
-        </p:nvSpPr>
-        <p:spPr>
-          <a:xfrm>
-            <a:off x="210312" y="1655064"/>
-            <a:ext cx="384048" cy="228600"/>
+          <p:cNvPr id="48" name="TextBox 47"/>
+          <p:cNvSpPr txBox="1"/>
+          <p:nvPr/>
+        </p:nvSpPr>
+        <p:spPr>
+          <a:xfrm>
+            <a:off x="5038344" y="3419856"/>
+            <a:ext cx="365760" cy="201168"/>
           </a:xfrm>
           <a:prstGeom prst="rect">
             <a:avLst/>
@@ -5877,27 +7001,70 @@
               </a:spcAft>
             </a:pPr>
             <a:r>
-              <a:rPr sz="900" b="1">
+              <a:rPr sz="800" b="1">
                 <a:solidFill>
                   <a:srgbClr val="FFFFFF"/>
                 </a:solidFill>
                 <a:latin typeface="Calibri"/>
               </a:rPr>
-              <a:t>§1</a:t>
-            </a:r>
-          </a:p>
-        </p:txBody>
-      </p:sp>
-      <p:sp>
-        <p:nvSpPr>
-          <p:cNvPr id="23" name="TextBox 22"/>
-          <p:cNvSpPr txBox="1"/>
-          <p:nvPr/>
-        </p:nvSpPr>
-        <p:spPr>
-          <a:xfrm>
-            <a:off x="210312" y="1956816"/>
-            <a:ext cx="402336" cy="502920"/>
+              <a:t>§3</a:t>
+            </a:r>
+          </a:p>
+        </p:txBody>
+      </p:sp>
+      <p:sp>
+        <p:nvSpPr>
+          <p:cNvPr id="49" name="TextBox 48"/>
+          <p:cNvSpPr txBox="1"/>
+          <p:nvPr/>
+        </p:nvSpPr>
+        <p:spPr>
+          <a:xfrm>
+            <a:off x="5486400" y="3410712"/>
+            <a:ext cx="1645920" cy="256032"/>
+          </a:xfrm>
+          <a:prstGeom prst="rect">
+            <a:avLst/>
+          </a:prstGeom>
+          <a:noFill/>
+        </p:spPr>
+        <p:txBody>
+          <a:bodyPr wrap="none">
+            <a:spAutoFit/>
+          </a:bodyPr>
+          <a:lstStyle/>
+          <a:p/>
+          <a:p>
+            <a:pPr algn="l">
+              <a:spcBef>
+                <a:spcPts val="0"/>
+              </a:spcBef>
+              <a:spcAft>
+                <a:spcPts val="0"/>
+              </a:spcAft>
+            </a:pPr>
+            <a:r>
+              <a:rPr sz="1000" b="1">
+                <a:solidFill>
+                  <a:srgbClr val="1A1A1A"/>
+                </a:solidFill>
+                <a:latin typeface="Calibri"/>
+              </a:rPr>
+              <a:t>Price Delta</a:t>
+            </a:r>
+          </a:p>
+        </p:txBody>
+      </p:sp>
+      <p:sp>
+        <p:nvSpPr>
+          <p:cNvPr id="50" name="TextBox 49"/>
+          <p:cNvSpPr txBox="1"/>
+          <p:nvPr/>
+        </p:nvSpPr>
+        <p:spPr>
+          <a:xfrm>
+            <a:off x="5029200" y="3703320"/>
+            <a:ext cx="2103120" cy="1463040"/>
           </a:xfrm>
           <a:prstGeom prst="rect">
             <a:avLst/>
@@ -5920,27 +7087,70 @@
               </a:spcAft>
             </a:pPr>
             <a:r>
-              <a:rPr sz="800" b="1">
-                <a:solidFill>
-                  <a:srgbClr val="1A1A1A"/>
-                </a:solidFill>
-                <a:latin typeface="Calibri"/>
-              </a:rPr>
-              <a:t>Supplier Response Time</a:t>
-            </a:r>
-          </a:p>
-        </p:txBody>
-      </p:sp>
-      <p:sp>
-        <p:nvSpPr>
-          <p:cNvPr id="24" name="TextBox 23"/>
-          <p:cNvSpPr txBox="1"/>
-          <p:nvPr/>
-        </p:nvSpPr>
-        <p:spPr>
-          <a:xfrm>
-            <a:off x="777240" y="1627632"/>
-            <a:ext cx="3977639" cy="868680"/>
+              <a:rPr sz="900" b="0">
+                <a:solidFill>
+                  <a:srgbClr val="1A1A1A"/>
+                </a:solidFill>
+                <a:latin typeface="Calibri"/>
+              </a:rPr>
+              <a:t>Latest email quote vs contract base price — % and absolute</a:t>
+            </a:r>
+          </a:p>
+        </p:txBody>
+      </p:sp>
+      <p:sp>
+        <p:nvSpPr>
+          <p:cNvPr id="51" name="TextBox 50"/>
+          <p:cNvSpPr txBox="1"/>
+          <p:nvPr/>
+        </p:nvSpPr>
+        <p:spPr>
+          <a:xfrm>
+            <a:off x="5029200" y="6263640"/>
+            <a:ext cx="2103120" cy="274320"/>
+          </a:xfrm>
+          <a:prstGeom prst="rect">
+            <a:avLst/>
+          </a:prstGeom>
+          <a:noFill/>
+        </p:spPr>
+        <p:txBody>
+          <a:bodyPr wrap="none">
+            <a:spAutoFit/>
+          </a:bodyPr>
+          <a:lstStyle/>
+          <a:p/>
+          <a:p>
+            <a:pPr algn="l">
+              <a:spcBef>
+                <a:spcPts val="0"/>
+              </a:spcBef>
+              <a:spcAft>
+                <a:spcPts val="0"/>
+              </a:spcAft>
+            </a:pPr>
+            <a:r>
+              <a:rPr sz="700" b="0">
+                <a:solidFill>
+                  <a:srgbClr val="555555"/>
+                </a:solidFill>
+                <a:latin typeface="Calibri"/>
+              </a:rPr>
+              <a:t>kpi_price_delta_pct</a:t>
+            </a:r>
+          </a:p>
+        </p:txBody>
+      </p:sp>
+      <p:sp>
+        <p:nvSpPr>
+          <p:cNvPr id="52" name="TextBox 51"/>
+          <p:cNvSpPr txBox="1"/>
+          <p:nvPr/>
+        </p:nvSpPr>
+        <p:spPr>
+          <a:xfrm>
+            <a:off x="5029200" y="5212080"/>
+            <a:ext cx="2103120" cy="1005840"/>
           </a:xfrm>
           <a:prstGeom prst="rect">
             <a:avLst/>
@@ -5963,156 +7173,32 @@
               </a:spcAft>
             </a:pPr>
             <a:r>
-              <a:rPr sz="900" b="0">
-                <a:solidFill>
-                  <a:srgbClr val="1A1A1A"/>
-                </a:solidFill>
-                <a:latin typeface="Calibri"/>
-              </a:rPr>
-              <a:t>Avg calendar days between each Strauss outbound email and the first supplier reply, across the 6-month window.</a:t>
-            </a:r>
-          </a:p>
-        </p:txBody>
-      </p:sp>
-      <p:sp>
-        <p:nvSpPr>
-          <p:cNvPr id="25" name="TextBox 24"/>
-          <p:cNvSpPr txBox="1"/>
-          <p:nvPr/>
-        </p:nvSpPr>
-        <p:spPr>
-          <a:xfrm>
-            <a:off x="4983480" y="1627632"/>
-            <a:ext cx="3108960" cy="868680"/>
-          </a:xfrm>
-          <a:prstGeom prst="rect">
-            <a:avLst/>
-          </a:prstGeom>
-          <a:noFill/>
-        </p:spPr>
-        <p:txBody>
-          <a:bodyPr wrap="square">
-            <a:spAutoFit/>
-          </a:bodyPr>
-          <a:lstStyle/>
-          <a:p/>
-          <a:p>
-            <a:pPr algn="l">
-              <a:spcBef>
-                <a:spcPts val="0"/>
-              </a:spcBef>
-              <a:spcAft>
-                <a:spcPts val="0"/>
-              </a:spcAft>
-            </a:pPr>
-            <a:r>
-              <a:rPr sz="900" b="0">
-                <a:solidFill>
-                  <a:srgbClr val="1A1A1A"/>
-                </a:solidFill>
-                <a:latin typeface="Calibri"/>
-              </a:rPr>
-              <a:t>Computed locally from email date fields. No API call needed. Pairs matched chronologically per thread.</a:t>
-            </a:r>
-          </a:p>
-        </p:txBody>
-      </p:sp>
-      <p:sp>
-        <p:nvSpPr>
-          <p:cNvPr id="26" name="TextBox 25"/>
-          <p:cNvSpPr txBox="1"/>
-          <p:nvPr/>
-        </p:nvSpPr>
-        <p:spPr>
-          <a:xfrm>
-            <a:off x="8275320" y="1627632"/>
-            <a:ext cx="1737360" cy="868680"/>
-          </a:xfrm>
-          <a:prstGeom prst="rect">
-            <a:avLst/>
-          </a:prstGeom>
-          <a:noFill/>
-        </p:spPr>
-        <p:txBody>
-          <a:bodyPr wrap="square">
-            <a:spAutoFit/>
-          </a:bodyPr>
-          <a:lstStyle/>
-          <a:p/>
-          <a:p>
-            <a:pPr algn="l">
-              <a:spcBef>
-                <a:spcPts val="0"/>
-              </a:spcBef>
-              <a:spcAft>
-                <a:spcPts val="0"/>
-              </a:spcAft>
-            </a:pPr>
-            <a:r>
-              <a:rPr sz="900" b="0">
-                <a:solidFill>
-                  <a:srgbClr val="1A1A1A"/>
-                </a:solidFill>
-                <a:latin typeface="Calibri"/>
-              </a:rPr>
-              <a:t>Galil Dairy: 11.2d avg</a:t>
-            </a:r>
-          </a:p>
-        </p:txBody>
-      </p:sp>
-      <p:sp>
-        <p:nvSpPr>
-          <p:cNvPr id="27" name="TextBox 26"/>
-          <p:cNvSpPr txBox="1"/>
-          <p:nvPr/>
-        </p:nvSpPr>
-        <p:spPr>
-          <a:xfrm>
-            <a:off x="10195560" y="1627632"/>
-            <a:ext cx="1737360" cy="868680"/>
-          </a:xfrm>
-          <a:prstGeom prst="rect">
-            <a:avLst/>
-          </a:prstGeom>
-          <a:noFill/>
-        </p:spPr>
-        <p:txBody>
-          <a:bodyPr wrap="square">
-            <a:spAutoFit/>
-          </a:bodyPr>
-          <a:lstStyle/>
-          <a:p/>
-          <a:p>
-            <a:pPr algn="l">
-              <a:spcBef>
-                <a:spcPts val="0"/>
-              </a:spcBef>
-              <a:spcAft>
-                <a:spcPts val="0"/>
-              </a:spcAft>
-            </a:pPr>
-            <a:r>
-              <a:rPr sz="900" b="0">
-                <a:solidFill>
-                  <a:srgbClr val="555555"/>
-                </a:solidFill>
-                <a:latin typeface="Calibri"/>
-              </a:rPr>
-              <a:t>kpi_response_days stored per packet. Trend visible in per-supplier breakdown.</a:t>
-            </a:r>
-          </a:p>
-        </p:txBody>
-      </p:sp>
-      <p:sp>
-        <p:nvSpPr>
-          <p:cNvPr id="28" name="Rectangle 27"/>
+              <a:rPr sz="800" b="0">
+                <a:solidFill>
+                  <a:srgbClr val="C8102E"/>
+                </a:solidFill>
+                <a:latin typeface="Calibri"/>
+              </a:rPr>
+              <a:t>Alert if &gt;0%
+without written amendment</a:t>
+            </a:r>
+            <a:br/>
+            <a:r>
+              <a:t>without written amendment</a:t>
+            </a:r>
+          </a:p>
+        </p:txBody>
+      </p:sp>
+      <p:sp>
+        <p:nvSpPr>
+          <p:cNvPr id="53" name="Rectangle 52"/>
           <p:cNvSpPr/>
           <p:nvPr/>
         </p:nvSpPr>
         <p:spPr>
           <a:xfrm>
-            <a:off x="182880" y="2606039"/>
-            <a:ext cx="457200" cy="987552"/>
+            <a:off x="7315200" y="3364992"/>
+            <a:ext cx="2286000" cy="3246120"/>
           </a:xfrm>
           <a:prstGeom prst="rect">
             <a:avLst/>
@@ -6150,194 +7236,14 @@
       </p:sp>
       <p:sp>
         <p:nvSpPr>
-          <p:cNvPr id="29" name="Rectangle 28"/>
+          <p:cNvPr id="54" name="Rectangle 53"/>
           <p:cNvSpPr/>
           <p:nvPr/>
         </p:nvSpPr>
         <p:spPr>
           <a:xfrm>
-            <a:off x="731520" y="2606039"/>
-            <a:ext cx="4114800" cy="987552"/>
-          </a:xfrm>
-          <a:prstGeom prst="rect">
-            <a:avLst/>
-          </a:prstGeom>
-          <a:solidFill>
-            <a:srgbClr val="FFFFFF"/>
-          </a:solidFill>
-          <a:ln>
-            <a:solidFill>
-              <a:srgbClr val="DDDDDD"/>
-            </a:solidFill>
-          </a:ln>
-        </p:spPr>
-        <p:style>
-          <a:lnRef idx="1">
-            <a:schemeClr val="accent1"/>
-          </a:lnRef>
-          <a:fillRef idx="3">
-            <a:schemeClr val="accent1"/>
-          </a:fillRef>
-          <a:effectRef idx="2">
-            <a:schemeClr val="accent1"/>
-          </a:effectRef>
-          <a:fontRef idx="minor">
-            <a:schemeClr val="lt1"/>
-          </a:fontRef>
-        </p:style>
-        <p:txBody>
-          <a:bodyPr rtlCol="0" anchor="ctr"/>
-          <a:lstStyle/>
-          <a:p>
-            <a:pPr algn="ctr"/>
-          </a:p>
-        </p:txBody>
-      </p:sp>
-      <p:sp>
-        <p:nvSpPr>
-          <p:cNvPr id="30" name="Rectangle 29"/>
-          <p:cNvSpPr/>
-          <p:nvPr/>
-        </p:nvSpPr>
-        <p:spPr>
-          <a:xfrm>
-            <a:off x="4937760" y="2606039"/>
-            <a:ext cx="3200400" cy="987552"/>
-          </a:xfrm>
-          <a:prstGeom prst="rect">
-            <a:avLst/>
-          </a:prstGeom>
-          <a:solidFill>
-            <a:srgbClr val="FFFFFF"/>
-          </a:solidFill>
-          <a:ln>
-            <a:solidFill>
-              <a:srgbClr val="DDDDDD"/>
-            </a:solidFill>
-          </a:ln>
-        </p:spPr>
-        <p:style>
-          <a:lnRef idx="1">
-            <a:schemeClr val="accent1"/>
-          </a:lnRef>
-          <a:fillRef idx="3">
-            <a:schemeClr val="accent1"/>
-          </a:fillRef>
-          <a:effectRef idx="2">
-            <a:schemeClr val="accent1"/>
-          </a:effectRef>
-          <a:fontRef idx="minor">
-            <a:schemeClr val="lt1"/>
-          </a:fontRef>
-        </p:style>
-        <p:txBody>
-          <a:bodyPr rtlCol="0" anchor="ctr"/>
-          <a:lstStyle/>
-          <a:p>
-            <a:pPr algn="ctr"/>
-          </a:p>
-        </p:txBody>
-      </p:sp>
-      <p:sp>
-        <p:nvSpPr>
-          <p:cNvPr id="31" name="Rectangle 30"/>
-          <p:cNvSpPr/>
-          <p:nvPr/>
-        </p:nvSpPr>
-        <p:spPr>
-          <a:xfrm>
-            <a:off x="8229600" y="2606039"/>
-            <a:ext cx="1828800" cy="987552"/>
-          </a:xfrm>
-          <a:prstGeom prst="rect">
-            <a:avLst/>
-          </a:prstGeom>
-          <a:solidFill>
-            <a:srgbClr val="FFFFFF"/>
-          </a:solidFill>
-          <a:ln>
-            <a:solidFill>
-              <a:srgbClr val="DDDDDD"/>
-            </a:solidFill>
-          </a:ln>
-        </p:spPr>
-        <p:style>
-          <a:lnRef idx="1">
-            <a:schemeClr val="accent1"/>
-          </a:lnRef>
-          <a:fillRef idx="3">
-            <a:schemeClr val="accent1"/>
-          </a:fillRef>
-          <a:effectRef idx="2">
-            <a:schemeClr val="accent1"/>
-          </a:effectRef>
-          <a:fontRef idx="minor">
-            <a:schemeClr val="lt1"/>
-          </a:fontRef>
-        </p:style>
-        <p:txBody>
-          <a:bodyPr rtlCol="0" anchor="ctr"/>
-          <a:lstStyle/>
-          <a:p>
-            <a:pPr algn="ctr"/>
-          </a:p>
-        </p:txBody>
-      </p:sp>
-      <p:sp>
-        <p:nvSpPr>
-          <p:cNvPr id="32" name="Rectangle 31"/>
-          <p:cNvSpPr/>
-          <p:nvPr/>
-        </p:nvSpPr>
-        <p:spPr>
-          <a:xfrm>
-            <a:off x="10149840" y="2606039"/>
-            <a:ext cx="1828800" cy="987552"/>
-          </a:xfrm>
-          <a:prstGeom prst="rect">
-            <a:avLst/>
-          </a:prstGeom>
-          <a:solidFill>
-            <a:srgbClr val="FFFFFF"/>
-          </a:solidFill>
-          <a:ln>
-            <a:solidFill>
-              <a:srgbClr val="DDDDDD"/>
-            </a:solidFill>
-          </a:ln>
-        </p:spPr>
-        <p:style>
-          <a:lnRef idx="1">
-            <a:schemeClr val="accent1"/>
-          </a:lnRef>
-          <a:fillRef idx="3">
-            <a:schemeClr val="accent1"/>
-          </a:fillRef>
-          <a:effectRef idx="2">
-            <a:schemeClr val="accent1"/>
-          </a:effectRef>
-          <a:fontRef idx="minor">
-            <a:schemeClr val="lt1"/>
-          </a:fontRef>
-        </p:style>
-        <p:txBody>
-          <a:bodyPr rtlCol="0" anchor="ctr"/>
-          <a:lstStyle/>
-          <a:p>
-            <a:pPr algn="ctr"/>
-          </a:p>
-        </p:txBody>
-      </p:sp>
-      <p:sp>
-        <p:nvSpPr>
-          <p:cNvPr id="33" name="Rectangle 32"/>
-          <p:cNvSpPr/>
-          <p:nvPr/>
-        </p:nvSpPr>
-        <p:spPr>
-          <a:xfrm>
-            <a:off x="201168" y="2679191"/>
-            <a:ext cx="402336" cy="256032"/>
+            <a:off x="7406640" y="3410712"/>
+            <a:ext cx="384048" cy="237744"/>
           </a:xfrm>
           <a:prstGeom prst="rect">
             <a:avLst/>
@@ -6373,14 +7279,14 @@
       </p:sp>
       <p:sp>
         <p:nvSpPr>
-          <p:cNvPr id="34" name="TextBox 33"/>
-          <p:cNvSpPr txBox="1"/>
-          <p:nvPr/>
-        </p:nvSpPr>
-        <p:spPr>
-          <a:xfrm>
-            <a:off x="210312" y="2688335"/>
-            <a:ext cx="384048" cy="228600"/>
+          <p:cNvPr id="55" name="TextBox 54"/>
+          <p:cNvSpPr txBox="1"/>
+          <p:nvPr/>
+        </p:nvSpPr>
+        <p:spPr>
+          <a:xfrm>
+            <a:off x="7415783" y="3419856"/>
+            <a:ext cx="365760" cy="201168"/>
           </a:xfrm>
           <a:prstGeom prst="rect">
             <a:avLst/>
@@ -6403,27 +7309,70 @@
               </a:spcAft>
             </a:pPr>
             <a:r>
-              <a:rPr sz="900" b="1">
+              <a:rPr sz="800" b="1">
                 <a:solidFill>
                   <a:srgbClr val="FFFFFF"/>
                 </a:solidFill>
                 <a:latin typeface="Calibri"/>
               </a:rPr>
-              <a:t>§2</a:t>
-            </a:r>
-          </a:p>
-        </p:txBody>
-      </p:sp>
-      <p:sp>
-        <p:nvSpPr>
-          <p:cNvPr id="35" name="TextBox 34"/>
-          <p:cNvSpPr txBox="1"/>
-          <p:nvPr/>
-        </p:nvSpPr>
-        <p:spPr>
-          <a:xfrm>
-            <a:off x="210312" y="2990087"/>
-            <a:ext cx="402336" cy="502920"/>
+              <a:t>§4</a:t>
+            </a:r>
+          </a:p>
+        </p:txBody>
+      </p:sp>
+      <p:sp>
+        <p:nvSpPr>
+          <p:cNvPr id="56" name="TextBox 55"/>
+          <p:cNvSpPr txBox="1"/>
+          <p:nvPr/>
+        </p:nvSpPr>
+        <p:spPr>
+          <a:xfrm>
+            <a:off x="7863840" y="3410712"/>
+            <a:ext cx="1645920" cy="256032"/>
+          </a:xfrm>
+          <a:prstGeom prst="rect">
+            <a:avLst/>
+          </a:prstGeom>
+          <a:noFill/>
+        </p:spPr>
+        <p:txBody>
+          <a:bodyPr wrap="none">
+            <a:spAutoFit/>
+          </a:bodyPr>
+          <a:lstStyle/>
+          <a:p/>
+          <a:p>
+            <a:pPr algn="l">
+              <a:spcBef>
+                <a:spcPts val="0"/>
+              </a:spcBef>
+              <a:spcAft>
+                <a:spcPts val="0"/>
+              </a:spcAft>
+            </a:pPr>
+            <a:r>
+              <a:rPr sz="1000" b="1">
+                <a:solidFill>
+                  <a:srgbClr val="1A1A1A"/>
+                </a:solidFill>
+                <a:latin typeface="Calibri"/>
+              </a:rPr>
+              <a:t>Days to Renewal</a:t>
+            </a:r>
+          </a:p>
+        </p:txBody>
+      </p:sp>
+      <p:sp>
+        <p:nvSpPr>
+          <p:cNvPr id="57" name="TextBox 56"/>
+          <p:cNvSpPr txBox="1"/>
+          <p:nvPr/>
+        </p:nvSpPr>
+        <p:spPr>
+          <a:xfrm>
+            <a:off x="7406640" y="3703320"/>
+            <a:ext cx="2103120" cy="1463040"/>
           </a:xfrm>
           <a:prstGeom prst="rect">
             <a:avLst/>
@@ -6446,27 +7395,70 @@
               </a:spcAft>
             </a:pPr>
             <a:r>
-              <a:rPr sz="800" b="1">
-                <a:solidFill>
-                  <a:srgbClr val="1A1A1A"/>
-                </a:solidFill>
-                <a:latin typeface="Calibri"/>
-              </a:rPr>
-              <a:t>Open Issues Count</a:t>
-            </a:r>
-          </a:p>
-        </p:txBody>
-      </p:sp>
-      <p:sp>
-        <p:nvSpPr>
-          <p:cNvPr id="36" name="TextBox 35"/>
-          <p:cNvSpPr txBox="1"/>
-          <p:nvPr/>
-        </p:nvSpPr>
-        <p:spPr>
-          <a:xfrm>
-            <a:off x="777240" y="2660903"/>
-            <a:ext cx="3977639" cy="868680"/>
+              <a:rPr sz="900" b="0">
+                <a:solidFill>
+                  <a:srgbClr val="1A1A1A"/>
+                </a:solidFill>
+                <a:latin typeface="Calibri"/>
+              </a:rPr>
+              <a:t>Calendar days to contract renewal date; red &lt;30d</a:t>
+            </a:r>
+          </a:p>
+        </p:txBody>
+      </p:sp>
+      <p:sp>
+        <p:nvSpPr>
+          <p:cNvPr id="58" name="TextBox 57"/>
+          <p:cNvSpPr txBox="1"/>
+          <p:nvPr/>
+        </p:nvSpPr>
+        <p:spPr>
+          <a:xfrm>
+            <a:off x="7406640" y="6263640"/>
+            <a:ext cx="2103120" cy="274320"/>
+          </a:xfrm>
+          <a:prstGeom prst="rect">
+            <a:avLst/>
+          </a:prstGeom>
+          <a:noFill/>
+        </p:spPr>
+        <p:txBody>
+          <a:bodyPr wrap="none">
+            <a:spAutoFit/>
+          </a:bodyPr>
+          <a:lstStyle/>
+          <a:p/>
+          <a:p>
+            <a:pPr algn="l">
+              <a:spcBef>
+                <a:spcPts val="0"/>
+              </a:spcBef>
+              <a:spcAft>
+                <a:spcPts val="0"/>
+              </a:spcAft>
+            </a:pPr>
+            <a:r>
+              <a:rPr sz="700" b="0">
+                <a:solidFill>
+                  <a:srgbClr val="555555"/>
+                </a:solidFill>
+                <a:latin typeface="Calibri"/>
+              </a:rPr>
+              <a:t>kpi_days_to_renewal</a:t>
+            </a:r>
+          </a:p>
+        </p:txBody>
+      </p:sp>
+      <p:sp>
+        <p:nvSpPr>
+          <p:cNvPr id="59" name="TextBox 58"/>
+          <p:cNvSpPr txBox="1"/>
+          <p:nvPr/>
+        </p:nvSpPr>
+        <p:spPr>
+          <a:xfrm>
+            <a:off x="7406640" y="5212080"/>
+            <a:ext cx="2103120" cy="1005840"/>
           </a:xfrm>
           <a:prstGeom prst="rect">
             <a:avLst/>
@@ -6489,156 +7481,32 @@
               </a:spcAft>
             </a:pPr>
             <a:r>
-              <a:rPr sz="900" b="0">
-                <a:solidFill>
-                  <a:srgbClr val="1A1A1A"/>
-                </a:solidFill>
-                <a:latin typeface="Calibri"/>
-              </a:rPr>
-              <a:t>Number of distinct unresolved threads or flagged items per supplier as of the most recent email date.</a:t>
-            </a:r>
-          </a:p>
-        </p:txBody>
-      </p:sp>
-      <p:sp>
-        <p:nvSpPr>
-          <p:cNvPr id="37" name="TextBox 36"/>
-          <p:cNvSpPr txBox="1"/>
-          <p:nvPr/>
-        </p:nvSpPr>
-        <p:spPr>
-          <a:xfrm>
-            <a:off x="4983480" y="2660903"/>
-            <a:ext cx="3108960" cy="868680"/>
-          </a:xfrm>
-          <a:prstGeom prst="rect">
-            <a:avLst/>
-          </a:prstGeom>
-          <a:noFill/>
-        </p:spPr>
-        <p:txBody>
-          <a:bodyPr wrap="square">
-            <a:spAutoFit/>
-          </a:bodyPr>
-          <a:lstStyle/>
-          <a:p/>
-          <a:p>
-            <a:pPr algn="l">
-              <a:spcBef>
-                <a:spcPts val="0"/>
-              </a:spcBef>
-              <a:spcAft>
-                <a:spcPts val="0"/>
-              </a:spcAft>
-            </a:pPr>
-            <a:r>
-              <a:rPr sz="900" b="0">
-                <a:solidFill>
-                  <a:srgbClr val="1A1A1A"/>
-                </a:solidFill>
-                <a:latin typeface="Calibri"/>
-              </a:rPr>
-              <a:t>Claude API extraction pass. Each issue has type, description, source_ref, and status=open.</a:t>
-            </a:r>
-          </a:p>
-        </p:txBody>
-      </p:sp>
-      <p:sp>
-        <p:nvSpPr>
-          <p:cNvPr id="38" name="TextBox 37"/>
-          <p:cNvSpPr txBox="1"/>
-          <p:nvPr/>
-        </p:nvSpPr>
-        <p:spPr>
-          <a:xfrm>
-            <a:off x="8275320" y="2660903"/>
-            <a:ext cx="1737360" cy="868680"/>
-          </a:xfrm>
-          <a:prstGeom prst="rect">
-            <a:avLst/>
-          </a:prstGeom>
-          <a:noFill/>
-        </p:spPr>
-        <p:txBody>
-          <a:bodyPr wrap="square">
-            <a:spAutoFit/>
-          </a:bodyPr>
-          <a:lstStyle/>
-          <a:p/>
-          <a:p>
-            <a:pPr algn="l">
-              <a:spcBef>
-                <a:spcPts val="0"/>
-              </a:spcBef>
-              <a:spcAft>
-                <a:spcPts val="0"/>
-              </a:spcAft>
-            </a:pPr>
-            <a:r>
-              <a:rPr sz="900" b="0">
-                <a:solidFill>
-                  <a:srgbClr val="1A1A1A"/>
-                </a:solidFill>
-                <a:latin typeface="Calibri"/>
-              </a:rPr>
-              <a:t>Galil: 2 open (price discrepancy + unanswered thread)</a:t>
-            </a:r>
-          </a:p>
-        </p:txBody>
-      </p:sp>
-      <p:sp>
-        <p:nvSpPr>
-          <p:cNvPr id="39" name="TextBox 38"/>
-          <p:cNvSpPr txBox="1"/>
-          <p:nvPr/>
-        </p:nvSpPr>
-        <p:spPr>
-          <a:xfrm>
-            <a:off x="10195560" y="2660903"/>
-            <a:ext cx="1737360" cy="868680"/>
-          </a:xfrm>
-          <a:prstGeom prst="rect">
-            <a:avLst/>
-          </a:prstGeom>
-          <a:noFill/>
-        </p:spPr>
-        <p:txBody>
-          <a:bodyPr wrap="square">
-            <a:spAutoFit/>
-          </a:bodyPr>
-          <a:lstStyle/>
-          <a:p/>
-          <a:p>
-            <a:pPr algn="l">
-              <a:spcBef>
-                <a:spcPts val="0"/>
-              </a:spcBef>
-              <a:spcAft>
-                <a:spcPts val="0"/>
-              </a:spcAft>
-            </a:pPr>
-            <a:r>
-              <a:rPr sz="900" b="0">
-                <a:solidFill>
-                  <a:srgbClr val="555555"/>
-                </a:solidFill>
-                <a:latin typeface="Calibri"/>
-              </a:rPr>
-              <a:t>kpi_open_issues stored per packet. Avg across all packets shown in KPI tile.</a:t>
-            </a:r>
-          </a:p>
-        </p:txBody>
-      </p:sp>
-      <p:sp>
-        <p:nvSpPr>
-          <p:cNvPr id="40" name="Rectangle 39"/>
+              <a:rPr sz="800" b="0">
+                <a:solidFill>
+                  <a:srgbClr val="C8102E"/>
+                </a:solidFill>
+                <a:latin typeface="Calibri"/>
+              </a:rPr>
+              <a:t>Red &lt;30d, amber 30-90d
+auto-renewal notice shown</a:t>
+            </a:r>
+            <a:br/>
+            <a:r>
+              <a:t>auto-renewal notice shown</a:t>
+            </a:r>
+          </a:p>
+        </p:txBody>
+      </p:sp>
+      <p:sp>
+        <p:nvSpPr>
+          <p:cNvPr id="60" name="Rectangle 59"/>
           <p:cNvSpPr/>
           <p:nvPr/>
         </p:nvSpPr>
         <p:spPr>
           <a:xfrm>
-            <a:off x="182880" y="3639311"/>
-            <a:ext cx="457200" cy="987552"/>
+            <a:off x="9692640" y="3364992"/>
+            <a:ext cx="2286000" cy="3246120"/>
           </a:xfrm>
           <a:prstGeom prst="rect">
             <a:avLst/>
@@ -6676,194 +7544,14 @@
       </p:sp>
       <p:sp>
         <p:nvSpPr>
-          <p:cNvPr id="41" name="Rectangle 40"/>
+          <p:cNvPr id="61" name="Rectangle 60"/>
           <p:cNvSpPr/>
           <p:nvPr/>
         </p:nvSpPr>
         <p:spPr>
           <a:xfrm>
-            <a:off x="731520" y="3639311"/>
-            <a:ext cx="4114800" cy="987552"/>
-          </a:xfrm>
-          <a:prstGeom prst="rect">
-            <a:avLst/>
-          </a:prstGeom>
-          <a:solidFill>
-            <a:srgbClr val="F0F0F0"/>
-          </a:solidFill>
-          <a:ln>
-            <a:solidFill>
-              <a:srgbClr val="DDDDDD"/>
-            </a:solidFill>
-          </a:ln>
-        </p:spPr>
-        <p:style>
-          <a:lnRef idx="1">
-            <a:schemeClr val="accent1"/>
-          </a:lnRef>
-          <a:fillRef idx="3">
-            <a:schemeClr val="accent1"/>
-          </a:fillRef>
-          <a:effectRef idx="2">
-            <a:schemeClr val="accent1"/>
-          </a:effectRef>
-          <a:fontRef idx="minor">
-            <a:schemeClr val="lt1"/>
-          </a:fontRef>
-        </p:style>
-        <p:txBody>
-          <a:bodyPr rtlCol="0" anchor="ctr"/>
-          <a:lstStyle/>
-          <a:p>
-            <a:pPr algn="ctr"/>
-          </a:p>
-        </p:txBody>
-      </p:sp>
-      <p:sp>
-        <p:nvSpPr>
-          <p:cNvPr id="42" name="Rectangle 41"/>
-          <p:cNvSpPr/>
-          <p:nvPr/>
-        </p:nvSpPr>
-        <p:spPr>
-          <a:xfrm>
-            <a:off x="4937760" y="3639311"/>
-            <a:ext cx="3200400" cy="987552"/>
-          </a:xfrm>
-          <a:prstGeom prst="rect">
-            <a:avLst/>
-          </a:prstGeom>
-          <a:solidFill>
-            <a:srgbClr val="F0F0F0"/>
-          </a:solidFill>
-          <a:ln>
-            <a:solidFill>
-              <a:srgbClr val="DDDDDD"/>
-            </a:solidFill>
-          </a:ln>
-        </p:spPr>
-        <p:style>
-          <a:lnRef idx="1">
-            <a:schemeClr val="accent1"/>
-          </a:lnRef>
-          <a:fillRef idx="3">
-            <a:schemeClr val="accent1"/>
-          </a:fillRef>
-          <a:effectRef idx="2">
-            <a:schemeClr val="accent1"/>
-          </a:effectRef>
-          <a:fontRef idx="minor">
-            <a:schemeClr val="lt1"/>
-          </a:fontRef>
-        </p:style>
-        <p:txBody>
-          <a:bodyPr rtlCol="0" anchor="ctr"/>
-          <a:lstStyle/>
-          <a:p>
-            <a:pPr algn="ctr"/>
-          </a:p>
-        </p:txBody>
-      </p:sp>
-      <p:sp>
-        <p:nvSpPr>
-          <p:cNvPr id="43" name="Rectangle 42"/>
-          <p:cNvSpPr/>
-          <p:nvPr/>
-        </p:nvSpPr>
-        <p:spPr>
-          <a:xfrm>
-            <a:off x="8229600" y="3639311"/>
-            <a:ext cx="1828800" cy="987552"/>
-          </a:xfrm>
-          <a:prstGeom prst="rect">
-            <a:avLst/>
-          </a:prstGeom>
-          <a:solidFill>
-            <a:srgbClr val="F0F0F0"/>
-          </a:solidFill>
-          <a:ln>
-            <a:solidFill>
-              <a:srgbClr val="DDDDDD"/>
-            </a:solidFill>
-          </a:ln>
-        </p:spPr>
-        <p:style>
-          <a:lnRef idx="1">
-            <a:schemeClr val="accent1"/>
-          </a:lnRef>
-          <a:fillRef idx="3">
-            <a:schemeClr val="accent1"/>
-          </a:fillRef>
-          <a:effectRef idx="2">
-            <a:schemeClr val="accent1"/>
-          </a:effectRef>
-          <a:fontRef idx="minor">
-            <a:schemeClr val="lt1"/>
-          </a:fontRef>
-        </p:style>
-        <p:txBody>
-          <a:bodyPr rtlCol="0" anchor="ctr"/>
-          <a:lstStyle/>
-          <a:p>
-            <a:pPr algn="ctr"/>
-          </a:p>
-        </p:txBody>
-      </p:sp>
-      <p:sp>
-        <p:nvSpPr>
-          <p:cNvPr id="44" name="Rectangle 43"/>
-          <p:cNvSpPr/>
-          <p:nvPr/>
-        </p:nvSpPr>
-        <p:spPr>
-          <a:xfrm>
-            <a:off x="10149840" y="3639311"/>
-            <a:ext cx="1828800" cy="987552"/>
-          </a:xfrm>
-          <a:prstGeom prst="rect">
-            <a:avLst/>
-          </a:prstGeom>
-          <a:solidFill>
-            <a:srgbClr val="F0F0F0"/>
-          </a:solidFill>
-          <a:ln>
-            <a:solidFill>
-              <a:srgbClr val="DDDDDD"/>
-            </a:solidFill>
-          </a:ln>
-        </p:spPr>
-        <p:style>
-          <a:lnRef idx="1">
-            <a:schemeClr val="accent1"/>
-          </a:lnRef>
-          <a:fillRef idx="3">
-            <a:schemeClr val="accent1"/>
-          </a:fillRef>
-          <a:effectRef idx="2">
-            <a:schemeClr val="accent1"/>
-          </a:effectRef>
-          <a:fontRef idx="minor">
-            <a:schemeClr val="lt1"/>
-          </a:fontRef>
-        </p:style>
-        <p:txBody>
-          <a:bodyPr rtlCol="0" anchor="ctr"/>
-          <a:lstStyle/>
-          <a:p>
-            <a:pPr algn="ctr"/>
-          </a:p>
-        </p:txBody>
-      </p:sp>
-      <p:sp>
-        <p:nvSpPr>
-          <p:cNvPr id="45" name="Rectangle 44"/>
-          <p:cNvSpPr/>
-          <p:nvPr/>
-        </p:nvSpPr>
-        <p:spPr>
-          <a:xfrm>
-            <a:off x="201168" y="3712463"/>
-            <a:ext cx="402336" cy="256032"/>
+            <a:off x="9784080" y="3410712"/>
+            <a:ext cx="384048" cy="237744"/>
           </a:xfrm>
           <a:prstGeom prst="rect">
             <a:avLst/>
@@ -6899,14 +7587,14 @@
       </p:sp>
       <p:sp>
         <p:nvSpPr>
-          <p:cNvPr id="46" name="TextBox 45"/>
-          <p:cNvSpPr txBox="1"/>
-          <p:nvPr/>
-        </p:nvSpPr>
-        <p:spPr>
-          <a:xfrm>
-            <a:off x="210312" y="3721607"/>
-            <a:ext cx="384048" cy="228600"/>
+          <p:cNvPr id="62" name="TextBox 61"/>
+          <p:cNvSpPr txBox="1"/>
+          <p:nvPr/>
+        </p:nvSpPr>
+        <p:spPr>
+          <a:xfrm>
+            <a:off x="9793224" y="3419856"/>
+            <a:ext cx="365760" cy="201168"/>
           </a:xfrm>
           <a:prstGeom prst="rect">
             <a:avLst/>
@@ -6929,27 +7617,70 @@
               </a:spcAft>
             </a:pPr>
             <a:r>
-              <a:rPr sz="900" b="1">
+              <a:rPr sz="800" b="1">
                 <a:solidFill>
                   <a:srgbClr val="FFFFFF"/>
                 </a:solidFill>
                 <a:latin typeface="Calibri"/>
               </a:rPr>
-              <a:t>§3</a:t>
-            </a:r>
-          </a:p>
-        </p:txBody>
-      </p:sp>
-      <p:sp>
-        <p:nvSpPr>
-          <p:cNvPr id="47" name="TextBox 46"/>
-          <p:cNvSpPr txBox="1"/>
-          <p:nvPr/>
-        </p:nvSpPr>
-        <p:spPr>
-          <a:xfrm>
-            <a:off x="210312" y="4023359"/>
-            <a:ext cx="402336" cy="502920"/>
+              <a:t>§5</a:t>
+            </a:r>
+          </a:p>
+        </p:txBody>
+      </p:sp>
+      <p:sp>
+        <p:nvSpPr>
+          <p:cNvPr id="63" name="TextBox 62"/>
+          <p:cNvSpPr txBox="1"/>
+          <p:nvPr/>
+        </p:nvSpPr>
+        <p:spPr>
+          <a:xfrm>
+            <a:off x="10241280" y="3410712"/>
+            <a:ext cx="1645920" cy="256032"/>
+          </a:xfrm>
+          <a:prstGeom prst="rect">
+            <a:avLst/>
+          </a:prstGeom>
+          <a:noFill/>
+        </p:spPr>
+        <p:txBody>
+          <a:bodyPr wrap="none">
+            <a:spAutoFit/>
+          </a:bodyPr>
+          <a:lstStyle/>
+          <a:p/>
+          <a:p>
+            <a:pPr algn="l">
+              <a:spcBef>
+                <a:spcPts val="0"/>
+              </a:spcBef>
+              <a:spcAft>
+                <a:spcPts val="0"/>
+              </a:spcAft>
+            </a:pPr>
+            <a:r>
+              <a:rPr sz="1000" b="1">
+                <a:solidFill>
+                  <a:srgbClr val="1A1A1A"/>
+                </a:solidFill>
+                <a:latin typeface="Calibri"/>
+              </a:rPr>
+              <a:t>Correction Rate</a:t>
+            </a:r>
+          </a:p>
+        </p:txBody>
+      </p:sp>
+      <p:sp>
+        <p:nvSpPr>
+          <p:cNvPr id="64" name="TextBox 63"/>
+          <p:cNvSpPr txBox="1"/>
+          <p:nvPr/>
+        </p:nvSpPr>
+        <p:spPr>
+          <a:xfrm>
+            <a:off x="9784080" y="3703320"/>
+            <a:ext cx="2103120" cy="1463040"/>
           </a:xfrm>
           <a:prstGeom prst="rect">
             <a:avLst/>
@@ -6972,27 +7703,70 @@
               </a:spcAft>
             </a:pPr>
             <a:r>
-              <a:rPr sz="800" b="1">
-                <a:solidFill>
-                  <a:srgbClr val="1A1A1A"/>
-                </a:solidFill>
-                <a:latin typeface="Calibri"/>
-              </a:rPr>
-              <a:t>Price vs. Contract Delta</a:t>
-            </a:r>
-          </a:p>
-        </p:txBody>
-      </p:sp>
-      <p:sp>
-        <p:nvSpPr>
-          <p:cNvPr id="48" name="TextBox 47"/>
-          <p:cNvSpPr txBox="1"/>
-          <p:nvPr/>
-        </p:nvSpPr>
-        <p:spPr>
-          <a:xfrm>
-            <a:off x="777240" y="3694175"/>
-            <a:ext cx="3977639" cy="868680"/>
+              <a:rPr sz="900" b="0">
+                <a:solidFill>
+                  <a:srgbClr val="1A1A1A"/>
+                </a:solidFill>
+                <a:latin typeface="Calibri"/>
+              </a:rPr>
+              <a:t>% of AI fields flagged wrong by manager per packet</a:t>
+            </a:r>
+          </a:p>
+        </p:txBody>
+      </p:sp>
+      <p:sp>
+        <p:nvSpPr>
+          <p:cNvPr id="65" name="TextBox 64"/>
+          <p:cNvSpPr txBox="1"/>
+          <p:nvPr/>
+        </p:nvSpPr>
+        <p:spPr>
+          <a:xfrm>
+            <a:off x="9784080" y="6263640"/>
+            <a:ext cx="2103120" cy="274320"/>
+          </a:xfrm>
+          <a:prstGeom prst="rect">
+            <a:avLst/>
+          </a:prstGeom>
+          <a:noFill/>
+        </p:spPr>
+        <p:txBody>
+          <a:bodyPr wrap="none">
+            <a:spAutoFit/>
+          </a:bodyPr>
+          <a:lstStyle/>
+          <a:p/>
+          <a:p>
+            <a:pPr algn="l">
+              <a:spcBef>
+                <a:spcPts val="0"/>
+              </a:spcBef>
+              <a:spcAft>
+                <a:spcPts val="0"/>
+              </a:spcAft>
+            </a:pPr>
+            <a:r>
+              <a:rPr sz="700" b="0">
+                <a:solidFill>
+                  <a:srgbClr val="555555"/>
+                </a:solidFill>
+                <a:latin typeface="Calibri"/>
+              </a:rPr>
+              <a:t>kpi_correction_rate_pct</a:t>
+            </a:r>
+          </a:p>
+        </p:txBody>
+      </p:sp>
+      <p:sp>
+        <p:nvSpPr>
+          <p:cNvPr id="66" name="TextBox 65"/>
+          <p:cNvSpPr txBox="1"/>
+          <p:nvPr/>
+        </p:nvSpPr>
+        <p:spPr>
+          <a:xfrm>
+            <a:off x="9784080" y="5212080"/>
+            <a:ext cx="2103120" cy="1005840"/>
           </a:xfrm>
           <a:prstGeom prst="rect">
             <a:avLst/>
@@ -7015,1194 +7789,18 @@
               </a:spcAft>
             </a:pPr>
             <a:r>
-              <a:rPr sz="900" b="0">
-                <a:solidFill>
-                  <a:srgbClr val="1A1A1A"/>
-                </a:solidFill>
-                <a:latin typeface="Calibri"/>
-              </a:rPr>
-              <a:t>Latest email price quote minus contract base price. Absolute and percentage. Alert if delta &gt; 0 without written amendment.</a:t>
-            </a:r>
-          </a:p>
-        </p:txBody>
-      </p:sp>
-      <p:sp>
-        <p:nvSpPr>
-          <p:cNvPr id="49" name="TextBox 48"/>
-          <p:cNvSpPr txBox="1"/>
-          <p:nvPr/>
-        </p:nvSpPr>
-        <p:spPr>
-          <a:xfrm>
-            <a:off x="4983480" y="3694175"/>
-            <a:ext cx="3108960" cy="868680"/>
-          </a:xfrm>
-          <a:prstGeom prst="rect">
-            <a:avLst/>
-          </a:prstGeom>
-          <a:noFill/>
-        </p:spPr>
-        <p:txBody>
-          <a:bodyPr wrap="square">
-            <a:spAutoFit/>
-          </a:bodyPr>
-          <a:lstStyle/>
-          <a:p/>
-          <a:p>
-            <a:pPr algn="l">
-              <a:spcBef>
-                <a:spcPts val="0"/>
-              </a:spcBef>
-              <a:spcAft>
-                <a:spcPts val="0"/>
-              </a:spcAft>
-            </a:pPr>
-            <a:r>
-              <a:rPr sz="900" b="0">
-                <a:solidFill>
-                  <a:srgbClr val="1A1A1A"/>
-                </a:solidFill>
-                <a:latin typeface="Calibri"/>
-              </a:rPr>
-              <a:t>Computed locally. latest_price_quoted.value from Claude vs contract_base_price_numeric from contract.</a:t>
-            </a:r>
-          </a:p>
-        </p:txBody>
-      </p:sp>
-      <p:sp>
-        <p:nvSpPr>
-          <p:cNvPr id="50" name="TextBox 49"/>
-          <p:cNvSpPr txBox="1"/>
-          <p:nvPr/>
-        </p:nvSpPr>
-        <p:spPr>
-          <a:xfrm>
-            <a:off x="8275320" y="3694175"/>
-            <a:ext cx="1737360" cy="868680"/>
-          </a:xfrm>
-          <a:prstGeom prst="rect">
-            <a:avLst/>
-          </a:prstGeom>
-          <a:noFill/>
-        </p:spPr>
-        <p:txBody>
-          <a:bodyPr wrap="square">
-            <a:spAutoFit/>
-          </a:bodyPr>
-          <a:lstStyle/>
-          <a:p/>
-          <a:p>
-            <a:pPr algn="l">
-              <a:spcBef>
-                <a:spcPts val="0"/>
-              </a:spcBef>
-              <a:spcAft>
-                <a:spcPts val="0"/>
-              </a:spcAft>
-            </a:pPr>
-            <a:r>
-              <a:rPr sz="900" b="0">
-                <a:solidFill>
-                  <a:srgbClr val="1A1A1A"/>
-                </a:solidFill>
-                <a:latin typeface="Calibri"/>
-              </a:rPr>
-              <a:t>Galil: +9.2% (+NIS 1.30/kg). Triggers red alert.</a:t>
-            </a:r>
-          </a:p>
-        </p:txBody>
-      </p:sp>
-      <p:sp>
-        <p:nvSpPr>
-          <p:cNvPr id="51" name="TextBox 50"/>
-          <p:cNvSpPr txBox="1"/>
-          <p:nvPr/>
-        </p:nvSpPr>
-        <p:spPr>
-          <a:xfrm>
-            <a:off x="10195560" y="3694175"/>
-            <a:ext cx="1737360" cy="868680"/>
-          </a:xfrm>
-          <a:prstGeom prst="rect">
-            <a:avLst/>
-          </a:prstGeom>
-          <a:noFill/>
-        </p:spPr>
-        <p:txBody>
-          <a:bodyPr wrap="square">
-            <a:spAutoFit/>
-          </a:bodyPr>
-          <a:lstStyle/>
-          <a:p/>
-          <a:p>
-            <a:pPr algn="l">
-              <a:spcBef>
-                <a:spcPts val="0"/>
-              </a:spcBef>
-              <a:spcAft>
-                <a:spcPts val="0"/>
-              </a:spcAft>
-            </a:pPr>
-            <a:r>
-              <a:rPr sz="900" b="0">
-                <a:solidFill>
-                  <a:srgbClr val="555555"/>
-                </a:solidFill>
-                <a:latin typeface="Calibri"/>
-              </a:rPr>
-              <a:t>kpi_price_delta_pct stored per packet. Tracks which suppliers are consistently over contract.</a:t>
-            </a:r>
-          </a:p>
-        </p:txBody>
-      </p:sp>
-      <p:sp>
-        <p:nvSpPr>
-          <p:cNvPr id="52" name="Rectangle 51"/>
-          <p:cNvSpPr/>
-          <p:nvPr/>
-        </p:nvSpPr>
-        <p:spPr>
-          <a:xfrm>
-            <a:off x="182880" y="4672583"/>
-            <a:ext cx="457200" cy="987552"/>
-          </a:xfrm>
-          <a:prstGeom prst="rect">
-            <a:avLst/>
-          </a:prstGeom>
-          <a:solidFill>
-            <a:srgbClr val="FFFFFF"/>
-          </a:solidFill>
-          <a:ln>
-            <a:solidFill>
-              <a:srgbClr val="DDDDDD"/>
-            </a:solidFill>
-          </a:ln>
-        </p:spPr>
-        <p:style>
-          <a:lnRef idx="1">
-            <a:schemeClr val="accent1"/>
-          </a:lnRef>
-          <a:fillRef idx="3">
-            <a:schemeClr val="accent1"/>
-          </a:fillRef>
-          <a:effectRef idx="2">
-            <a:schemeClr val="accent1"/>
-          </a:effectRef>
-          <a:fontRef idx="minor">
-            <a:schemeClr val="lt1"/>
-          </a:fontRef>
-        </p:style>
-        <p:txBody>
-          <a:bodyPr rtlCol="0" anchor="ctr"/>
-          <a:lstStyle/>
-          <a:p>
-            <a:pPr algn="ctr"/>
-          </a:p>
-        </p:txBody>
-      </p:sp>
-      <p:sp>
-        <p:nvSpPr>
-          <p:cNvPr id="53" name="Rectangle 52"/>
-          <p:cNvSpPr/>
-          <p:nvPr/>
-        </p:nvSpPr>
-        <p:spPr>
-          <a:xfrm>
-            <a:off x="731520" y="4672583"/>
-            <a:ext cx="4114800" cy="987552"/>
-          </a:xfrm>
-          <a:prstGeom prst="rect">
-            <a:avLst/>
-          </a:prstGeom>
-          <a:solidFill>
-            <a:srgbClr val="FFFFFF"/>
-          </a:solidFill>
-          <a:ln>
-            <a:solidFill>
-              <a:srgbClr val="DDDDDD"/>
-            </a:solidFill>
-          </a:ln>
-        </p:spPr>
-        <p:style>
-          <a:lnRef idx="1">
-            <a:schemeClr val="accent1"/>
-          </a:lnRef>
-          <a:fillRef idx="3">
-            <a:schemeClr val="accent1"/>
-          </a:fillRef>
-          <a:effectRef idx="2">
-            <a:schemeClr val="accent1"/>
-          </a:effectRef>
-          <a:fontRef idx="minor">
-            <a:schemeClr val="lt1"/>
-          </a:fontRef>
-        </p:style>
-        <p:txBody>
-          <a:bodyPr rtlCol="0" anchor="ctr"/>
-          <a:lstStyle/>
-          <a:p>
-            <a:pPr algn="ctr"/>
-          </a:p>
-        </p:txBody>
-      </p:sp>
-      <p:sp>
-        <p:nvSpPr>
-          <p:cNvPr id="54" name="Rectangle 53"/>
-          <p:cNvSpPr/>
-          <p:nvPr/>
-        </p:nvSpPr>
-        <p:spPr>
-          <a:xfrm>
-            <a:off x="4937760" y="4672583"/>
-            <a:ext cx="3200400" cy="987552"/>
-          </a:xfrm>
-          <a:prstGeom prst="rect">
-            <a:avLst/>
-          </a:prstGeom>
-          <a:solidFill>
-            <a:srgbClr val="FFFFFF"/>
-          </a:solidFill>
-          <a:ln>
-            <a:solidFill>
-              <a:srgbClr val="DDDDDD"/>
-            </a:solidFill>
-          </a:ln>
-        </p:spPr>
-        <p:style>
-          <a:lnRef idx="1">
-            <a:schemeClr val="accent1"/>
-          </a:lnRef>
-          <a:fillRef idx="3">
-            <a:schemeClr val="accent1"/>
-          </a:fillRef>
-          <a:effectRef idx="2">
-            <a:schemeClr val="accent1"/>
-          </a:effectRef>
-          <a:fontRef idx="minor">
-            <a:schemeClr val="lt1"/>
-          </a:fontRef>
-        </p:style>
-        <p:txBody>
-          <a:bodyPr rtlCol="0" anchor="ctr"/>
-          <a:lstStyle/>
-          <a:p>
-            <a:pPr algn="ctr"/>
-          </a:p>
-        </p:txBody>
-      </p:sp>
-      <p:sp>
-        <p:nvSpPr>
-          <p:cNvPr id="55" name="Rectangle 54"/>
-          <p:cNvSpPr/>
-          <p:nvPr/>
-        </p:nvSpPr>
-        <p:spPr>
-          <a:xfrm>
-            <a:off x="8229600" y="4672583"/>
-            <a:ext cx="1828800" cy="987552"/>
-          </a:xfrm>
-          <a:prstGeom prst="rect">
-            <a:avLst/>
-          </a:prstGeom>
-          <a:solidFill>
-            <a:srgbClr val="FFFFFF"/>
-          </a:solidFill>
-          <a:ln>
-            <a:solidFill>
-              <a:srgbClr val="DDDDDD"/>
-            </a:solidFill>
-          </a:ln>
-        </p:spPr>
-        <p:style>
-          <a:lnRef idx="1">
-            <a:schemeClr val="accent1"/>
-          </a:lnRef>
-          <a:fillRef idx="3">
-            <a:schemeClr val="accent1"/>
-          </a:fillRef>
-          <a:effectRef idx="2">
-            <a:schemeClr val="accent1"/>
-          </a:effectRef>
-          <a:fontRef idx="minor">
-            <a:schemeClr val="lt1"/>
-          </a:fontRef>
-        </p:style>
-        <p:txBody>
-          <a:bodyPr rtlCol="0" anchor="ctr"/>
-          <a:lstStyle/>
-          <a:p>
-            <a:pPr algn="ctr"/>
-          </a:p>
-        </p:txBody>
-      </p:sp>
-      <p:sp>
-        <p:nvSpPr>
-          <p:cNvPr id="56" name="Rectangle 55"/>
-          <p:cNvSpPr/>
-          <p:nvPr/>
-        </p:nvSpPr>
-        <p:spPr>
-          <a:xfrm>
-            <a:off x="10149840" y="4672583"/>
-            <a:ext cx="1828800" cy="987552"/>
-          </a:xfrm>
-          <a:prstGeom prst="rect">
-            <a:avLst/>
-          </a:prstGeom>
-          <a:solidFill>
-            <a:srgbClr val="FFFFFF"/>
-          </a:solidFill>
-          <a:ln>
-            <a:solidFill>
-              <a:srgbClr val="DDDDDD"/>
-            </a:solidFill>
-          </a:ln>
-        </p:spPr>
-        <p:style>
-          <a:lnRef idx="1">
-            <a:schemeClr val="accent1"/>
-          </a:lnRef>
-          <a:fillRef idx="3">
-            <a:schemeClr val="accent1"/>
-          </a:fillRef>
-          <a:effectRef idx="2">
-            <a:schemeClr val="accent1"/>
-          </a:effectRef>
-          <a:fontRef idx="minor">
-            <a:schemeClr val="lt1"/>
-          </a:fontRef>
-        </p:style>
-        <p:txBody>
-          <a:bodyPr rtlCol="0" anchor="ctr"/>
-          <a:lstStyle/>
-          <a:p>
-            <a:pPr algn="ctr"/>
-          </a:p>
-        </p:txBody>
-      </p:sp>
-      <p:sp>
-        <p:nvSpPr>
-          <p:cNvPr id="57" name="Rectangle 56"/>
-          <p:cNvSpPr/>
-          <p:nvPr/>
-        </p:nvSpPr>
-        <p:spPr>
-          <a:xfrm>
-            <a:off x="201168" y="4745736"/>
-            <a:ext cx="402336" cy="256032"/>
-          </a:xfrm>
-          <a:prstGeom prst="rect">
-            <a:avLst/>
-          </a:prstGeom>
-          <a:solidFill>
-            <a:srgbClr val="C8102E"/>
-          </a:solidFill>
-          <a:ln>
-            <a:noFill/>
-          </a:ln>
-        </p:spPr>
-        <p:style>
-          <a:lnRef idx="1">
-            <a:schemeClr val="accent1"/>
-          </a:lnRef>
-          <a:fillRef idx="3">
-            <a:schemeClr val="accent1"/>
-          </a:fillRef>
-          <a:effectRef idx="2">
-            <a:schemeClr val="accent1"/>
-          </a:effectRef>
-          <a:fontRef idx="minor">
-            <a:schemeClr val="lt1"/>
-          </a:fontRef>
-        </p:style>
-        <p:txBody>
-          <a:bodyPr rtlCol="0" anchor="ctr"/>
-          <a:lstStyle/>
-          <a:p>
-            <a:pPr algn="ctr"/>
-          </a:p>
-        </p:txBody>
-      </p:sp>
-      <p:sp>
-        <p:nvSpPr>
-          <p:cNvPr id="58" name="TextBox 57"/>
-          <p:cNvSpPr txBox="1"/>
-          <p:nvPr/>
-        </p:nvSpPr>
-        <p:spPr>
-          <a:xfrm>
-            <a:off x="210312" y="4754879"/>
-            <a:ext cx="384048" cy="228600"/>
-          </a:xfrm>
-          <a:prstGeom prst="rect">
-            <a:avLst/>
-          </a:prstGeom>
-          <a:noFill/>
-        </p:spPr>
-        <p:txBody>
-          <a:bodyPr wrap="none">
-            <a:spAutoFit/>
-          </a:bodyPr>
-          <a:lstStyle/>
-          <a:p/>
-          <a:p>
-            <a:pPr algn="ctr">
-              <a:spcBef>
-                <a:spcPts val="0"/>
-              </a:spcBef>
-              <a:spcAft>
-                <a:spcPts val="0"/>
-              </a:spcAft>
-            </a:pPr>
-            <a:r>
-              <a:rPr sz="900" b="1">
-                <a:solidFill>
-                  <a:srgbClr val="FFFFFF"/>
-                </a:solidFill>
-                <a:latin typeface="Calibri"/>
-              </a:rPr>
-              <a:t>§4</a:t>
-            </a:r>
-          </a:p>
-        </p:txBody>
-      </p:sp>
-      <p:sp>
-        <p:nvSpPr>
-          <p:cNvPr id="59" name="TextBox 58"/>
-          <p:cNvSpPr txBox="1"/>
-          <p:nvPr/>
-        </p:nvSpPr>
-        <p:spPr>
-          <a:xfrm>
-            <a:off x="210312" y="5056631"/>
-            <a:ext cx="402336" cy="502920"/>
-          </a:xfrm>
-          <a:prstGeom prst="rect">
-            <a:avLst/>
-          </a:prstGeom>
-          <a:noFill/>
-        </p:spPr>
-        <p:txBody>
-          <a:bodyPr wrap="square">
-            <a:spAutoFit/>
-          </a:bodyPr>
-          <a:lstStyle/>
-          <a:p/>
-          <a:p>
-            <a:pPr algn="l">
-              <a:spcBef>
-                <a:spcPts val="0"/>
-              </a:spcBef>
-              <a:spcAft>
-                <a:spcPts val="0"/>
-              </a:spcAft>
-            </a:pPr>
-            <a:r>
-              <a:rPr sz="800" b="1">
-                <a:solidFill>
-                  <a:srgbClr val="1A1A1A"/>
-                </a:solidFill>
-                <a:latin typeface="Calibri"/>
-              </a:rPr>
-              <a:t>Days to Renewal</a:t>
-            </a:r>
-          </a:p>
-        </p:txBody>
-      </p:sp>
-      <p:sp>
-        <p:nvSpPr>
-          <p:cNvPr id="60" name="TextBox 59"/>
-          <p:cNvSpPr txBox="1"/>
-          <p:nvPr/>
-        </p:nvSpPr>
-        <p:spPr>
-          <a:xfrm>
-            <a:off x="777240" y="4727447"/>
-            <a:ext cx="3977639" cy="868680"/>
-          </a:xfrm>
-          <a:prstGeom prst="rect">
-            <a:avLst/>
-          </a:prstGeom>
-          <a:noFill/>
-        </p:spPr>
-        <p:txBody>
-          <a:bodyPr wrap="square">
-            <a:spAutoFit/>
-          </a:bodyPr>
-          <a:lstStyle/>
-          <a:p/>
-          <a:p>
-            <a:pPr algn="l">
-              <a:spcBef>
-                <a:spcPts val="0"/>
-              </a:spcBef>
-              <a:spcAft>
-                <a:spcPts val="0"/>
-              </a:spcAft>
-            </a:pPr>
-            <a:r>
-              <a:rPr sz="900" b="0">
-                <a:solidFill>
-                  <a:srgbClr val="1A1A1A"/>
-                </a:solidFill>
-                <a:latin typeface="Calibri"/>
-              </a:rPr>
-              <a:t>Calendar days from today to contract renewal date. Red &lt;30d, amber 30-90d. Auto-renewal shows notice deadline.</a:t>
-            </a:r>
-          </a:p>
-        </p:txBody>
-      </p:sp>
-      <p:sp>
-        <p:nvSpPr>
-          <p:cNvPr id="61" name="TextBox 60"/>
-          <p:cNvSpPr txBox="1"/>
-          <p:nvPr/>
-        </p:nvSpPr>
-        <p:spPr>
-          <a:xfrm>
-            <a:off x="4983480" y="4727447"/>
-            <a:ext cx="3108960" cy="868680"/>
-          </a:xfrm>
-          <a:prstGeom prst="rect">
-            <a:avLst/>
-          </a:prstGeom>
-          <a:noFill/>
-        </p:spPr>
-        <p:txBody>
-          <a:bodyPr wrap="square">
-            <a:spAutoFit/>
-          </a:bodyPr>
-          <a:lstStyle/>
-          <a:p/>
-          <a:p>
-            <a:pPr algn="l">
-              <a:spcBef>
-                <a:spcPts val="0"/>
-              </a:spcBef>
-              <a:spcAft>
-                <a:spcPts val="0"/>
-              </a:spcAft>
-            </a:pPr>
-            <a:r>
-              <a:rPr sz="900" b="0">
-                <a:solidFill>
-                  <a:srgbClr val="1A1A1A"/>
-                </a:solidFill>
-                <a:latin typeface="Calibri"/>
-              </a:rPr>
-              <a:t>Computed locally from contract renewal_date field vs system date. No API call.</a:t>
-            </a:r>
-          </a:p>
-        </p:txBody>
-      </p:sp>
-      <p:sp>
-        <p:nvSpPr>
-          <p:cNvPr id="62" name="TextBox 61"/>
-          <p:cNvSpPr txBox="1"/>
-          <p:nvPr/>
-        </p:nvSpPr>
-        <p:spPr>
-          <a:xfrm>
-            <a:off x="8275320" y="4727447"/>
-            <a:ext cx="1737360" cy="868680"/>
-          </a:xfrm>
-          <a:prstGeom prst="rect">
-            <a:avLst/>
-          </a:prstGeom>
-          <a:noFill/>
-        </p:spPr>
-        <p:txBody>
-          <a:bodyPr wrap="square">
-            <a:spAutoFit/>
-          </a:bodyPr>
-          <a:lstStyle/>
-          <a:p/>
-          <a:p>
-            <a:pPr algn="l">
-              <a:spcBef>
-                <a:spcPts val="0"/>
-              </a:spcBef>
-              <a:spcAft>
-                <a:spcPts val="0"/>
-              </a:spcAft>
-            </a:pPr>
-            <a:r>
-              <a:rPr sz="900" b="0">
-                <a:solidFill>
-                  <a:srgbClr val="1A1A1A"/>
-                </a:solidFill>
-                <a:latin typeface="Calibri"/>
-              </a:rPr>
-              <a:t>Lowlands Dairy: no active contract flagged immediately.</a:t>
-            </a:r>
-          </a:p>
-        </p:txBody>
-      </p:sp>
-      <p:sp>
-        <p:nvSpPr>
-          <p:cNvPr id="63" name="TextBox 62"/>
-          <p:cNvSpPr txBox="1"/>
-          <p:nvPr/>
-        </p:nvSpPr>
-        <p:spPr>
-          <a:xfrm>
-            <a:off x="10195560" y="4727447"/>
-            <a:ext cx="1737360" cy="868680"/>
-          </a:xfrm>
-          <a:prstGeom prst="rect">
-            <a:avLst/>
-          </a:prstGeom>
-          <a:noFill/>
-        </p:spPr>
-        <p:txBody>
-          <a:bodyPr wrap="square">
-            <a:spAutoFit/>
-          </a:bodyPr>
-          <a:lstStyle/>
-          <a:p/>
-          <a:p>
-            <a:pPr algn="l">
-              <a:spcBef>
-                <a:spcPts val="0"/>
-              </a:spcBef>
-              <a:spcAft>
-                <a:spcPts val="0"/>
-              </a:spcAft>
-            </a:pPr>
-            <a:r>
-              <a:rPr sz="900" b="0">
-                <a:solidFill>
-                  <a:srgbClr val="555555"/>
-                </a:solidFill>
-                <a:latin typeface="Calibri"/>
-              </a:rPr>
-              <a:t>kpi_days_to_renewal stored per packet. Surfaces suppliers approaching critical renewal window.</a:t>
-            </a:r>
-          </a:p>
-        </p:txBody>
-      </p:sp>
-      <p:sp>
-        <p:nvSpPr>
-          <p:cNvPr id="64" name="Rectangle 63"/>
-          <p:cNvSpPr/>
-          <p:nvPr/>
-        </p:nvSpPr>
-        <p:spPr>
-          <a:xfrm>
-            <a:off x="182880" y="5705855"/>
-            <a:ext cx="457200" cy="987552"/>
-          </a:xfrm>
-          <a:prstGeom prst="rect">
-            <a:avLst/>
-          </a:prstGeom>
-          <a:solidFill>
-            <a:srgbClr val="F0F0F0"/>
-          </a:solidFill>
-          <a:ln>
-            <a:solidFill>
-              <a:srgbClr val="DDDDDD"/>
-            </a:solidFill>
-          </a:ln>
-        </p:spPr>
-        <p:style>
-          <a:lnRef idx="1">
-            <a:schemeClr val="accent1"/>
-          </a:lnRef>
-          <a:fillRef idx="3">
-            <a:schemeClr val="accent1"/>
-          </a:fillRef>
-          <a:effectRef idx="2">
-            <a:schemeClr val="accent1"/>
-          </a:effectRef>
-          <a:fontRef idx="minor">
-            <a:schemeClr val="lt1"/>
-          </a:fontRef>
-        </p:style>
-        <p:txBody>
-          <a:bodyPr rtlCol="0" anchor="ctr"/>
-          <a:lstStyle/>
-          <a:p>
-            <a:pPr algn="ctr"/>
-          </a:p>
-        </p:txBody>
-      </p:sp>
-      <p:sp>
-        <p:nvSpPr>
-          <p:cNvPr id="65" name="Rectangle 64"/>
-          <p:cNvSpPr/>
-          <p:nvPr/>
-        </p:nvSpPr>
-        <p:spPr>
-          <a:xfrm>
-            <a:off x="731520" y="5705855"/>
-            <a:ext cx="4114800" cy="987552"/>
-          </a:xfrm>
-          <a:prstGeom prst="rect">
-            <a:avLst/>
-          </a:prstGeom>
-          <a:solidFill>
-            <a:srgbClr val="F0F0F0"/>
-          </a:solidFill>
-          <a:ln>
-            <a:solidFill>
-              <a:srgbClr val="DDDDDD"/>
-            </a:solidFill>
-          </a:ln>
-        </p:spPr>
-        <p:style>
-          <a:lnRef idx="1">
-            <a:schemeClr val="accent1"/>
-          </a:lnRef>
-          <a:fillRef idx="3">
-            <a:schemeClr val="accent1"/>
-          </a:fillRef>
-          <a:effectRef idx="2">
-            <a:schemeClr val="accent1"/>
-          </a:effectRef>
-          <a:fontRef idx="minor">
-            <a:schemeClr val="lt1"/>
-          </a:fontRef>
-        </p:style>
-        <p:txBody>
-          <a:bodyPr rtlCol="0" anchor="ctr"/>
-          <a:lstStyle/>
-          <a:p>
-            <a:pPr algn="ctr"/>
-          </a:p>
-        </p:txBody>
-      </p:sp>
-      <p:sp>
-        <p:nvSpPr>
-          <p:cNvPr id="66" name="Rectangle 65"/>
-          <p:cNvSpPr/>
-          <p:nvPr/>
-        </p:nvSpPr>
-        <p:spPr>
-          <a:xfrm>
-            <a:off x="4937760" y="5705855"/>
-            <a:ext cx="3200400" cy="987552"/>
-          </a:xfrm>
-          <a:prstGeom prst="rect">
-            <a:avLst/>
-          </a:prstGeom>
-          <a:solidFill>
-            <a:srgbClr val="F0F0F0"/>
-          </a:solidFill>
-          <a:ln>
-            <a:solidFill>
-              <a:srgbClr val="DDDDDD"/>
-            </a:solidFill>
-          </a:ln>
-        </p:spPr>
-        <p:style>
-          <a:lnRef idx="1">
-            <a:schemeClr val="accent1"/>
-          </a:lnRef>
-          <a:fillRef idx="3">
-            <a:schemeClr val="accent1"/>
-          </a:fillRef>
-          <a:effectRef idx="2">
-            <a:schemeClr val="accent1"/>
-          </a:effectRef>
-          <a:fontRef idx="minor">
-            <a:schemeClr val="lt1"/>
-          </a:fontRef>
-        </p:style>
-        <p:txBody>
-          <a:bodyPr rtlCol="0" anchor="ctr"/>
-          <a:lstStyle/>
-          <a:p>
-            <a:pPr algn="ctr"/>
-          </a:p>
-        </p:txBody>
-      </p:sp>
-      <p:sp>
-        <p:nvSpPr>
-          <p:cNvPr id="67" name="Rectangle 66"/>
-          <p:cNvSpPr/>
-          <p:nvPr/>
-        </p:nvSpPr>
-        <p:spPr>
-          <a:xfrm>
-            <a:off x="8229600" y="5705855"/>
-            <a:ext cx="1828800" cy="987552"/>
-          </a:xfrm>
-          <a:prstGeom prst="rect">
-            <a:avLst/>
-          </a:prstGeom>
-          <a:solidFill>
-            <a:srgbClr val="F0F0F0"/>
-          </a:solidFill>
-          <a:ln>
-            <a:solidFill>
-              <a:srgbClr val="DDDDDD"/>
-            </a:solidFill>
-          </a:ln>
-        </p:spPr>
-        <p:style>
-          <a:lnRef idx="1">
-            <a:schemeClr val="accent1"/>
-          </a:lnRef>
-          <a:fillRef idx="3">
-            <a:schemeClr val="accent1"/>
-          </a:fillRef>
-          <a:effectRef idx="2">
-            <a:schemeClr val="accent1"/>
-          </a:effectRef>
-          <a:fontRef idx="minor">
-            <a:schemeClr val="lt1"/>
-          </a:fontRef>
-        </p:style>
-        <p:txBody>
-          <a:bodyPr rtlCol="0" anchor="ctr"/>
-          <a:lstStyle/>
-          <a:p>
-            <a:pPr algn="ctr"/>
-          </a:p>
-        </p:txBody>
-      </p:sp>
-      <p:sp>
-        <p:nvSpPr>
-          <p:cNvPr id="68" name="Rectangle 67"/>
-          <p:cNvSpPr/>
-          <p:nvPr/>
-        </p:nvSpPr>
-        <p:spPr>
-          <a:xfrm>
-            <a:off x="10149840" y="5705855"/>
-            <a:ext cx="1828800" cy="987552"/>
-          </a:xfrm>
-          <a:prstGeom prst="rect">
-            <a:avLst/>
-          </a:prstGeom>
-          <a:solidFill>
-            <a:srgbClr val="F0F0F0"/>
-          </a:solidFill>
-          <a:ln>
-            <a:solidFill>
-              <a:srgbClr val="DDDDDD"/>
-            </a:solidFill>
-          </a:ln>
-        </p:spPr>
-        <p:style>
-          <a:lnRef idx="1">
-            <a:schemeClr val="accent1"/>
-          </a:lnRef>
-          <a:fillRef idx="3">
-            <a:schemeClr val="accent1"/>
-          </a:fillRef>
-          <a:effectRef idx="2">
-            <a:schemeClr val="accent1"/>
-          </a:effectRef>
-          <a:fontRef idx="minor">
-            <a:schemeClr val="lt1"/>
-          </a:fontRef>
-        </p:style>
-        <p:txBody>
-          <a:bodyPr rtlCol="0" anchor="ctr"/>
-          <a:lstStyle/>
-          <a:p>
-            <a:pPr algn="ctr"/>
-          </a:p>
-        </p:txBody>
-      </p:sp>
-      <p:sp>
-        <p:nvSpPr>
-          <p:cNvPr id="69" name="Rectangle 68"/>
-          <p:cNvSpPr/>
-          <p:nvPr/>
-        </p:nvSpPr>
-        <p:spPr>
-          <a:xfrm>
-            <a:off x="201168" y="5779007"/>
-            <a:ext cx="402336" cy="256032"/>
-          </a:xfrm>
-          <a:prstGeom prst="rect">
-            <a:avLst/>
-          </a:prstGeom>
-          <a:solidFill>
-            <a:srgbClr val="C8102E"/>
-          </a:solidFill>
-          <a:ln>
-            <a:noFill/>
-          </a:ln>
-        </p:spPr>
-        <p:style>
-          <a:lnRef idx="1">
-            <a:schemeClr val="accent1"/>
-          </a:lnRef>
-          <a:fillRef idx="3">
-            <a:schemeClr val="accent1"/>
-          </a:fillRef>
-          <a:effectRef idx="2">
-            <a:schemeClr val="accent1"/>
-          </a:effectRef>
-          <a:fontRef idx="minor">
-            <a:schemeClr val="lt1"/>
-          </a:fontRef>
-        </p:style>
-        <p:txBody>
-          <a:bodyPr rtlCol="0" anchor="ctr"/>
-          <a:lstStyle/>
-          <a:p>
-            <a:pPr algn="ctr"/>
-          </a:p>
-        </p:txBody>
-      </p:sp>
-      <p:sp>
-        <p:nvSpPr>
-          <p:cNvPr id="70" name="TextBox 69"/>
-          <p:cNvSpPr txBox="1"/>
-          <p:nvPr/>
-        </p:nvSpPr>
-        <p:spPr>
-          <a:xfrm>
-            <a:off x="210312" y="5788151"/>
-            <a:ext cx="384048" cy="228600"/>
-          </a:xfrm>
-          <a:prstGeom prst="rect">
-            <a:avLst/>
-          </a:prstGeom>
-          <a:noFill/>
-        </p:spPr>
-        <p:txBody>
-          <a:bodyPr wrap="none">
-            <a:spAutoFit/>
-          </a:bodyPr>
-          <a:lstStyle/>
-          <a:p/>
-          <a:p>
-            <a:pPr algn="ctr">
-              <a:spcBef>
-                <a:spcPts val="0"/>
-              </a:spcBef>
-              <a:spcAft>
-                <a:spcPts val="0"/>
-              </a:spcAft>
-            </a:pPr>
-            <a:r>
-              <a:rPr sz="900" b="1">
-                <a:solidFill>
-                  <a:srgbClr val="FFFFFF"/>
-                </a:solidFill>
-                <a:latin typeface="Calibri"/>
-              </a:rPr>
-              <a:t>§5</a:t>
-            </a:r>
-          </a:p>
-        </p:txBody>
-      </p:sp>
-      <p:sp>
-        <p:nvSpPr>
-          <p:cNvPr id="71" name="TextBox 70"/>
-          <p:cNvSpPr txBox="1"/>
-          <p:nvPr/>
-        </p:nvSpPr>
-        <p:spPr>
-          <a:xfrm>
-            <a:off x="210312" y="6089903"/>
-            <a:ext cx="402336" cy="502920"/>
-          </a:xfrm>
-          <a:prstGeom prst="rect">
-            <a:avLst/>
-          </a:prstGeom>
-          <a:noFill/>
-        </p:spPr>
-        <p:txBody>
-          <a:bodyPr wrap="square">
-            <a:spAutoFit/>
-          </a:bodyPr>
-          <a:lstStyle/>
-          <a:p/>
-          <a:p>
-            <a:pPr algn="l">
-              <a:spcBef>
-                <a:spcPts val="0"/>
-              </a:spcBef>
-              <a:spcAft>
-                <a:spcPts val="0"/>
-              </a:spcAft>
-            </a:pPr>
-            <a:r>
-              <a:rPr sz="800" b="1">
-                <a:solidFill>
-                  <a:srgbClr val="1A1A1A"/>
-                </a:solidFill>
-                <a:latin typeface="Calibri"/>
-              </a:rPr>
-              <a:t>Override / Correction Rate</a:t>
-            </a:r>
-          </a:p>
-        </p:txBody>
-      </p:sp>
-      <p:sp>
-        <p:nvSpPr>
-          <p:cNvPr id="72" name="TextBox 71"/>
-          <p:cNvSpPr txBox="1"/>
-          <p:nvPr/>
-        </p:nvSpPr>
-        <p:spPr>
-          <a:xfrm>
-            <a:off x="777240" y="5760719"/>
-            <a:ext cx="3977639" cy="868680"/>
-          </a:xfrm>
-          <a:prstGeom prst="rect">
-            <a:avLst/>
-          </a:prstGeom>
-          <a:noFill/>
-        </p:spPr>
-        <p:txBody>
-          <a:bodyPr wrap="square">
-            <a:spAutoFit/>
-          </a:bodyPr>
-          <a:lstStyle/>
-          <a:p/>
-          <a:p>
-            <a:pPr algn="l">
-              <a:spcBef>
-                <a:spcPts val="0"/>
-              </a:spcBef>
-              <a:spcAft>
-                <a:spcPts val="0"/>
-              </a:spcAft>
-            </a:pPr>
-            <a:r>
-              <a:rPr sz="900" b="0">
-                <a:solidFill>
-                  <a:srgbClr val="1A1A1A"/>
-                </a:solidFill>
-                <a:latin typeface="Calibri"/>
-              </a:rPr>
-              <a:t>% of AI-extracted fields flagged as wrong per packet by the manager. High rate = extraction needs tuning.</a:t>
-            </a:r>
-          </a:p>
-        </p:txBody>
-      </p:sp>
-      <p:sp>
-        <p:nvSpPr>
-          <p:cNvPr id="73" name="TextBox 72"/>
-          <p:cNvSpPr txBox="1"/>
-          <p:nvPr/>
-        </p:nvSpPr>
-        <p:spPr>
-          <a:xfrm>
-            <a:off x="4983480" y="5760719"/>
-            <a:ext cx="3108960" cy="868680"/>
-          </a:xfrm>
-          <a:prstGeom prst="rect">
-            <a:avLst/>
-          </a:prstGeom>
-          <a:noFill/>
-        </p:spPr>
-        <p:txBody>
-          <a:bodyPr wrap="square">
-            <a:spAutoFit/>
-          </a:bodyPr>
-          <a:lstStyle/>
-          <a:p/>
-          <a:p>
-            <a:pPr algn="l">
-              <a:spcBef>
-                <a:spcPts val="0"/>
-              </a:spcBef>
-              <a:spcAft>
-                <a:spcPts val="0"/>
-              </a:spcAft>
-            </a:pPr>
-            <a:r>
-              <a:rPr sz="900" b="0">
-                <a:solidFill>
-                  <a:srgbClr val="1A1A1A"/>
-                </a:solidFill>
-                <a:latin typeface="Calibri"/>
-              </a:rPr>
-              <a:t>UI checkboxes in packet view. Saved to correction_log.csv when manager clicks Save. Joined to SQLite for aggregate view.</a:t>
-            </a:r>
-          </a:p>
-        </p:txBody>
-      </p:sp>
-      <p:sp>
-        <p:nvSpPr>
-          <p:cNvPr id="74" name="TextBox 73"/>
-          <p:cNvSpPr txBox="1"/>
-          <p:nvPr/>
-        </p:nvSpPr>
-        <p:spPr>
-          <a:xfrm>
-            <a:off x="8275320" y="5760719"/>
-            <a:ext cx="1737360" cy="868680"/>
-          </a:xfrm>
-          <a:prstGeom prst="rect">
-            <a:avLst/>
-          </a:prstGeom>
-          <a:noFill/>
-        </p:spPr>
-        <p:txBody>
-          <a:bodyPr wrap="square">
-            <a:spAutoFit/>
-          </a:bodyPr>
-          <a:lstStyle/>
-          <a:p/>
-          <a:p>
-            <a:pPr algn="l">
-              <a:spcBef>
-                <a:spcPts val="0"/>
-              </a:spcBef>
-              <a:spcAft>
-                <a:spcPts val="0"/>
-              </a:spcAft>
-            </a:pPr>
-            <a:r>
-              <a:rPr sz="900" b="0">
-                <a:solidFill>
-                  <a:srgbClr val="1A1A1A"/>
-                </a:solidFill>
-                <a:latin typeface="Calibri"/>
-              </a:rPr>
-              <a:t>Target: &lt;10% by day 90. Currently tracked per session.</a:t>
-            </a:r>
-          </a:p>
-        </p:txBody>
-      </p:sp>
-      <p:sp>
-        <p:nvSpPr>
-          <p:cNvPr id="75" name="TextBox 74"/>
-          <p:cNvSpPr txBox="1"/>
-          <p:nvPr/>
-        </p:nvSpPr>
-        <p:spPr>
-          <a:xfrm>
-            <a:off x="10195560" y="5760719"/>
-            <a:ext cx="1737360" cy="868680"/>
-          </a:xfrm>
-          <a:prstGeom prst="rect">
-            <a:avLst/>
-          </a:prstGeom>
-          <a:noFill/>
-        </p:spPr>
-        <p:txBody>
-          <a:bodyPr wrap="square">
-            <a:spAutoFit/>
-          </a:bodyPr>
-          <a:lstStyle/>
-          <a:p/>
-          <a:p>
-            <a:pPr algn="l">
-              <a:spcBef>
-                <a:spcPts val="0"/>
-              </a:spcBef>
-              <a:spcAft>
-                <a:spcPts val="0"/>
-              </a:spcAft>
-            </a:pPr>
-            <a:r>
-              <a:rPr sz="900" b="0">
-                <a:solidFill>
-                  <a:srgbClr val="555555"/>
-                </a:solidFill>
-                <a:latin typeface="Calibri"/>
-              </a:rPr>
-              <a:t>kpi_correction_rate_pct written when manager saves corrections. Identifies which fields and suppliers have highest error rate.</a:t>
+              <a:rPr sz="800" b="0">
+                <a:solidFill>
+                  <a:srgbClr val="C8102E"/>
+                </a:solidFill>
+                <a:latin typeface="Calibri"/>
+              </a:rPr>
+              <a:t>Target &lt;10% by day 90
+High rate = retune prompt</a:t>
+            </a:r>
+            <a:br/>
+            <a:r>
+              <a:t>High rate = retune prompt</a:t>
             </a:r>
           </a:p>
         </p:txBody>

</xml_diff>

<commit_message>
docs: add AI negotiation brief to slide 10 packet contents
</commit_message>
<xml_diff>
--- a/docs/strauss_fde_deck.pptx
+++ b/docs/strauss_fde_deck.pptx
@@ -6306,6 +6306,22 @@
                 <a:latin typeface="Calibri"/>
               </a:rPr>
               <a:t>  • Open issues list (colour-coded by severity)</a:t>
+            </a:r>
+          </a:p>
+          <a:p>
+            <a:pPr algn="l">
+              <a:spcBef>
+                <a:spcPts val="600"/>
+              </a:spcBef>
+            </a:pPr>
+            <a:r>
+              <a:rPr sz="1300">
+                <a:solidFill>
+                  <a:srgbClr val="1A1A1A"/>
+                </a:solidFill>
+                <a:latin typeface="Calibri"/>
+              </a:rPr>
+              <a:t>  • AI negotiation brief — one-paragraph synthesis of the supplier relationship, open risks, and what leverage Strauss holds walking into the meeting; generated automatically from emails + contract</a:t>
             </a:r>
           </a:p>
           <a:p>

</xml_diff>

<commit_message>
docs: rewrite slide 12 to exactly 3 KPIs — prep time, adoption rate, correction rate
</commit_message>
<xml_diff>
--- a/docs/strauss_fde_deck.pptx
+++ b/docs/strauss_fde_deck.pptx
@@ -7916,1053 +7916,14 @@
       </p:sp>
       <p:sp>
         <p:nvSpPr>
-          <p:cNvPr id="7" name="TextBox 6"/>
-          <p:cNvSpPr txBox="1"/>
-          <p:nvPr/>
-        </p:nvSpPr>
-        <p:spPr>
-          <a:xfrm>
-            <a:off x="182880" y="1170432"/>
-            <a:ext cx="4114800" cy="292608"/>
-          </a:xfrm>
-          <a:prstGeom prst="rect">
-            <a:avLst/>
-          </a:prstGeom>
-          <a:noFill/>
-        </p:spPr>
-        <p:txBody>
-          <a:bodyPr wrap="none">
-            <a:spAutoFit/>
-          </a:bodyPr>
-          <a:lstStyle/>
-          <a:p>
-            <a:endParaRPr/>
-          </a:p>
-          <a:p>
-            <a:pPr algn="l">
-              <a:spcBef>
-                <a:spcPts val="0"/>
-              </a:spcBef>
-              <a:spcAft>
-                <a:spcPts val="0"/>
-              </a:spcAft>
-            </a:pPr>
-            <a:r>
-              <a:rPr sz="1000" b="1">
-                <a:solidFill>
-                  <a:srgbClr val="FFFFFF"/>
-                </a:solidFill>
-                <a:latin typeface="Calibri"/>
-              </a:rPr>
-              <a:t>TIER 1  —  ADOPTION  (is it being used?)</a:t>
-            </a:r>
-          </a:p>
-        </p:txBody>
-      </p:sp>
-      <p:sp>
-        <p:nvSpPr>
-          <p:cNvPr id="8" name="Rectangle 7"/>
+          <p:cNvPr id="7" name="Rectangle 6"/>
           <p:cNvSpPr/>
           <p:nvPr/>
         </p:nvSpPr>
         <p:spPr>
           <a:xfrm>
-            <a:off x="182880" y="1170432"/>
-            <a:ext cx="11841480" cy="292608"/>
-          </a:xfrm>
-          <a:prstGeom prst="rect">
-            <a:avLst/>
-          </a:prstGeom>
-          <a:solidFill>
-            <a:srgbClr val="1A1A1A"/>
-          </a:solidFill>
-          <a:ln>
-            <a:noFill/>
-          </a:ln>
-        </p:spPr>
-        <p:style>
-          <a:lnRef idx="1">
-            <a:schemeClr val="accent1"/>
-          </a:lnRef>
-          <a:fillRef idx="3">
-            <a:schemeClr val="accent1"/>
-          </a:fillRef>
-          <a:effectRef idx="2">
-            <a:schemeClr val="accent1"/>
-          </a:effectRef>
-          <a:fontRef idx="minor">
-            <a:schemeClr val="lt1"/>
-          </a:fontRef>
-        </p:style>
-        <p:txBody>
-          <a:bodyPr rtlCol="0" anchor="ctr"/>
-          <a:lstStyle/>
-          <a:p>
-            <a:pPr algn="ctr"/>
-            <a:endParaRPr/>
-          </a:p>
-        </p:txBody>
-      </p:sp>
-      <p:sp>
-        <p:nvSpPr>
-          <p:cNvPr id="9" name="TextBox 8"/>
-          <p:cNvSpPr txBox="1"/>
-          <p:nvPr/>
-        </p:nvSpPr>
-        <p:spPr>
-          <a:xfrm>
-            <a:off x="274320" y="1179576"/>
-            <a:ext cx="11612880" cy="256032"/>
-          </a:xfrm>
-          <a:prstGeom prst="rect">
-            <a:avLst/>
-          </a:prstGeom>
-          <a:noFill/>
-        </p:spPr>
-        <p:txBody>
-          <a:bodyPr wrap="none">
-            <a:spAutoFit/>
-          </a:bodyPr>
-          <a:lstStyle/>
-          <a:p>
-            <a:endParaRPr/>
-          </a:p>
-          <a:p>
-            <a:pPr algn="l">
-              <a:spcBef>
-                <a:spcPts val="0"/>
-              </a:spcBef>
-              <a:spcAft>
-                <a:spcPts val="0"/>
-              </a:spcAft>
-            </a:pPr>
-            <a:r>
-              <a:rPr sz="1000" b="1">
-                <a:solidFill>
-                  <a:srgbClr val="FFFFFF"/>
-                </a:solidFill>
-                <a:latin typeface="Calibri"/>
-              </a:rPr>
-              <a:t>TIER 1  —  ADOPTION  (is it being used?)</a:t>
-            </a:r>
-          </a:p>
-        </p:txBody>
-      </p:sp>
-      <p:sp>
-        <p:nvSpPr>
-          <p:cNvPr id="10" name="Rectangle 9"/>
-          <p:cNvSpPr/>
-          <p:nvPr/>
-        </p:nvSpPr>
-        <p:spPr>
-          <a:xfrm>
-            <a:off x="182880" y="1508760"/>
-            <a:ext cx="2286000" cy="1417320"/>
-          </a:xfrm>
-          <a:prstGeom prst="rect">
-            <a:avLst/>
-          </a:prstGeom>
-          <a:solidFill>
-            <a:srgbClr val="F0F0F0"/>
-          </a:solidFill>
-          <a:ln>
-            <a:solidFill>
-              <a:srgbClr val="DDDDDD"/>
-            </a:solidFill>
-          </a:ln>
-        </p:spPr>
-        <p:style>
-          <a:lnRef idx="1">
-            <a:schemeClr val="accent1"/>
-          </a:lnRef>
-          <a:fillRef idx="3">
-            <a:schemeClr val="accent1"/>
-          </a:fillRef>
-          <a:effectRef idx="2">
-            <a:schemeClr val="accent1"/>
-          </a:effectRef>
-          <a:fontRef idx="minor">
-            <a:schemeClr val="lt1"/>
-          </a:fontRef>
-        </p:style>
-        <p:txBody>
-          <a:bodyPr rtlCol="0" anchor="ctr"/>
-          <a:lstStyle/>
-          <a:p>
-            <a:pPr algn="ctr"/>
-            <a:endParaRPr/>
-          </a:p>
-        </p:txBody>
-      </p:sp>
-      <p:sp>
-        <p:nvSpPr>
-          <p:cNvPr id="11" name="TextBox 10"/>
-          <p:cNvSpPr txBox="1"/>
-          <p:nvPr/>
-        </p:nvSpPr>
-        <p:spPr>
-          <a:xfrm>
-            <a:off x="274320" y="1536192"/>
-            <a:ext cx="2103120" cy="292608"/>
-          </a:xfrm>
-          <a:prstGeom prst="rect">
-            <a:avLst/>
-          </a:prstGeom>
-          <a:noFill/>
-        </p:spPr>
-        <p:txBody>
-          <a:bodyPr wrap="none">
-            <a:spAutoFit/>
-          </a:bodyPr>
-          <a:lstStyle/>
-          <a:p>
-            <a:endParaRPr/>
-          </a:p>
-          <a:p>
-            <a:pPr algn="l">
-              <a:spcBef>
-                <a:spcPts val="0"/>
-              </a:spcBef>
-              <a:spcAft>
-                <a:spcPts val="0"/>
-              </a:spcAft>
-            </a:pPr>
-            <a:r>
-              <a:rPr sz="1000" b="1">
-                <a:solidFill>
-                  <a:srgbClr val="1A1A1A"/>
-                </a:solidFill>
-                <a:latin typeface="Calibri"/>
-              </a:rPr>
-              <a:t>Packets generated</a:t>
-            </a:r>
-          </a:p>
-        </p:txBody>
-      </p:sp>
-      <p:sp>
-        <p:nvSpPr>
-          <p:cNvPr id="12" name="TextBox 11"/>
-          <p:cNvSpPr txBox="1"/>
-          <p:nvPr/>
-        </p:nvSpPr>
-        <p:spPr>
-          <a:xfrm>
-            <a:off x="274320" y="1828800"/>
-            <a:ext cx="2103120" cy="822960"/>
-          </a:xfrm>
-          <a:prstGeom prst="rect">
-            <a:avLst/>
-          </a:prstGeom>
-          <a:noFill/>
-        </p:spPr>
-        <p:txBody>
-          <a:bodyPr wrap="square">
-            <a:spAutoFit/>
-          </a:bodyPr>
-          <a:lstStyle/>
-          <a:p>
-            <a:endParaRPr/>
-          </a:p>
-          <a:p>
-            <a:pPr algn="l">
-              <a:spcBef>
-                <a:spcPts val="0"/>
-              </a:spcBef>
-              <a:spcAft>
-                <a:spcPts val="0"/>
-              </a:spcAft>
-            </a:pPr>
-            <a:r>
-              <a:rPr sz="800" b="0">
-                <a:solidFill>
-                  <a:srgbClr val="1A1A1A"/>
-                </a:solidFill>
-                <a:latin typeface="Calibri"/>
-              </a:rPr>
-              <a:t>Total count of prep packets produced. Primary adoption signal — zero means the tool isn't being used.</a:t>
-            </a:r>
-          </a:p>
-        </p:txBody>
-      </p:sp>
-      <p:sp>
-        <p:nvSpPr>
-          <p:cNvPr id="13" name="TextBox 12"/>
-          <p:cNvSpPr txBox="1"/>
-          <p:nvPr/>
-        </p:nvSpPr>
-        <p:spPr>
-          <a:xfrm>
-            <a:off x="274320" y="2724912"/>
-            <a:ext cx="2103120" cy="182880"/>
-          </a:xfrm>
-          <a:prstGeom prst="rect">
-            <a:avLst/>
-          </a:prstGeom>
-          <a:noFill/>
-        </p:spPr>
-        <p:txBody>
-          <a:bodyPr wrap="none">
-            <a:spAutoFit/>
-          </a:bodyPr>
-          <a:lstStyle/>
-          <a:p>
-            <a:endParaRPr/>
-          </a:p>
-          <a:p>
-            <a:pPr algn="l">
-              <a:spcBef>
-                <a:spcPts val="0"/>
-              </a:spcBef>
-              <a:spcAft>
-                <a:spcPts val="0"/>
-              </a:spcAft>
-            </a:pPr>
-            <a:r>
-              <a:rPr sz="700" b="0">
-                <a:solidFill>
-                  <a:srgbClr val="555555"/>
-                </a:solidFill>
-                <a:latin typeface="Calibri"/>
-              </a:rPr>
-              <a:t>total_packets in SQLite</a:t>
-            </a:r>
-          </a:p>
-        </p:txBody>
-      </p:sp>
-      <p:sp>
-        <p:nvSpPr>
-          <p:cNvPr id="14" name="Rectangle 13"/>
-          <p:cNvSpPr/>
-          <p:nvPr/>
-        </p:nvSpPr>
-        <p:spPr>
-          <a:xfrm>
-            <a:off x="2560320" y="1508760"/>
-            <a:ext cx="2286000" cy="1417320"/>
-          </a:xfrm>
-          <a:prstGeom prst="rect">
-            <a:avLst/>
-          </a:prstGeom>
-          <a:solidFill>
-            <a:srgbClr val="FFFFFF"/>
-          </a:solidFill>
-          <a:ln>
-            <a:solidFill>
-              <a:srgbClr val="DDDDDD"/>
-            </a:solidFill>
-          </a:ln>
-        </p:spPr>
-        <p:style>
-          <a:lnRef idx="1">
-            <a:schemeClr val="accent1"/>
-          </a:lnRef>
-          <a:fillRef idx="3">
-            <a:schemeClr val="accent1"/>
-          </a:fillRef>
-          <a:effectRef idx="2">
-            <a:schemeClr val="accent1"/>
-          </a:effectRef>
-          <a:fontRef idx="minor">
-            <a:schemeClr val="lt1"/>
-          </a:fontRef>
-        </p:style>
-        <p:txBody>
-          <a:bodyPr rtlCol="0" anchor="ctr"/>
-          <a:lstStyle/>
-          <a:p>
-            <a:pPr algn="ctr"/>
-            <a:endParaRPr/>
-          </a:p>
-        </p:txBody>
-      </p:sp>
-      <p:sp>
-        <p:nvSpPr>
-          <p:cNvPr id="15" name="TextBox 14"/>
-          <p:cNvSpPr txBox="1"/>
-          <p:nvPr/>
-        </p:nvSpPr>
-        <p:spPr>
-          <a:xfrm>
-            <a:off x="2651760" y="1536192"/>
-            <a:ext cx="2103120" cy="292608"/>
-          </a:xfrm>
-          <a:prstGeom prst="rect">
-            <a:avLst/>
-          </a:prstGeom>
-          <a:noFill/>
-        </p:spPr>
-        <p:txBody>
-          <a:bodyPr wrap="none">
-            <a:spAutoFit/>
-          </a:bodyPr>
-          <a:lstStyle/>
-          <a:p>
-            <a:endParaRPr/>
-          </a:p>
-          <a:p>
-            <a:pPr algn="l">
-              <a:spcBef>
-                <a:spcPts val="0"/>
-              </a:spcBef>
-              <a:spcAft>
-                <a:spcPts val="0"/>
-              </a:spcAft>
-            </a:pPr>
-            <a:r>
-              <a:rPr sz="1000" b="1">
-                <a:solidFill>
-                  <a:srgbClr val="1A1A1A"/>
-                </a:solidFill>
-                <a:latin typeface="Calibri"/>
-              </a:rPr>
-              <a:t>Unique suppliers queried</a:t>
-            </a:r>
-          </a:p>
-        </p:txBody>
-      </p:sp>
-      <p:sp>
-        <p:nvSpPr>
-          <p:cNvPr id="16" name="TextBox 15"/>
-          <p:cNvSpPr txBox="1"/>
-          <p:nvPr/>
-        </p:nvSpPr>
-        <p:spPr>
-          <a:xfrm>
-            <a:off x="2651760" y="1828800"/>
-            <a:ext cx="2103120" cy="822960"/>
-          </a:xfrm>
-          <a:prstGeom prst="rect">
-            <a:avLst/>
-          </a:prstGeom>
-          <a:noFill/>
-        </p:spPr>
-        <p:txBody>
-          <a:bodyPr wrap="square">
-            <a:spAutoFit/>
-          </a:bodyPr>
-          <a:lstStyle/>
-          <a:p>
-            <a:endParaRPr/>
-          </a:p>
-          <a:p>
-            <a:pPr algn="l">
-              <a:spcBef>
-                <a:spcPts val="0"/>
-              </a:spcBef>
-              <a:spcAft>
-                <a:spcPts val="0"/>
-              </a:spcAft>
-            </a:pPr>
-            <a:r>
-              <a:rPr sz="800" b="0">
-                <a:solidFill>
-                  <a:srgbClr val="1A1A1A"/>
-                </a:solidFill>
-                <a:latin typeface="Calibri"/>
-              </a:rPr>
-              <a:t>How many distinct suppliers have had a packet generated. Breadth of adoption across the supplier roster.</a:t>
-            </a:r>
-          </a:p>
-        </p:txBody>
-      </p:sp>
-      <p:sp>
-        <p:nvSpPr>
-          <p:cNvPr id="17" name="TextBox 16"/>
-          <p:cNvSpPr txBox="1"/>
-          <p:nvPr/>
-        </p:nvSpPr>
-        <p:spPr>
-          <a:xfrm>
-            <a:off x="2651760" y="2724912"/>
-            <a:ext cx="2103120" cy="182880"/>
-          </a:xfrm>
-          <a:prstGeom prst="rect">
-            <a:avLst/>
-          </a:prstGeom>
-          <a:noFill/>
-        </p:spPr>
-        <p:txBody>
-          <a:bodyPr wrap="none">
-            <a:spAutoFit/>
-          </a:bodyPr>
-          <a:lstStyle/>
-          <a:p>
-            <a:endParaRPr/>
-          </a:p>
-          <a:p>
-            <a:pPr algn="l">
-              <a:spcBef>
-                <a:spcPts val="0"/>
-              </a:spcBef>
-              <a:spcAft>
-                <a:spcPts val="0"/>
-              </a:spcAft>
-            </a:pPr>
-            <a:r>
-              <a:rPr sz="700" b="0">
-                <a:solidFill>
-                  <a:srgbClr val="555555"/>
-                </a:solidFill>
-                <a:latin typeface="Calibri"/>
-              </a:rPr>
-              <a:t>unique_suppliers in SQLite</a:t>
-            </a:r>
-          </a:p>
-        </p:txBody>
-      </p:sp>
-      <p:sp>
-        <p:nvSpPr>
-          <p:cNvPr id="18" name="Rectangle 17"/>
-          <p:cNvSpPr/>
-          <p:nvPr/>
-        </p:nvSpPr>
-        <p:spPr>
-          <a:xfrm>
-            <a:off x="4937760" y="1508760"/>
-            <a:ext cx="2286000" cy="1417320"/>
-          </a:xfrm>
-          <a:prstGeom prst="rect">
-            <a:avLst/>
-          </a:prstGeom>
-          <a:solidFill>
-            <a:srgbClr val="F0F0F0"/>
-          </a:solidFill>
-          <a:ln>
-            <a:solidFill>
-              <a:srgbClr val="DDDDDD"/>
-            </a:solidFill>
-          </a:ln>
-        </p:spPr>
-        <p:style>
-          <a:lnRef idx="1">
-            <a:schemeClr val="accent1"/>
-          </a:lnRef>
-          <a:fillRef idx="3">
-            <a:schemeClr val="accent1"/>
-          </a:fillRef>
-          <a:effectRef idx="2">
-            <a:schemeClr val="accent1"/>
-          </a:effectRef>
-          <a:fontRef idx="minor">
-            <a:schemeClr val="lt1"/>
-          </a:fontRef>
-        </p:style>
-        <p:txBody>
-          <a:bodyPr rtlCol="0" anchor="ctr"/>
-          <a:lstStyle/>
-          <a:p>
-            <a:pPr algn="ctr"/>
-            <a:endParaRPr/>
-          </a:p>
-        </p:txBody>
-      </p:sp>
-      <p:sp>
-        <p:nvSpPr>
-          <p:cNvPr id="19" name="TextBox 18"/>
-          <p:cNvSpPr txBox="1"/>
-          <p:nvPr/>
-        </p:nvSpPr>
-        <p:spPr>
-          <a:xfrm>
-            <a:off x="5029200" y="1536192"/>
-            <a:ext cx="2103120" cy="292608"/>
-          </a:xfrm>
-          <a:prstGeom prst="rect">
-            <a:avLst/>
-          </a:prstGeom>
-          <a:noFill/>
-        </p:spPr>
-        <p:txBody>
-          <a:bodyPr wrap="none">
-            <a:spAutoFit/>
-          </a:bodyPr>
-          <a:lstStyle/>
-          <a:p>
-            <a:endParaRPr/>
-          </a:p>
-          <a:p>
-            <a:pPr algn="l">
-              <a:spcBef>
-                <a:spcPts val="0"/>
-              </a:spcBef>
-              <a:spcAft>
-                <a:spcPts val="0"/>
-              </a:spcAft>
-            </a:pPr>
-            <a:r>
-              <a:rPr sz="1000" b="1">
-                <a:solidFill>
-                  <a:srgbClr val="1A1A1A"/>
-                </a:solidFill>
-                <a:latin typeface="Calibri"/>
-              </a:rPr>
-              <a:t>Avg generation time (s)</a:t>
-            </a:r>
-          </a:p>
-        </p:txBody>
-      </p:sp>
-      <p:sp>
-        <p:nvSpPr>
-          <p:cNvPr id="20" name="TextBox 19"/>
-          <p:cNvSpPr txBox="1"/>
-          <p:nvPr/>
-        </p:nvSpPr>
-        <p:spPr>
-          <a:xfrm>
-            <a:off x="5029200" y="1828800"/>
-            <a:ext cx="2103120" cy="822960"/>
-          </a:xfrm>
-          <a:prstGeom prst="rect">
-            <a:avLst/>
-          </a:prstGeom>
-          <a:noFill/>
-        </p:spPr>
-        <p:txBody>
-          <a:bodyPr wrap="square">
-            <a:spAutoFit/>
-          </a:bodyPr>
-          <a:lstStyle/>
-          <a:p>
-            <a:endParaRPr/>
-          </a:p>
-          <a:p>
-            <a:pPr algn="l">
-              <a:spcBef>
-                <a:spcPts val="0"/>
-              </a:spcBef>
-              <a:spcAft>
-                <a:spcPts val="0"/>
-              </a:spcAft>
-            </a:pPr>
-            <a:r>
-              <a:rPr sz="800" b="0">
-                <a:solidFill>
-                  <a:srgbClr val="1A1A1A"/>
-                </a:solidFill>
-                <a:latin typeface="Calibri"/>
-              </a:rPr>
-              <a:t>Average seconds per packet. Tracks performance — target &lt;15s. Regression signal if it grows.</a:t>
-            </a:r>
-          </a:p>
-        </p:txBody>
-      </p:sp>
-      <p:sp>
-        <p:nvSpPr>
-          <p:cNvPr id="21" name="TextBox 20"/>
-          <p:cNvSpPr txBox="1"/>
-          <p:nvPr/>
-        </p:nvSpPr>
-        <p:spPr>
-          <a:xfrm>
-            <a:off x="5029200" y="2724912"/>
-            <a:ext cx="2103120" cy="182880"/>
-          </a:xfrm>
-          <a:prstGeom prst="rect">
-            <a:avLst/>
-          </a:prstGeom>
-          <a:noFill/>
-        </p:spPr>
-        <p:txBody>
-          <a:bodyPr wrap="none">
-            <a:spAutoFit/>
-          </a:bodyPr>
-          <a:lstStyle/>
-          <a:p>
-            <a:endParaRPr/>
-          </a:p>
-          <a:p>
-            <a:pPr algn="l">
-              <a:spcBef>
-                <a:spcPts val="0"/>
-              </a:spcBef>
-              <a:spcAft>
-                <a:spcPts val="0"/>
-              </a:spcAft>
-            </a:pPr>
-            <a:r>
-              <a:rPr sz="700" b="0">
-                <a:solidFill>
-                  <a:srgbClr val="555555"/>
-                </a:solidFill>
-                <a:latin typeface="Calibri"/>
-              </a:rPr>
-              <a:t>avg_duration_sec in SQLite</a:t>
-            </a:r>
-          </a:p>
-        </p:txBody>
-      </p:sp>
-      <p:sp>
-        <p:nvSpPr>
-          <p:cNvPr id="22" name="Rectangle 21"/>
-          <p:cNvSpPr/>
-          <p:nvPr/>
-        </p:nvSpPr>
-        <p:spPr>
-          <a:xfrm>
-            <a:off x="7315200" y="1508760"/>
-            <a:ext cx="2286000" cy="1417320"/>
-          </a:xfrm>
-          <a:prstGeom prst="rect">
-            <a:avLst/>
-          </a:prstGeom>
-          <a:solidFill>
-            <a:srgbClr val="FFFFFF"/>
-          </a:solidFill>
-          <a:ln>
-            <a:solidFill>
-              <a:srgbClr val="DDDDDD"/>
-            </a:solidFill>
-          </a:ln>
-        </p:spPr>
-        <p:style>
-          <a:lnRef idx="1">
-            <a:schemeClr val="accent1"/>
-          </a:lnRef>
-          <a:fillRef idx="3">
-            <a:schemeClr val="accent1"/>
-          </a:fillRef>
-          <a:effectRef idx="2">
-            <a:schemeClr val="accent1"/>
-          </a:effectRef>
-          <a:fontRef idx="minor">
-            <a:schemeClr val="lt1"/>
-          </a:fontRef>
-        </p:style>
-        <p:txBody>
-          <a:bodyPr rtlCol="0" anchor="ctr"/>
-          <a:lstStyle/>
-          <a:p>
-            <a:pPr algn="ctr"/>
-            <a:endParaRPr/>
-          </a:p>
-        </p:txBody>
-      </p:sp>
-      <p:sp>
-        <p:nvSpPr>
-          <p:cNvPr id="23" name="TextBox 22"/>
-          <p:cNvSpPr txBox="1"/>
-          <p:nvPr/>
-        </p:nvSpPr>
-        <p:spPr>
-          <a:xfrm>
-            <a:off x="7406640" y="1536192"/>
-            <a:ext cx="2103120" cy="292608"/>
-          </a:xfrm>
-          <a:prstGeom prst="rect">
-            <a:avLst/>
-          </a:prstGeom>
-          <a:noFill/>
-        </p:spPr>
-        <p:txBody>
-          <a:bodyPr wrap="none">
-            <a:spAutoFit/>
-          </a:bodyPr>
-          <a:lstStyle/>
-          <a:p>
-            <a:endParaRPr/>
-          </a:p>
-          <a:p>
-            <a:pPr algn="l">
-              <a:spcBef>
-                <a:spcPts val="0"/>
-              </a:spcBef>
-              <a:spcAft>
-                <a:spcPts val="0"/>
-              </a:spcAft>
-            </a:pPr>
-            <a:r>
-              <a:rPr sz="1000" b="1">
-                <a:solidFill>
-                  <a:srgbClr val="1A1A1A"/>
-                </a:solidFill>
-                <a:latin typeface="Calibri"/>
-              </a:rPr>
-              <a:t>Daily generation volume</a:t>
-            </a:r>
-          </a:p>
-        </p:txBody>
-      </p:sp>
-      <p:sp>
-        <p:nvSpPr>
-          <p:cNvPr id="24" name="TextBox 23"/>
-          <p:cNvSpPr txBox="1"/>
-          <p:nvPr/>
-        </p:nvSpPr>
-        <p:spPr>
-          <a:xfrm>
-            <a:off x="7406640" y="1828800"/>
-            <a:ext cx="2103120" cy="822960"/>
-          </a:xfrm>
-          <a:prstGeom prst="rect">
-            <a:avLst/>
-          </a:prstGeom>
-          <a:noFill/>
-        </p:spPr>
-        <p:txBody>
-          <a:bodyPr wrap="square">
-            <a:spAutoFit/>
-          </a:bodyPr>
-          <a:lstStyle/>
-          <a:p>
-            <a:endParaRPr/>
-          </a:p>
-          <a:p>
-            <a:pPr algn="l">
-              <a:spcBef>
-                <a:spcPts val="0"/>
-              </a:spcBef>
-              <a:spcAft>
-                <a:spcPts val="0"/>
-              </a:spcAft>
-            </a:pPr>
-            <a:r>
-              <a:rPr sz="800" b="0">
-                <a:solidFill>
-                  <a:srgbClr val="1A1A1A"/>
-                </a:solidFill>
-                <a:latin typeface="Calibri"/>
-              </a:rPr>
-              <a:t>Packets per day over rolling 30 days. Reveals whether use is growing, flat, or dropping after initial curiosity.</a:t>
-            </a:r>
-          </a:p>
-        </p:txBody>
-      </p:sp>
-      <p:sp>
-        <p:nvSpPr>
-          <p:cNvPr id="25" name="TextBox 24"/>
-          <p:cNvSpPr txBox="1"/>
-          <p:nvPr/>
-        </p:nvSpPr>
-        <p:spPr>
-          <a:xfrm>
-            <a:off x="7406640" y="2724912"/>
-            <a:ext cx="2103120" cy="182880"/>
-          </a:xfrm>
-          <a:prstGeom prst="rect">
-            <a:avLst/>
-          </a:prstGeom>
-          <a:noFill/>
-        </p:spPr>
-        <p:txBody>
-          <a:bodyPr wrap="none">
-            <a:spAutoFit/>
-          </a:bodyPr>
-          <a:lstStyle/>
-          <a:p>
-            <a:endParaRPr/>
-          </a:p>
-          <a:p>
-            <a:pPr algn="l">
-              <a:spcBef>
-                <a:spcPts val="0"/>
-              </a:spcBef>
-              <a:spcAft>
-                <a:spcPts val="0"/>
-              </a:spcAft>
-            </a:pPr>
-            <a:r>
-              <a:rPr sz="700" b="0">
-                <a:solidFill>
-                  <a:srgbClr val="555555"/>
-                </a:solidFill>
-                <a:latin typeface="Calibri"/>
-              </a:rPr>
-              <a:t>daily_breakdown table</a:t>
-            </a:r>
-          </a:p>
-        </p:txBody>
-      </p:sp>
-      <p:sp>
-        <p:nvSpPr>
-          <p:cNvPr id="26" name="Rectangle 25"/>
-          <p:cNvSpPr/>
-          <p:nvPr/>
-        </p:nvSpPr>
-        <p:spPr>
-          <a:xfrm>
-            <a:off x="9692640" y="1508760"/>
-            <a:ext cx="2286000" cy="1417320"/>
-          </a:xfrm>
-          <a:prstGeom prst="rect">
-            <a:avLst/>
-          </a:prstGeom>
-          <a:solidFill>
-            <a:srgbClr val="F0F0F0"/>
-          </a:solidFill>
-          <a:ln>
-            <a:solidFill>
-              <a:srgbClr val="DDDDDD"/>
-            </a:solidFill>
-          </a:ln>
-        </p:spPr>
-        <p:style>
-          <a:lnRef idx="1">
-            <a:schemeClr val="accent1"/>
-          </a:lnRef>
-          <a:fillRef idx="3">
-            <a:schemeClr val="accent1"/>
-          </a:fillRef>
-          <a:effectRef idx="2">
-            <a:schemeClr val="accent1"/>
-          </a:effectRef>
-          <a:fontRef idx="minor">
-            <a:schemeClr val="lt1"/>
-          </a:fontRef>
-        </p:style>
-        <p:txBody>
-          <a:bodyPr rtlCol="0" anchor="ctr"/>
-          <a:lstStyle/>
-          <a:p>
-            <a:pPr algn="ctr"/>
-            <a:endParaRPr/>
-          </a:p>
-        </p:txBody>
-      </p:sp>
-      <p:sp>
-        <p:nvSpPr>
-          <p:cNvPr id="27" name="TextBox 26"/>
-          <p:cNvSpPr txBox="1"/>
-          <p:nvPr/>
-        </p:nvSpPr>
-        <p:spPr>
-          <a:xfrm>
-            <a:off x="9784080" y="1536192"/>
-            <a:ext cx="2103120" cy="292608"/>
-          </a:xfrm>
-          <a:prstGeom prst="rect">
-            <a:avLst/>
-          </a:prstGeom>
-          <a:noFill/>
-        </p:spPr>
-        <p:txBody>
-          <a:bodyPr wrap="none">
-            <a:spAutoFit/>
-          </a:bodyPr>
-          <a:lstStyle/>
-          <a:p>
-            <a:endParaRPr/>
-          </a:p>
-          <a:p>
-            <a:pPr algn="l">
-              <a:spcBef>
-                <a:spcPts val="0"/>
-              </a:spcBef>
-              <a:spcAft>
-                <a:spcPts val="0"/>
-              </a:spcAft>
-            </a:pPr>
-            <a:r>
-              <a:rPr sz="1000" b="1">
-                <a:solidFill>
-                  <a:srgbClr val="1A1A1A"/>
-                </a:solidFill>
-                <a:latin typeface="Calibri"/>
-              </a:rPr>
-              <a:t>Per-supplier frequency</a:t>
-            </a:r>
-          </a:p>
-        </p:txBody>
-      </p:sp>
-      <p:sp>
-        <p:nvSpPr>
-          <p:cNvPr id="28" name="TextBox 27"/>
-          <p:cNvSpPr txBox="1"/>
-          <p:nvPr/>
-        </p:nvSpPr>
-        <p:spPr>
-          <a:xfrm>
-            <a:off x="9784080" y="1828800"/>
-            <a:ext cx="2103120" cy="822960"/>
-          </a:xfrm>
-          <a:prstGeom prst="rect">
-            <a:avLst/>
-          </a:prstGeom>
-          <a:noFill/>
-        </p:spPr>
-        <p:txBody>
-          <a:bodyPr wrap="square">
-            <a:spAutoFit/>
-          </a:bodyPr>
-          <a:lstStyle/>
-          <a:p>
-            <a:endParaRPr/>
-          </a:p>
-          <a:p>
-            <a:pPr algn="l">
-              <a:spcBef>
-                <a:spcPts val="0"/>
-              </a:spcBef>
-              <a:spcAft>
-                <a:spcPts val="0"/>
-              </a:spcAft>
-            </a:pPr>
-            <a:r>
-              <a:rPr sz="800" b="0">
-                <a:solidFill>
-                  <a:srgbClr val="1A1A1A"/>
-                </a:solidFill>
-                <a:latin typeface="Calibri"/>
-              </a:rPr>
-              <a:t>Which suppliers get prepped most often. Low frequency on a high-risk supplier = adoption gap.</a:t>
-            </a:r>
-          </a:p>
-        </p:txBody>
-      </p:sp>
-      <p:sp>
-        <p:nvSpPr>
-          <p:cNvPr id="29" name="TextBox 28"/>
-          <p:cNvSpPr txBox="1"/>
-          <p:nvPr/>
-        </p:nvSpPr>
-        <p:spPr>
-          <a:xfrm>
-            <a:off x="9784080" y="2724912"/>
-            <a:ext cx="2103120" cy="182880"/>
-          </a:xfrm>
-          <a:prstGeom prst="rect">
-            <a:avLst/>
-          </a:prstGeom>
-          <a:noFill/>
-        </p:spPr>
-        <p:txBody>
-          <a:bodyPr wrap="none">
-            <a:spAutoFit/>
-          </a:bodyPr>
-          <a:lstStyle/>
-          <a:p>
-            <a:endParaRPr/>
-          </a:p>
-          <a:p>
-            <a:pPr algn="l">
-              <a:spcBef>
-                <a:spcPts val="0"/>
-              </a:spcBef>
-              <a:spcAft>
-                <a:spcPts val="0"/>
-              </a:spcAft>
-            </a:pPr>
-            <a:r>
-              <a:rPr sz="700" b="0">
-                <a:solidFill>
-                  <a:srgbClr val="555555"/>
-                </a:solidFill>
-                <a:latin typeface="Calibri"/>
-              </a:rPr>
-              <a:t>supplier_breakdown table</a:t>
-            </a:r>
-          </a:p>
-        </p:txBody>
-      </p:sp>
-      <p:sp>
-        <p:nvSpPr>
-          <p:cNvPr id="30" name="Rectangle 29"/>
-          <p:cNvSpPr/>
-          <p:nvPr/>
-        </p:nvSpPr>
-        <p:spPr>
-          <a:xfrm>
-            <a:off x="182880" y="3035808"/>
-            <a:ext cx="11841480" cy="292608"/>
+            <a:off x="182880" y="1143000"/>
+            <a:ext cx="411480" cy="365760"/>
           </a:xfrm>
           <a:prstGeom prst="rect">
             <a:avLst/>
@@ -8989,24 +7950,31 @@
           </a:fontRef>
         </p:style>
         <p:txBody>
-          <a:bodyPr rtlCol="0" anchor="ctr"/>
+          <a:bodyPr rtlCol="0" anchor="ctr" wrap="none"/>
           <a:lstStyle/>
           <a:p>
             <a:pPr algn="ctr"/>
-            <a:endParaRPr/>
-          </a:p>
-        </p:txBody>
-      </p:sp>
-      <p:sp>
-        <p:nvSpPr>
-          <p:cNvPr id="31" name="TextBox 30"/>
+            <a:r>
+              <a:rPr b="1" sz="1400">
+                <a:solidFill>
+                  <a:srgbClr val="FFFFFF"/>
+                </a:solidFill>
+              </a:rPr>
+              <a:t>1</a:t>
+            </a:r>
+          </a:p>
+        </p:txBody>
+      </p:sp>
+      <p:sp>
+        <p:nvSpPr>
+          <p:cNvPr id="8" name="TextBox 7"/>
           <p:cNvSpPr txBox="1"/>
           <p:nvPr/>
         </p:nvSpPr>
         <p:spPr>
           <a:xfrm>
-            <a:off x="274320" y="3044952"/>
-            <a:ext cx="11612880" cy="256032"/>
+            <a:off x="685800" y="1124712"/>
+            <a:ext cx="11292840" cy="329184"/>
           </a:xfrm>
           <a:prstGeom prst="rect">
             <a:avLst/>
@@ -9019,50 +7987,112 @@
           </a:bodyPr>
           <a:lstStyle/>
           <a:p>
-            <a:endParaRPr/>
-          </a:p>
-          <a:p>
-            <a:pPr algn="l">
-              <a:spcBef>
-                <a:spcPts val="0"/>
-              </a:spcBef>
-              <a:spcAft>
-                <a:spcPts val="0"/>
-              </a:spcAft>
-            </a:pPr>
-            <a:r>
-              <a:rPr sz="1000" b="1">
-                <a:solidFill>
-                  <a:srgbClr val="FFFFFF"/>
-                </a:solidFill>
-                <a:latin typeface="Calibri"/>
-              </a:rPr>
-              <a:t>TIER 2  —  EXTRACTION QUALITY  (is it worth using?)</a:t>
-            </a:r>
-          </a:p>
-        </p:txBody>
-      </p:sp>
-      <p:sp>
-        <p:nvSpPr>
-          <p:cNvPr id="32" name="Rectangle 31"/>
+            <a:r>
+              <a:rPr b="1" sz="1600">
+                <a:solidFill>
+                  <a:srgbClr val="1A1A1A"/>
+                </a:solidFill>
+              </a:rPr>
+              <a:t>Prep Time Saved</a:t>
+            </a:r>
+          </a:p>
+        </p:txBody>
+      </p:sp>
+      <p:sp>
+        <p:nvSpPr>
+          <p:cNvPr id="9" name="TextBox 8"/>
+          <p:cNvSpPr txBox="1"/>
+          <p:nvPr/>
+        </p:nvSpPr>
+        <p:spPr>
+          <a:xfrm>
+            <a:off x="685800" y="1508760"/>
+            <a:ext cx="11292840" cy="777240"/>
+          </a:xfrm>
+          <a:prstGeom prst="rect">
+            <a:avLst/>
+          </a:prstGeom>
+          <a:noFill/>
+        </p:spPr>
+        <p:txBody>
+          <a:bodyPr wrap="square">
+            <a:spAutoFit/>
+          </a:bodyPr>
+          <a:lstStyle/>
+          <a:p>
+            <a:r>
+              <a:rPr b="0" sz="1300">
+                <a:solidFill>
+                  <a:srgbClr val="1A1A1A"/>
+                </a:solidFill>
+              </a:rPr>
+              <a:t>Manual prep: 2.5 hrs per meeting  →  AI-assisted: 20 min</a:t>
+            </a:r>
+          </a:p>
+          <a:p>
+            <a:r>
+              <a:rPr b="0" sz="1300">
+                <a:solidFill>
+                  <a:srgbClr val="1A1A1A"/>
+                </a:solidFill>
+              </a:rPr>
+              <a:t>Time saved: 2h10m × 14 meetings/quarter = ~30 hrs/quarter per analyst</a:t>
+            </a:r>
+          </a:p>
+        </p:txBody>
+      </p:sp>
+      <p:sp>
+        <p:nvSpPr>
+          <p:cNvPr id="10" name="TextBox 9"/>
+          <p:cNvSpPr txBox="1"/>
+          <p:nvPr/>
+        </p:nvSpPr>
+        <p:spPr>
+          <a:xfrm>
+            <a:off x="685800" y="2286000"/>
+            <a:ext cx="11292840" cy="502920"/>
+          </a:xfrm>
+          <a:prstGeom prst="rect">
+            <a:avLst/>
+          </a:prstGeom>
+          <a:noFill/>
+        </p:spPr>
+        <p:txBody>
+          <a:bodyPr wrap="square">
+            <a:spAutoFit/>
+          </a:bodyPr>
+          <a:lstStyle/>
+          <a:p>
+            <a:r>
+              <a:rPr b="0" sz="1000">
+                <a:solidFill>
+                  <a:srgbClr val="555555"/>
+                </a:solidFill>
+              </a:rPr>
+              <a:t>Tracked via packet generation timestamps vs. historical baseline survey.</a:t>
+            </a:r>
+          </a:p>
+        </p:txBody>
+      </p:sp>
+      <p:sp>
+        <p:nvSpPr>
+          <p:cNvPr id="11" name="Rectangle 10"/>
           <p:cNvSpPr/>
           <p:nvPr/>
         </p:nvSpPr>
         <p:spPr>
           <a:xfrm>
-            <a:off x="182880" y="3364992"/>
-            <a:ext cx="2286000" cy="3246120"/>
+            <a:off x="182880" y="2901696"/>
+            <a:ext cx="11795760" cy="9144"/>
           </a:xfrm>
           <a:prstGeom prst="rect">
             <a:avLst/>
           </a:prstGeom>
           <a:solidFill>
-            <a:srgbClr val="F0F0F0"/>
+            <a:srgbClr val="DDDDDD"/>
           </a:solidFill>
           <a:ln>
-            <a:solidFill>
-              <a:srgbClr val="DDDDDD"/>
-            </a:solidFill>
+            <a:noFill/>
           </a:ln>
         </p:spPr>
         <p:style>
@@ -9084,20 +8114,19 @@
           <a:lstStyle/>
           <a:p>
             <a:pPr algn="ctr"/>
-            <a:endParaRPr/>
-          </a:p>
-        </p:txBody>
-      </p:sp>
-      <p:sp>
-        <p:nvSpPr>
-          <p:cNvPr id="33" name="Rectangle 32"/>
+          </a:p>
+        </p:txBody>
+      </p:sp>
+      <p:sp>
+        <p:nvSpPr>
+          <p:cNvPr id="12" name="Rectangle 11"/>
           <p:cNvSpPr/>
           <p:nvPr/>
         </p:nvSpPr>
         <p:spPr>
           <a:xfrm>
-            <a:off x="274320" y="3410712"/>
-            <a:ext cx="384048" cy="237744"/>
+            <a:off x="182880" y="3011424"/>
+            <a:ext cx="411480" cy="365760"/>
           </a:xfrm>
           <a:prstGeom prst="rect">
             <a:avLst/>
@@ -9124,24 +8153,31 @@
           </a:fontRef>
         </p:style>
         <p:txBody>
-          <a:bodyPr rtlCol="0" anchor="ctr"/>
+          <a:bodyPr rtlCol="0" anchor="ctr" wrap="none"/>
           <a:lstStyle/>
           <a:p>
             <a:pPr algn="ctr"/>
-            <a:endParaRPr/>
-          </a:p>
-        </p:txBody>
-      </p:sp>
-      <p:sp>
-        <p:nvSpPr>
-          <p:cNvPr id="34" name="TextBox 33"/>
+            <a:r>
+              <a:rPr b="1" sz="1400">
+                <a:solidFill>
+                  <a:srgbClr val="FFFFFF"/>
+                </a:solidFill>
+              </a:rPr>
+              <a:t>2</a:t>
+            </a:r>
+          </a:p>
+        </p:txBody>
+      </p:sp>
+      <p:sp>
+        <p:nvSpPr>
+          <p:cNvPr id="13" name="TextBox 12"/>
           <p:cNvSpPr txBox="1"/>
           <p:nvPr/>
         </p:nvSpPr>
         <p:spPr>
           <a:xfrm>
-            <a:off x="283464" y="3419856"/>
-            <a:ext cx="365760" cy="201168"/>
+            <a:off x="685800" y="2993136"/>
+            <a:ext cx="11292840" cy="329184"/>
           </a:xfrm>
           <a:prstGeom prst="rect">
             <a:avLst/>
@@ -9154,84 +8190,27 @@
           </a:bodyPr>
           <a:lstStyle/>
           <a:p>
-            <a:endParaRPr/>
-          </a:p>
-          <a:p>
-            <a:pPr algn="ctr">
-              <a:spcBef>
-                <a:spcPts val="0"/>
-              </a:spcBef>
-              <a:spcAft>
-                <a:spcPts val="0"/>
-              </a:spcAft>
-            </a:pPr>
-            <a:r>
-              <a:rPr sz="800" b="1">
-                <a:solidFill>
-                  <a:srgbClr val="FFFFFF"/>
-                </a:solidFill>
-                <a:latin typeface="Calibri"/>
-              </a:rPr>
-              <a:t>§1</a:t>
-            </a:r>
-          </a:p>
-        </p:txBody>
-      </p:sp>
-      <p:sp>
-        <p:nvSpPr>
-          <p:cNvPr id="35" name="TextBox 34"/>
+            <a:r>
+              <a:rPr b="1" sz="1600">
+                <a:solidFill>
+                  <a:srgbClr val="1A1A1A"/>
+                </a:solidFill>
+              </a:rPr>
+              <a:t>Packet Adoption Rate</a:t>
+            </a:r>
+          </a:p>
+        </p:txBody>
+      </p:sp>
+      <p:sp>
+        <p:nvSpPr>
+          <p:cNvPr id="14" name="TextBox 13"/>
           <p:cNvSpPr txBox="1"/>
           <p:nvPr/>
         </p:nvSpPr>
         <p:spPr>
           <a:xfrm>
-            <a:off x="731520" y="3410712"/>
-            <a:ext cx="1645920" cy="256032"/>
-          </a:xfrm>
-          <a:prstGeom prst="rect">
-            <a:avLst/>
-          </a:prstGeom>
-          <a:noFill/>
-        </p:spPr>
-        <p:txBody>
-          <a:bodyPr wrap="none">
-            <a:spAutoFit/>
-          </a:bodyPr>
-          <a:lstStyle/>
-          <a:p>
-            <a:endParaRPr/>
-          </a:p>
-          <a:p>
-            <a:pPr algn="l">
-              <a:spcBef>
-                <a:spcPts val="0"/>
-              </a:spcBef>
-              <a:spcAft>
-                <a:spcPts val="0"/>
-              </a:spcAft>
-            </a:pPr>
-            <a:r>
-              <a:rPr sz="1000" b="1">
-                <a:solidFill>
-                  <a:srgbClr val="1A1A1A"/>
-                </a:solidFill>
-                <a:latin typeface="Calibri"/>
-              </a:rPr>
-              <a:t>Response Time</a:t>
-            </a:r>
-          </a:p>
-        </p:txBody>
-      </p:sp>
-      <p:sp>
-        <p:nvSpPr>
-          <p:cNvPr id="36" name="TextBox 35"/>
-          <p:cNvSpPr txBox="1"/>
-          <p:nvPr/>
-        </p:nvSpPr>
-        <p:spPr>
-          <a:xfrm>
-            <a:off x="274320" y="3703320"/>
-            <a:ext cx="2103120" cy="1463040"/>
+            <a:off x="685800" y="3377184"/>
+            <a:ext cx="11292840" cy="777240"/>
           </a:xfrm>
           <a:prstGeom prst="rect">
             <a:avLst/>
@@ -9244,84 +8223,37 @@
           </a:bodyPr>
           <a:lstStyle/>
           <a:p>
-            <a:endParaRPr/>
-          </a:p>
-          <a:p>
-            <a:pPr algn="l">
-              <a:spcBef>
-                <a:spcPts val="0"/>
-              </a:spcBef>
-              <a:spcAft>
-                <a:spcPts val="0"/>
-              </a:spcAft>
-            </a:pPr>
-            <a:r>
-              <a:rPr sz="900" b="0">
-                <a:solidFill>
-                  <a:srgbClr val="1A1A1A"/>
-                </a:solidFill>
-                <a:latin typeface="Calibri"/>
-              </a:rPr>
-              <a:t>Avg days: Strauss outbound → first supplier reply</a:t>
-            </a:r>
-          </a:p>
-        </p:txBody>
-      </p:sp>
-      <p:sp>
-        <p:nvSpPr>
-          <p:cNvPr id="37" name="TextBox 36"/>
+            <a:r>
+              <a:rPr b="0" sz="1300">
+                <a:solidFill>
+                  <a:srgbClr val="1A1A1A"/>
+                </a:solidFill>
+              </a:rPr>
+              <a:t>% of upcoming meetings where the manager opens and uses the prep packet.</a:t>
+            </a:r>
+          </a:p>
+          <a:p>
+            <a:r>
+              <a:rPr b="0" sz="1300">
+                <a:solidFill>
+                  <a:srgbClr val="1A1A1A"/>
+                </a:solidFill>
+              </a:rPr>
+              <a:t>Target: &gt;80% by Phase 2.</a:t>
+            </a:r>
+          </a:p>
+        </p:txBody>
+      </p:sp>
+      <p:sp>
+        <p:nvSpPr>
+          <p:cNvPr id="15" name="TextBox 14"/>
           <p:cNvSpPr txBox="1"/>
           <p:nvPr/>
         </p:nvSpPr>
         <p:spPr>
           <a:xfrm>
-            <a:off x="274320" y="6263640"/>
-            <a:ext cx="2103120" cy="274320"/>
-          </a:xfrm>
-          <a:prstGeom prst="rect">
-            <a:avLst/>
-          </a:prstGeom>
-          <a:noFill/>
-        </p:spPr>
-        <p:txBody>
-          <a:bodyPr wrap="none">
-            <a:spAutoFit/>
-          </a:bodyPr>
-          <a:lstStyle/>
-          <a:p>
-            <a:endParaRPr/>
-          </a:p>
-          <a:p>
-            <a:pPr algn="l">
-              <a:spcBef>
-                <a:spcPts val="0"/>
-              </a:spcBef>
-              <a:spcAft>
-                <a:spcPts val="0"/>
-              </a:spcAft>
-            </a:pPr>
-            <a:r>
-              <a:rPr sz="700" b="0">
-                <a:solidFill>
-                  <a:srgbClr val="555555"/>
-                </a:solidFill>
-                <a:latin typeface="Calibri"/>
-              </a:rPr>
-              <a:t>kpi_response_days</a:t>
-            </a:r>
-          </a:p>
-        </p:txBody>
-      </p:sp>
-      <p:sp>
-        <p:nvSpPr>
-          <p:cNvPr id="38" name="TextBox 37"/>
-          <p:cNvSpPr txBox="1"/>
-          <p:nvPr/>
-        </p:nvSpPr>
-        <p:spPr>
-          <a:xfrm>
-            <a:off x="274320" y="5212080"/>
-            <a:ext cx="2103120" cy="1005840"/>
+            <a:off x="685800" y="4154424"/>
+            <a:ext cx="11292840" cy="502920"/>
           </a:xfrm>
           <a:prstGeom prst="rect">
             <a:avLst/>
@@ -9334,58 +8266,36 @@
           </a:bodyPr>
           <a:lstStyle/>
           <a:p>
-            <a:endParaRPr/>
-          </a:p>
-          <a:p>
-            <a:pPr algn="l">
-              <a:spcBef>
-                <a:spcPts val="0"/>
-              </a:spcBef>
-              <a:spcAft>
-                <a:spcPts val="0"/>
-              </a:spcAft>
-            </a:pPr>
-            <a:r>
-              <a:rPr sz="800" b="0">
-                <a:solidFill>
-                  <a:srgbClr val="C8102E"/>
-                </a:solidFill>
-                <a:latin typeface="Calibri"/>
-              </a:rPr>
-              <a:t>Benchmark: &lt;5d healthy
-&gt;14d = relationship risk</a:t>
-            </a:r>
-            <a:r>
-              <a:t/>
-            </a:r>
-            <a:br/>
-            <a:r>
-              <a:t>&gt;14d = relationship risk</a:t>
-            </a:r>
-          </a:p>
-        </p:txBody>
-      </p:sp>
-      <p:sp>
-        <p:nvSpPr>
-          <p:cNvPr id="39" name="Rectangle 38"/>
+            <a:r>
+              <a:rPr b="0" sz="1000">
+                <a:solidFill>
+                  <a:srgbClr val="555555"/>
+                </a:solidFill>
+              </a:rPr>
+              <a:t>Tracked via session logs (page views per scheduled meeting in calendar feed).</a:t>
+            </a:r>
+          </a:p>
+        </p:txBody>
+      </p:sp>
+      <p:sp>
+        <p:nvSpPr>
+          <p:cNvPr id="16" name="Rectangle 15"/>
           <p:cNvSpPr/>
           <p:nvPr/>
         </p:nvSpPr>
         <p:spPr>
           <a:xfrm>
-            <a:off x="2560320" y="3364992"/>
-            <a:ext cx="2286000" cy="3246120"/>
+            <a:off x="182880" y="4770120"/>
+            <a:ext cx="11795760" cy="9144"/>
           </a:xfrm>
           <a:prstGeom prst="rect">
             <a:avLst/>
           </a:prstGeom>
           <a:solidFill>
-            <a:srgbClr val="FFFFFF"/>
+            <a:srgbClr val="DDDDDD"/>
           </a:solidFill>
           <a:ln>
-            <a:solidFill>
-              <a:srgbClr val="DDDDDD"/>
-            </a:solidFill>
+            <a:noFill/>
           </a:ln>
         </p:spPr>
         <p:style>
@@ -9407,20 +8317,19 @@
           <a:lstStyle/>
           <a:p>
             <a:pPr algn="ctr"/>
-            <a:endParaRPr/>
-          </a:p>
-        </p:txBody>
-      </p:sp>
-      <p:sp>
-        <p:nvSpPr>
-          <p:cNvPr id="40" name="Rectangle 39"/>
+          </a:p>
+        </p:txBody>
+      </p:sp>
+      <p:sp>
+        <p:nvSpPr>
+          <p:cNvPr id="17" name="Rectangle 16"/>
           <p:cNvSpPr/>
           <p:nvPr/>
         </p:nvSpPr>
         <p:spPr>
           <a:xfrm>
-            <a:off x="2651760" y="3410712"/>
-            <a:ext cx="384048" cy="237744"/>
+            <a:off x="182880" y="4879848"/>
+            <a:ext cx="411480" cy="365760"/>
           </a:xfrm>
           <a:prstGeom prst="rect">
             <a:avLst/>
@@ -9447,24 +8356,31 @@
           </a:fontRef>
         </p:style>
         <p:txBody>
-          <a:bodyPr rtlCol="0" anchor="ctr"/>
+          <a:bodyPr rtlCol="0" anchor="ctr" wrap="none"/>
           <a:lstStyle/>
           <a:p>
             <a:pPr algn="ctr"/>
-            <a:endParaRPr/>
-          </a:p>
-        </p:txBody>
-      </p:sp>
-      <p:sp>
-        <p:nvSpPr>
-          <p:cNvPr id="41" name="TextBox 40"/>
+            <a:r>
+              <a:rPr b="1" sz="1400">
+                <a:solidFill>
+                  <a:srgbClr val="FFFFFF"/>
+                </a:solidFill>
+              </a:rPr>
+              <a:t>3</a:t>
+            </a:r>
+          </a:p>
+        </p:txBody>
+      </p:sp>
+      <p:sp>
+        <p:nvSpPr>
+          <p:cNvPr id="18" name="TextBox 17"/>
           <p:cNvSpPr txBox="1"/>
           <p:nvPr/>
         </p:nvSpPr>
         <p:spPr>
           <a:xfrm>
-            <a:off x="2660904" y="3419856"/>
-            <a:ext cx="365760" cy="201168"/>
+            <a:off x="685800" y="4861560"/>
+            <a:ext cx="11292840" cy="329184"/>
           </a:xfrm>
           <a:prstGeom prst="rect">
             <a:avLst/>
@@ -9477,84 +8393,27 @@
           </a:bodyPr>
           <a:lstStyle/>
           <a:p>
-            <a:endParaRPr/>
-          </a:p>
-          <a:p>
-            <a:pPr algn="ctr">
-              <a:spcBef>
-                <a:spcPts val="0"/>
-              </a:spcBef>
-              <a:spcAft>
-                <a:spcPts val="0"/>
-              </a:spcAft>
-            </a:pPr>
-            <a:r>
-              <a:rPr sz="800" b="1">
-                <a:solidFill>
-                  <a:srgbClr val="FFFFFF"/>
-                </a:solidFill>
-                <a:latin typeface="Calibri"/>
-              </a:rPr>
-              <a:t>§2</a:t>
-            </a:r>
-          </a:p>
-        </p:txBody>
-      </p:sp>
-      <p:sp>
-        <p:nvSpPr>
-          <p:cNvPr id="42" name="TextBox 41"/>
+            <a:r>
+              <a:rPr b="1" sz="1600">
+                <a:solidFill>
+                  <a:srgbClr val="1A1A1A"/>
+                </a:solidFill>
+              </a:rPr>
+              <a:t>Correction / Override Rate</a:t>
+            </a:r>
+          </a:p>
+        </p:txBody>
+      </p:sp>
+      <p:sp>
+        <p:nvSpPr>
+          <p:cNvPr id="19" name="TextBox 18"/>
           <p:cNvSpPr txBox="1"/>
           <p:nvPr/>
         </p:nvSpPr>
         <p:spPr>
           <a:xfrm>
-            <a:off x="3108960" y="3410712"/>
-            <a:ext cx="1645920" cy="256032"/>
-          </a:xfrm>
-          <a:prstGeom prst="rect">
-            <a:avLst/>
-          </a:prstGeom>
-          <a:noFill/>
-        </p:spPr>
-        <p:txBody>
-          <a:bodyPr wrap="none">
-            <a:spAutoFit/>
-          </a:bodyPr>
-          <a:lstStyle/>
-          <a:p>
-            <a:endParaRPr/>
-          </a:p>
-          <a:p>
-            <a:pPr algn="l">
-              <a:spcBef>
-                <a:spcPts val="0"/>
-              </a:spcBef>
-              <a:spcAft>
-                <a:spcPts val="0"/>
-              </a:spcAft>
-            </a:pPr>
-            <a:r>
-              <a:rPr sz="1000" b="1">
-                <a:solidFill>
-                  <a:srgbClr val="1A1A1A"/>
-                </a:solidFill>
-                <a:latin typeface="Calibri"/>
-              </a:rPr>
-              <a:t>Open Issues</a:t>
-            </a:r>
-          </a:p>
-        </p:txBody>
-      </p:sp>
-      <p:sp>
-        <p:nvSpPr>
-          <p:cNvPr id="43" name="TextBox 42"/>
-          <p:cNvSpPr txBox="1"/>
-          <p:nvPr/>
-        </p:nvSpPr>
-        <p:spPr>
-          <a:xfrm>
-            <a:off x="2651760" y="3703320"/>
-            <a:ext cx="2103120" cy="1463040"/>
+            <a:off x="685800" y="5245608"/>
+            <a:ext cx="11292840" cy="777240"/>
           </a:xfrm>
           <a:prstGeom prst="rect">
             <a:avLst/>
@@ -9567,84 +8426,37 @@
           </a:bodyPr>
           <a:lstStyle/>
           <a:p>
-            <a:endParaRPr/>
-          </a:p>
-          <a:p>
-            <a:pPr algn="l">
-              <a:spcBef>
-                <a:spcPts val="0"/>
-              </a:spcBef>
-              <a:spcAft>
-                <a:spcPts val="0"/>
-              </a:spcAft>
-            </a:pPr>
-            <a:r>
-              <a:rPr sz="900" b="0">
-                <a:solidFill>
-                  <a:srgbClr val="1A1A1A"/>
-                </a:solidFill>
-                <a:latin typeface="Calibri"/>
-              </a:rPr>
-              <a:t>Count of unresolved disputes, threads, contract gaps per supplier</a:t>
-            </a:r>
-          </a:p>
-        </p:txBody>
-      </p:sp>
-      <p:sp>
-        <p:nvSpPr>
-          <p:cNvPr id="44" name="TextBox 43"/>
+            <a:r>
+              <a:rPr b="0" sz="1300">
+                <a:solidFill>
+                  <a:srgbClr val="1A1A1A"/>
+                </a:solidFill>
+              </a:rPr>
+              <a:t>% of AI-extracted fields the manager manually flags or corrects.</a:t>
+            </a:r>
+          </a:p>
+          <a:p>
+            <a:r>
+              <a:rPr b="0" sz="1300">
+                <a:solidFill>
+                  <a:srgbClr val="1A1A1A"/>
+                </a:solidFill>
+              </a:rPr>
+              <a:t>Target: &lt;15% by Phase 2,  &lt;10% by day 90.</a:t>
+            </a:r>
+          </a:p>
+        </p:txBody>
+      </p:sp>
+      <p:sp>
+        <p:nvSpPr>
+          <p:cNvPr id="20" name="TextBox 19"/>
           <p:cNvSpPr txBox="1"/>
           <p:nvPr/>
         </p:nvSpPr>
         <p:spPr>
           <a:xfrm>
-            <a:off x="2651760" y="6263640"/>
-            <a:ext cx="2103120" cy="274320"/>
-          </a:xfrm>
-          <a:prstGeom prst="rect">
-            <a:avLst/>
-          </a:prstGeom>
-          <a:noFill/>
-        </p:spPr>
-        <p:txBody>
-          <a:bodyPr wrap="none">
-            <a:spAutoFit/>
-          </a:bodyPr>
-          <a:lstStyle/>
-          <a:p>
-            <a:endParaRPr/>
-          </a:p>
-          <a:p>
-            <a:pPr algn="l">
-              <a:spcBef>
-                <a:spcPts val="0"/>
-              </a:spcBef>
-              <a:spcAft>
-                <a:spcPts val="0"/>
-              </a:spcAft>
-            </a:pPr>
-            <a:r>
-              <a:rPr sz="700" b="0">
-                <a:solidFill>
-                  <a:srgbClr val="555555"/>
-                </a:solidFill>
-                <a:latin typeface="Calibri"/>
-              </a:rPr>
-              <a:t>kpi_open_issues</a:t>
-            </a:r>
-          </a:p>
-        </p:txBody>
-      </p:sp>
-      <p:sp>
-        <p:nvSpPr>
-          <p:cNvPr id="45" name="TextBox 44"/>
-          <p:cNvSpPr txBox="1"/>
-          <p:nvPr/>
-        </p:nvSpPr>
-        <p:spPr>
-          <a:xfrm>
-            <a:off x="2651760" y="5212080"/>
-            <a:ext cx="2103120" cy="1005840"/>
+            <a:off x="685800" y="6022848"/>
+            <a:ext cx="11292840" cy="502920"/>
           </a:xfrm>
           <a:prstGeom prst="rect">
             <a:avLst/>
@@ -9657,1002 +8469,13 @@
           </a:bodyPr>
           <a:lstStyle/>
           <a:p>
-            <a:endParaRPr/>
-          </a:p>
-          <a:p>
-            <a:pPr algn="l">
-              <a:spcBef>
-                <a:spcPts val="0"/>
-              </a:spcBef>
-              <a:spcAft>
-                <a:spcPts val="0"/>
-              </a:spcAft>
-            </a:pPr>
-            <a:r>
-              <a:rPr sz="800" b="0">
-                <a:solidFill>
-                  <a:srgbClr val="C8102E"/>
-                </a:solidFill>
-                <a:latin typeface="Calibri"/>
-              </a:rPr>
-              <a:t>Target: 0 open
-Each one costs prep time</a:t>
-            </a:r>
-            <a:r>
-              <a:t/>
-            </a:r>
-            <a:br/>
-            <a:r>
-              <a:t>Each one costs prep time</a:t>
-            </a:r>
-          </a:p>
-        </p:txBody>
-      </p:sp>
-      <p:sp>
-        <p:nvSpPr>
-          <p:cNvPr id="46" name="Rectangle 45"/>
-          <p:cNvSpPr/>
-          <p:nvPr/>
-        </p:nvSpPr>
-        <p:spPr>
-          <a:xfrm>
-            <a:off x="4937760" y="3364992"/>
-            <a:ext cx="2286000" cy="3246120"/>
-          </a:xfrm>
-          <a:prstGeom prst="rect">
-            <a:avLst/>
-          </a:prstGeom>
-          <a:solidFill>
-            <a:srgbClr val="F0F0F0"/>
-          </a:solidFill>
-          <a:ln>
-            <a:solidFill>
-              <a:srgbClr val="DDDDDD"/>
-            </a:solidFill>
-          </a:ln>
-        </p:spPr>
-        <p:style>
-          <a:lnRef idx="1">
-            <a:schemeClr val="accent1"/>
-          </a:lnRef>
-          <a:fillRef idx="3">
-            <a:schemeClr val="accent1"/>
-          </a:fillRef>
-          <a:effectRef idx="2">
-            <a:schemeClr val="accent1"/>
-          </a:effectRef>
-          <a:fontRef idx="minor">
-            <a:schemeClr val="lt1"/>
-          </a:fontRef>
-        </p:style>
-        <p:txBody>
-          <a:bodyPr rtlCol="0" anchor="ctr"/>
-          <a:lstStyle/>
-          <a:p>
-            <a:pPr algn="ctr"/>
-            <a:endParaRPr/>
-          </a:p>
-        </p:txBody>
-      </p:sp>
-      <p:sp>
-        <p:nvSpPr>
-          <p:cNvPr id="47" name="Rectangle 46"/>
-          <p:cNvSpPr/>
-          <p:nvPr/>
-        </p:nvSpPr>
-        <p:spPr>
-          <a:xfrm>
-            <a:off x="5029200" y="3410712"/>
-            <a:ext cx="384048" cy="237744"/>
-          </a:xfrm>
-          <a:prstGeom prst="rect">
-            <a:avLst/>
-          </a:prstGeom>
-          <a:solidFill>
-            <a:srgbClr val="C8102E"/>
-          </a:solidFill>
-          <a:ln>
-            <a:noFill/>
-          </a:ln>
-        </p:spPr>
-        <p:style>
-          <a:lnRef idx="1">
-            <a:schemeClr val="accent1"/>
-          </a:lnRef>
-          <a:fillRef idx="3">
-            <a:schemeClr val="accent1"/>
-          </a:fillRef>
-          <a:effectRef idx="2">
-            <a:schemeClr val="accent1"/>
-          </a:effectRef>
-          <a:fontRef idx="minor">
-            <a:schemeClr val="lt1"/>
-          </a:fontRef>
-        </p:style>
-        <p:txBody>
-          <a:bodyPr rtlCol="0" anchor="ctr"/>
-          <a:lstStyle/>
-          <a:p>
-            <a:pPr algn="ctr"/>
-            <a:endParaRPr/>
-          </a:p>
-        </p:txBody>
-      </p:sp>
-      <p:sp>
-        <p:nvSpPr>
-          <p:cNvPr id="48" name="TextBox 47"/>
-          <p:cNvSpPr txBox="1"/>
-          <p:nvPr/>
-        </p:nvSpPr>
-        <p:spPr>
-          <a:xfrm>
-            <a:off x="5038344" y="3419856"/>
-            <a:ext cx="365760" cy="201168"/>
-          </a:xfrm>
-          <a:prstGeom prst="rect">
-            <a:avLst/>
-          </a:prstGeom>
-          <a:noFill/>
-        </p:spPr>
-        <p:txBody>
-          <a:bodyPr wrap="none">
-            <a:spAutoFit/>
-          </a:bodyPr>
-          <a:lstStyle/>
-          <a:p>
-            <a:endParaRPr/>
-          </a:p>
-          <a:p>
-            <a:pPr algn="ctr">
-              <a:spcBef>
-                <a:spcPts val="0"/>
-              </a:spcBef>
-              <a:spcAft>
-                <a:spcPts val="0"/>
-              </a:spcAft>
-            </a:pPr>
-            <a:r>
-              <a:rPr sz="800" b="1">
-                <a:solidFill>
-                  <a:srgbClr val="FFFFFF"/>
-                </a:solidFill>
-                <a:latin typeface="Calibri"/>
-              </a:rPr>
-              <a:t>§3</a:t>
-            </a:r>
-          </a:p>
-        </p:txBody>
-      </p:sp>
-      <p:sp>
-        <p:nvSpPr>
-          <p:cNvPr id="49" name="TextBox 48"/>
-          <p:cNvSpPr txBox="1"/>
-          <p:nvPr/>
-        </p:nvSpPr>
-        <p:spPr>
-          <a:xfrm>
-            <a:off x="5486400" y="3410712"/>
-            <a:ext cx="1645920" cy="256032"/>
-          </a:xfrm>
-          <a:prstGeom prst="rect">
-            <a:avLst/>
-          </a:prstGeom>
-          <a:noFill/>
-        </p:spPr>
-        <p:txBody>
-          <a:bodyPr wrap="none">
-            <a:spAutoFit/>
-          </a:bodyPr>
-          <a:lstStyle/>
-          <a:p>
-            <a:endParaRPr/>
-          </a:p>
-          <a:p>
-            <a:pPr algn="l">
-              <a:spcBef>
-                <a:spcPts val="0"/>
-              </a:spcBef>
-              <a:spcAft>
-                <a:spcPts val="0"/>
-              </a:spcAft>
-            </a:pPr>
-            <a:r>
-              <a:rPr sz="1000" b="1">
-                <a:solidFill>
-                  <a:srgbClr val="1A1A1A"/>
-                </a:solidFill>
-                <a:latin typeface="Calibri"/>
-              </a:rPr>
-              <a:t>Price Delta</a:t>
-            </a:r>
-          </a:p>
-        </p:txBody>
-      </p:sp>
-      <p:sp>
-        <p:nvSpPr>
-          <p:cNvPr id="50" name="TextBox 49"/>
-          <p:cNvSpPr txBox="1"/>
-          <p:nvPr/>
-        </p:nvSpPr>
-        <p:spPr>
-          <a:xfrm>
-            <a:off x="5029200" y="3703320"/>
-            <a:ext cx="2103120" cy="1463040"/>
-          </a:xfrm>
-          <a:prstGeom prst="rect">
-            <a:avLst/>
-          </a:prstGeom>
-          <a:noFill/>
-        </p:spPr>
-        <p:txBody>
-          <a:bodyPr wrap="square">
-            <a:spAutoFit/>
-          </a:bodyPr>
-          <a:lstStyle/>
-          <a:p>
-            <a:endParaRPr/>
-          </a:p>
-          <a:p>
-            <a:pPr algn="l">
-              <a:spcBef>
-                <a:spcPts val="0"/>
-              </a:spcBef>
-              <a:spcAft>
-                <a:spcPts val="0"/>
-              </a:spcAft>
-            </a:pPr>
-            <a:r>
-              <a:rPr sz="900" b="0">
-                <a:solidFill>
-                  <a:srgbClr val="1A1A1A"/>
-                </a:solidFill>
-                <a:latin typeface="Calibri"/>
-              </a:rPr>
-              <a:t>Latest email quote vs contract base price — % and absolute</a:t>
-            </a:r>
-          </a:p>
-        </p:txBody>
-      </p:sp>
-      <p:sp>
-        <p:nvSpPr>
-          <p:cNvPr id="51" name="TextBox 50"/>
-          <p:cNvSpPr txBox="1"/>
-          <p:nvPr/>
-        </p:nvSpPr>
-        <p:spPr>
-          <a:xfrm>
-            <a:off x="5029200" y="6263640"/>
-            <a:ext cx="2103120" cy="274320"/>
-          </a:xfrm>
-          <a:prstGeom prst="rect">
-            <a:avLst/>
-          </a:prstGeom>
-          <a:noFill/>
-        </p:spPr>
-        <p:txBody>
-          <a:bodyPr wrap="none">
-            <a:spAutoFit/>
-          </a:bodyPr>
-          <a:lstStyle/>
-          <a:p>
-            <a:endParaRPr/>
-          </a:p>
-          <a:p>
-            <a:pPr algn="l">
-              <a:spcBef>
-                <a:spcPts val="0"/>
-              </a:spcBef>
-              <a:spcAft>
-                <a:spcPts val="0"/>
-              </a:spcAft>
-            </a:pPr>
-            <a:r>
-              <a:rPr sz="700" b="0">
+            <a:r>
+              <a:rPr b="0" sz="1000">
                 <a:solidFill>
                   <a:srgbClr val="555555"/>
                 </a:solidFill>
-                <a:latin typeface="Calibri"/>
-              </a:rPr>
-              <a:t>kpi_price_delta_pct</a:t>
-            </a:r>
-          </a:p>
-        </p:txBody>
-      </p:sp>
-      <p:sp>
-        <p:nvSpPr>
-          <p:cNvPr id="52" name="TextBox 51"/>
-          <p:cNvSpPr txBox="1"/>
-          <p:nvPr/>
-        </p:nvSpPr>
-        <p:spPr>
-          <a:xfrm>
-            <a:off x="5029200" y="5212080"/>
-            <a:ext cx="2103120" cy="1005840"/>
-          </a:xfrm>
-          <a:prstGeom prst="rect">
-            <a:avLst/>
-          </a:prstGeom>
-          <a:noFill/>
-        </p:spPr>
-        <p:txBody>
-          <a:bodyPr wrap="square">
-            <a:spAutoFit/>
-          </a:bodyPr>
-          <a:lstStyle/>
-          <a:p>
-            <a:endParaRPr/>
-          </a:p>
-          <a:p>
-            <a:pPr algn="l">
-              <a:spcBef>
-                <a:spcPts val="0"/>
-              </a:spcBef>
-              <a:spcAft>
-                <a:spcPts val="0"/>
-              </a:spcAft>
-            </a:pPr>
-            <a:r>
-              <a:rPr sz="800" b="0">
-                <a:solidFill>
-                  <a:srgbClr val="C8102E"/>
-                </a:solidFill>
-                <a:latin typeface="Calibri"/>
-              </a:rPr>
-              <a:t>Alert if &gt;0%
-without written amendment</a:t>
-            </a:r>
-            <a:r>
-              <a:t/>
-            </a:r>
-            <a:br/>
-            <a:r>
-              <a:t>without written amendment</a:t>
-            </a:r>
-          </a:p>
-        </p:txBody>
-      </p:sp>
-      <p:sp>
-        <p:nvSpPr>
-          <p:cNvPr id="53" name="Rectangle 52"/>
-          <p:cNvSpPr/>
-          <p:nvPr/>
-        </p:nvSpPr>
-        <p:spPr>
-          <a:xfrm>
-            <a:off x="7315200" y="3364992"/>
-            <a:ext cx="2286000" cy="3246120"/>
-          </a:xfrm>
-          <a:prstGeom prst="rect">
-            <a:avLst/>
-          </a:prstGeom>
-          <a:solidFill>
-            <a:srgbClr val="FFFFFF"/>
-          </a:solidFill>
-          <a:ln>
-            <a:solidFill>
-              <a:srgbClr val="DDDDDD"/>
-            </a:solidFill>
-          </a:ln>
-        </p:spPr>
-        <p:style>
-          <a:lnRef idx="1">
-            <a:schemeClr val="accent1"/>
-          </a:lnRef>
-          <a:fillRef idx="3">
-            <a:schemeClr val="accent1"/>
-          </a:fillRef>
-          <a:effectRef idx="2">
-            <a:schemeClr val="accent1"/>
-          </a:effectRef>
-          <a:fontRef idx="minor">
-            <a:schemeClr val="lt1"/>
-          </a:fontRef>
-        </p:style>
-        <p:txBody>
-          <a:bodyPr rtlCol="0" anchor="ctr"/>
-          <a:lstStyle/>
-          <a:p>
-            <a:pPr algn="ctr"/>
-            <a:endParaRPr/>
-          </a:p>
-        </p:txBody>
-      </p:sp>
-      <p:sp>
-        <p:nvSpPr>
-          <p:cNvPr id="54" name="Rectangle 53"/>
-          <p:cNvSpPr/>
-          <p:nvPr/>
-        </p:nvSpPr>
-        <p:spPr>
-          <a:xfrm>
-            <a:off x="7406640" y="3410712"/>
-            <a:ext cx="384048" cy="237744"/>
-          </a:xfrm>
-          <a:prstGeom prst="rect">
-            <a:avLst/>
-          </a:prstGeom>
-          <a:solidFill>
-            <a:srgbClr val="C8102E"/>
-          </a:solidFill>
-          <a:ln>
-            <a:noFill/>
-          </a:ln>
-        </p:spPr>
-        <p:style>
-          <a:lnRef idx="1">
-            <a:schemeClr val="accent1"/>
-          </a:lnRef>
-          <a:fillRef idx="3">
-            <a:schemeClr val="accent1"/>
-          </a:fillRef>
-          <a:effectRef idx="2">
-            <a:schemeClr val="accent1"/>
-          </a:effectRef>
-          <a:fontRef idx="minor">
-            <a:schemeClr val="lt1"/>
-          </a:fontRef>
-        </p:style>
-        <p:txBody>
-          <a:bodyPr rtlCol="0" anchor="ctr"/>
-          <a:lstStyle/>
-          <a:p>
-            <a:pPr algn="ctr"/>
-            <a:endParaRPr/>
-          </a:p>
-        </p:txBody>
-      </p:sp>
-      <p:sp>
-        <p:nvSpPr>
-          <p:cNvPr id="55" name="TextBox 54"/>
-          <p:cNvSpPr txBox="1"/>
-          <p:nvPr/>
-        </p:nvSpPr>
-        <p:spPr>
-          <a:xfrm>
-            <a:off x="7415783" y="3419856"/>
-            <a:ext cx="365760" cy="201168"/>
-          </a:xfrm>
-          <a:prstGeom prst="rect">
-            <a:avLst/>
-          </a:prstGeom>
-          <a:noFill/>
-        </p:spPr>
-        <p:txBody>
-          <a:bodyPr wrap="none">
-            <a:spAutoFit/>
-          </a:bodyPr>
-          <a:lstStyle/>
-          <a:p>
-            <a:endParaRPr/>
-          </a:p>
-          <a:p>
-            <a:pPr algn="ctr">
-              <a:spcBef>
-                <a:spcPts val="0"/>
-              </a:spcBef>
-              <a:spcAft>
-                <a:spcPts val="0"/>
-              </a:spcAft>
-            </a:pPr>
-            <a:r>
-              <a:rPr sz="800" b="1">
-                <a:solidFill>
-                  <a:srgbClr val="FFFFFF"/>
-                </a:solidFill>
-                <a:latin typeface="Calibri"/>
-              </a:rPr>
-              <a:t>§4</a:t>
-            </a:r>
-          </a:p>
-        </p:txBody>
-      </p:sp>
-      <p:sp>
-        <p:nvSpPr>
-          <p:cNvPr id="56" name="TextBox 55"/>
-          <p:cNvSpPr txBox="1"/>
-          <p:nvPr/>
-        </p:nvSpPr>
-        <p:spPr>
-          <a:xfrm>
-            <a:off x="7863840" y="3410712"/>
-            <a:ext cx="1645920" cy="256032"/>
-          </a:xfrm>
-          <a:prstGeom prst="rect">
-            <a:avLst/>
-          </a:prstGeom>
-          <a:noFill/>
-        </p:spPr>
-        <p:txBody>
-          <a:bodyPr wrap="none">
-            <a:spAutoFit/>
-          </a:bodyPr>
-          <a:lstStyle/>
-          <a:p>
-            <a:endParaRPr/>
-          </a:p>
-          <a:p>
-            <a:pPr algn="l">
-              <a:spcBef>
-                <a:spcPts val="0"/>
-              </a:spcBef>
-              <a:spcAft>
-                <a:spcPts val="0"/>
-              </a:spcAft>
-            </a:pPr>
-            <a:r>
-              <a:rPr sz="1000" b="1">
-                <a:solidFill>
-                  <a:srgbClr val="1A1A1A"/>
-                </a:solidFill>
-                <a:latin typeface="Calibri"/>
-              </a:rPr>
-              <a:t>Days to Renewal</a:t>
-            </a:r>
-          </a:p>
-        </p:txBody>
-      </p:sp>
-      <p:sp>
-        <p:nvSpPr>
-          <p:cNvPr id="57" name="TextBox 56"/>
-          <p:cNvSpPr txBox="1"/>
-          <p:nvPr/>
-        </p:nvSpPr>
-        <p:spPr>
-          <a:xfrm>
-            <a:off x="7406640" y="3703320"/>
-            <a:ext cx="2103120" cy="1463040"/>
-          </a:xfrm>
-          <a:prstGeom prst="rect">
-            <a:avLst/>
-          </a:prstGeom>
-          <a:noFill/>
-        </p:spPr>
-        <p:txBody>
-          <a:bodyPr wrap="square">
-            <a:spAutoFit/>
-          </a:bodyPr>
-          <a:lstStyle/>
-          <a:p>
-            <a:endParaRPr/>
-          </a:p>
-          <a:p>
-            <a:pPr algn="l">
-              <a:spcBef>
-                <a:spcPts val="0"/>
-              </a:spcBef>
-              <a:spcAft>
-                <a:spcPts val="0"/>
-              </a:spcAft>
-            </a:pPr>
-            <a:r>
-              <a:rPr sz="900" b="0">
-                <a:solidFill>
-                  <a:srgbClr val="1A1A1A"/>
-                </a:solidFill>
-                <a:latin typeface="Calibri"/>
-              </a:rPr>
-              <a:t>Calendar days to contract renewal date; red &lt;30d</a:t>
-            </a:r>
-          </a:p>
-        </p:txBody>
-      </p:sp>
-      <p:sp>
-        <p:nvSpPr>
-          <p:cNvPr id="58" name="TextBox 57"/>
-          <p:cNvSpPr txBox="1"/>
-          <p:nvPr/>
-        </p:nvSpPr>
-        <p:spPr>
-          <a:xfrm>
-            <a:off x="7406640" y="6263640"/>
-            <a:ext cx="2103120" cy="274320"/>
-          </a:xfrm>
-          <a:prstGeom prst="rect">
-            <a:avLst/>
-          </a:prstGeom>
-          <a:noFill/>
-        </p:spPr>
-        <p:txBody>
-          <a:bodyPr wrap="none">
-            <a:spAutoFit/>
-          </a:bodyPr>
-          <a:lstStyle/>
-          <a:p>
-            <a:endParaRPr/>
-          </a:p>
-          <a:p>
-            <a:pPr algn="l">
-              <a:spcBef>
-                <a:spcPts val="0"/>
-              </a:spcBef>
-              <a:spcAft>
-                <a:spcPts val="0"/>
-              </a:spcAft>
-            </a:pPr>
-            <a:r>
-              <a:rPr sz="700" b="0">
-                <a:solidFill>
-                  <a:srgbClr val="555555"/>
-                </a:solidFill>
-                <a:latin typeface="Calibri"/>
-              </a:rPr>
-              <a:t>kpi_days_to_renewal</a:t>
-            </a:r>
-          </a:p>
-        </p:txBody>
-      </p:sp>
-      <p:sp>
-        <p:nvSpPr>
-          <p:cNvPr id="59" name="TextBox 58"/>
-          <p:cNvSpPr txBox="1"/>
-          <p:nvPr/>
-        </p:nvSpPr>
-        <p:spPr>
-          <a:xfrm>
-            <a:off x="7406640" y="5212080"/>
-            <a:ext cx="2103120" cy="1005840"/>
-          </a:xfrm>
-          <a:prstGeom prst="rect">
-            <a:avLst/>
-          </a:prstGeom>
-          <a:noFill/>
-        </p:spPr>
-        <p:txBody>
-          <a:bodyPr wrap="square">
-            <a:spAutoFit/>
-          </a:bodyPr>
-          <a:lstStyle/>
-          <a:p>
-            <a:endParaRPr/>
-          </a:p>
-          <a:p>
-            <a:pPr algn="l">
-              <a:spcBef>
-                <a:spcPts val="0"/>
-              </a:spcBef>
-              <a:spcAft>
-                <a:spcPts val="0"/>
-              </a:spcAft>
-            </a:pPr>
-            <a:r>
-              <a:rPr sz="800" b="0">
-                <a:solidFill>
-                  <a:srgbClr val="C8102E"/>
-                </a:solidFill>
-                <a:latin typeface="Calibri"/>
-              </a:rPr>
-              <a:t>Red &lt;30d, amber 30-90d
-auto-renewal notice shown</a:t>
-            </a:r>
-            <a:r>
-              <a:t/>
-            </a:r>
-            <a:br/>
-            <a:r>
-              <a:t>auto-renewal notice shown</a:t>
-            </a:r>
-          </a:p>
-        </p:txBody>
-      </p:sp>
-      <p:sp>
-        <p:nvSpPr>
-          <p:cNvPr id="60" name="Rectangle 59"/>
-          <p:cNvSpPr/>
-          <p:nvPr/>
-        </p:nvSpPr>
-        <p:spPr>
-          <a:xfrm>
-            <a:off x="9692640" y="3364992"/>
-            <a:ext cx="2286000" cy="3246120"/>
-          </a:xfrm>
-          <a:prstGeom prst="rect">
-            <a:avLst/>
-          </a:prstGeom>
-          <a:solidFill>
-            <a:srgbClr val="F0F0F0"/>
-          </a:solidFill>
-          <a:ln>
-            <a:solidFill>
-              <a:srgbClr val="DDDDDD"/>
-            </a:solidFill>
-          </a:ln>
-        </p:spPr>
-        <p:style>
-          <a:lnRef idx="1">
-            <a:schemeClr val="accent1"/>
-          </a:lnRef>
-          <a:fillRef idx="3">
-            <a:schemeClr val="accent1"/>
-          </a:fillRef>
-          <a:effectRef idx="2">
-            <a:schemeClr val="accent1"/>
-          </a:effectRef>
-          <a:fontRef idx="minor">
-            <a:schemeClr val="lt1"/>
-          </a:fontRef>
-        </p:style>
-        <p:txBody>
-          <a:bodyPr rtlCol="0" anchor="ctr"/>
-          <a:lstStyle/>
-          <a:p>
-            <a:pPr algn="ctr"/>
-            <a:endParaRPr/>
-          </a:p>
-        </p:txBody>
-      </p:sp>
-      <p:sp>
-        <p:nvSpPr>
-          <p:cNvPr id="61" name="Rectangle 60"/>
-          <p:cNvSpPr/>
-          <p:nvPr/>
-        </p:nvSpPr>
-        <p:spPr>
-          <a:xfrm>
-            <a:off x="9784080" y="3410712"/>
-            <a:ext cx="384048" cy="237744"/>
-          </a:xfrm>
-          <a:prstGeom prst="rect">
-            <a:avLst/>
-          </a:prstGeom>
-          <a:solidFill>
-            <a:srgbClr val="C8102E"/>
-          </a:solidFill>
-          <a:ln>
-            <a:noFill/>
-          </a:ln>
-        </p:spPr>
-        <p:style>
-          <a:lnRef idx="1">
-            <a:schemeClr val="accent1"/>
-          </a:lnRef>
-          <a:fillRef idx="3">
-            <a:schemeClr val="accent1"/>
-          </a:fillRef>
-          <a:effectRef idx="2">
-            <a:schemeClr val="accent1"/>
-          </a:effectRef>
-          <a:fontRef idx="minor">
-            <a:schemeClr val="lt1"/>
-          </a:fontRef>
-        </p:style>
-        <p:txBody>
-          <a:bodyPr rtlCol="0" anchor="ctr"/>
-          <a:lstStyle/>
-          <a:p>
-            <a:pPr algn="ctr"/>
-            <a:endParaRPr/>
-          </a:p>
-        </p:txBody>
-      </p:sp>
-      <p:sp>
-        <p:nvSpPr>
-          <p:cNvPr id="62" name="TextBox 61"/>
-          <p:cNvSpPr txBox="1"/>
-          <p:nvPr/>
-        </p:nvSpPr>
-        <p:spPr>
-          <a:xfrm>
-            <a:off x="9793224" y="3419856"/>
-            <a:ext cx="365760" cy="201168"/>
-          </a:xfrm>
-          <a:prstGeom prst="rect">
-            <a:avLst/>
-          </a:prstGeom>
-          <a:noFill/>
-        </p:spPr>
-        <p:txBody>
-          <a:bodyPr wrap="none">
-            <a:spAutoFit/>
-          </a:bodyPr>
-          <a:lstStyle/>
-          <a:p>
-            <a:endParaRPr/>
-          </a:p>
-          <a:p>
-            <a:pPr algn="ctr">
-              <a:spcBef>
-                <a:spcPts val="0"/>
-              </a:spcBef>
-              <a:spcAft>
-                <a:spcPts val="0"/>
-              </a:spcAft>
-            </a:pPr>
-            <a:r>
-              <a:rPr sz="800" b="1">
-                <a:solidFill>
-                  <a:srgbClr val="FFFFFF"/>
-                </a:solidFill>
-                <a:latin typeface="Calibri"/>
-              </a:rPr>
-              <a:t>§5</a:t>
-            </a:r>
-          </a:p>
-        </p:txBody>
-      </p:sp>
-      <p:sp>
-        <p:nvSpPr>
-          <p:cNvPr id="63" name="TextBox 62"/>
-          <p:cNvSpPr txBox="1"/>
-          <p:nvPr/>
-        </p:nvSpPr>
-        <p:spPr>
-          <a:xfrm>
-            <a:off x="10241280" y="3410712"/>
-            <a:ext cx="1645920" cy="256032"/>
-          </a:xfrm>
-          <a:prstGeom prst="rect">
-            <a:avLst/>
-          </a:prstGeom>
-          <a:noFill/>
-        </p:spPr>
-        <p:txBody>
-          <a:bodyPr wrap="none">
-            <a:spAutoFit/>
-          </a:bodyPr>
-          <a:lstStyle/>
-          <a:p>
-            <a:endParaRPr/>
-          </a:p>
-          <a:p>
-            <a:pPr algn="l">
-              <a:spcBef>
-                <a:spcPts val="0"/>
-              </a:spcBef>
-              <a:spcAft>
-                <a:spcPts val="0"/>
-              </a:spcAft>
-            </a:pPr>
-            <a:r>
-              <a:rPr sz="1000" b="1">
-                <a:solidFill>
-                  <a:srgbClr val="1A1A1A"/>
-                </a:solidFill>
-                <a:latin typeface="Calibri"/>
-              </a:rPr>
-              <a:t>Correction Rate</a:t>
-            </a:r>
-          </a:p>
-        </p:txBody>
-      </p:sp>
-      <p:sp>
-        <p:nvSpPr>
-          <p:cNvPr id="64" name="TextBox 63"/>
-          <p:cNvSpPr txBox="1"/>
-          <p:nvPr/>
-        </p:nvSpPr>
-        <p:spPr>
-          <a:xfrm>
-            <a:off x="9784080" y="3703320"/>
-            <a:ext cx="2103120" cy="1463040"/>
-          </a:xfrm>
-          <a:prstGeom prst="rect">
-            <a:avLst/>
-          </a:prstGeom>
-          <a:noFill/>
-        </p:spPr>
-        <p:txBody>
-          <a:bodyPr wrap="square">
-            <a:spAutoFit/>
-          </a:bodyPr>
-          <a:lstStyle/>
-          <a:p>
-            <a:endParaRPr/>
-          </a:p>
-          <a:p>
-            <a:pPr algn="l">
-              <a:spcBef>
-                <a:spcPts val="0"/>
-              </a:spcBef>
-              <a:spcAft>
-                <a:spcPts val="0"/>
-              </a:spcAft>
-            </a:pPr>
-            <a:r>
-              <a:rPr sz="900" b="0">
-                <a:solidFill>
-                  <a:srgbClr val="1A1A1A"/>
-                </a:solidFill>
-                <a:latin typeface="Calibri"/>
-              </a:rPr>
-              <a:t>% of AI fields flagged wrong by manager per packet</a:t>
-            </a:r>
-          </a:p>
-        </p:txBody>
-      </p:sp>
-      <p:sp>
-        <p:nvSpPr>
-          <p:cNvPr id="65" name="TextBox 64"/>
-          <p:cNvSpPr txBox="1"/>
-          <p:nvPr/>
-        </p:nvSpPr>
-        <p:spPr>
-          <a:xfrm>
-            <a:off x="9784080" y="6263640"/>
-            <a:ext cx="2103120" cy="274320"/>
-          </a:xfrm>
-          <a:prstGeom prst="rect">
-            <a:avLst/>
-          </a:prstGeom>
-          <a:noFill/>
-        </p:spPr>
-        <p:txBody>
-          <a:bodyPr wrap="none">
-            <a:spAutoFit/>
-          </a:bodyPr>
-          <a:lstStyle/>
-          <a:p>
-            <a:endParaRPr/>
-          </a:p>
-          <a:p>
-            <a:pPr algn="l">
-              <a:spcBef>
-                <a:spcPts val="0"/>
-              </a:spcBef>
-              <a:spcAft>
-                <a:spcPts val="0"/>
-              </a:spcAft>
-            </a:pPr>
-            <a:r>
-              <a:rPr sz="700" b="0">
-                <a:solidFill>
-                  <a:srgbClr val="555555"/>
-                </a:solidFill>
-                <a:latin typeface="Calibri"/>
-              </a:rPr>
-              <a:t>kpi_correction_rate_pct</a:t>
-            </a:r>
-          </a:p>
-        </p:txBody>
-      </p:sp>
-      <p:sp>
-        <p:nvSpPr>
-          <p:cNvPr id="66" name="TextBox 65"/>
-          <p:cNvSpPr txBox="1"/>
-          <p:nvPr/>
-        </p:nvSpPr>
-        <p:spPr>
-          <a:xfrm>
-            <a:off x="9784080" y="5212080"/>
-            <a:ext cx="2103120" cy="1005840"/>
-          </a:xfrm>
-          <a:prstGeom prst="rect">
-            <a:avLst/>
-          </a:prstGeom>
-          <a:noFill/>
-        </p:spPr>
-        <p:txBody>
-          <a:bodyPr wrap="square">
-            <a:spAutoFit/>
-          </a:bodyPr>
-          <a:lstStyle/>
-          <a:p>
-            <a:endParaRPr/>
-          </a:p>
-          <a:p>
-            <a:pPr algn="l">
-              <a:spcBef>
-                <a:spcPts val="0"/>
-              </a:spcBef>
-              <a:spcAft>
-                <a:spcPts val="0"/>
-              </a:spcAft>
-            </a:pPr>
-            <a:r>
-              <a:rPr sz="800" b="0">
-                <a:solidFill>
-                  <a:srgbClr val="C8102E"/>
-                </a:solidFill>
-                <a:latin typeface="Calibri"/>
-              </a:rPr>
-              <a:t>Target &lt;10% by day 90
-High rate = retune prompt</a:t>
-            </a:r>
-            <a:r>
-              <a:t/>
-            </a:r>
-            <a:br/>
-            <a:r>
-              <a:t>High rate = retune prompt</a:t>
+              </a:rPr>
+              <a:t>Trust signal: a falling rate means extraction is improving. High rate on a specific supplier → retune prompt.</a:t>
             </a:r>
           </a:p>
         </p:txBody>

</xml_diff>

<commit_message>
docs: rewrite slide 13 to match 3 KPIs — inputs, source, computation, tracking
</commit_message>
<xml_diff>
--- a/docs/strauss_fde_deck.pptx
+++ b/docs/strauss_fde_deck.pptx
@@ -8746,9 +8746,7 @@
             <a:srgbClr val="C8102E"/>
           </a:solidFill>
           <a:ln>
-            <a:solidFill>
-              <a:srgbClr val="DDDDDD"/>
-            </a:solidFill>
+            <a:noFill/>
           </a:ln>
         </p:spPr>
         <p:style>
@@ -8770,7 +8768,6 @@
           <a:lstStyle/>
           <a:p>
             <a:pPr algn="ctr"/>
-            <a:endParaRPr/>
           </a:p>
         </p:txBody>
       </p:sp>
@@ -8783,7 +8780,7 @@
         <p:spPr>
           <a:xfrm>
             <a:off x="237744" y="1188720"/>
-            <a:ext cx="1097280" cy="310896"/>
+            <a:ext cx="1078992" cy="310896"/>
           </a:xfrm>
           <a:prstGeom prst="rect">
             <a:avLst/>
@@ -8791,15 +8788,12 @@
           <a:noFill/>
         </p:spPr>
         <p:txBody>
-          <a:bodyPr wrap="none">
+          <a:bodyPr wrap="square">
             <a:spAutoFit/>
           </a:bodyPr>
           <a:lstStyle/>
           <a:p>
-            <a:endParaRPr/>
-          </a:p>
-          <a:p>
-            <a:pPr algn="l">
+            <a:pPr>
               <a:spcBef>
                 <a:spcPts val="0"/>
               </a:spcBef>
@@ -8808,11 +8802,10 @@
               </a:spcAft>
             </a:pPr>
             <a:r>
-              <a:rPr sz="1000" b="1">
+              <a:rPr b="1" sz="1000">
                 <a:solidFill>
                   <a:srgbClr val="FFFFFF"/>
                 </a:solidFill>
-                <a:latin typeface="Calibri"/>
               </a:rPr>
               <a:t>KPI</a:t>
             </a:r>
@@ -8827,8 +8820,8 @@
         </p:nvSpPr>
         <p:spPr>
           <a:xfrm>
-            <a:off x="1463040" y="1170432"/>
-            <a:ext cx="2560320" cy="347472"/>
+            <a:off x="1371600" y="1170432"/>
+            <a:ext cx="2697480" cy="347472"/>
           </a:xfrm>
           <a:prstGeom prst="rect">
             <a:avLst/>
@@ -8837,9 +8830,7 @@
             <a:srgbClr val="C8102E"/>
           </a:solidFill>
           <a:ln>
-            <a:solidFill>
-              <a:srgbClr val="DDDDDD"/>
-            </a:solidFill>
+            <a:noFill/>
           </a:ln>
         </p:spPr>
         <p:style>
@@ -8861,7 +8852,6 @@
           <a:lstStyle/>
           <a:p>
             <a:pPr algn="ctr"/>
-            <a:endParaRPr/>
           </a:p>
         </p:txBody>
       </p:sp>
@@ -8873,8 +8863,8 @@
         </p:nvSpPr>
         <p:spPr>
           <a:xfrm>
-            <a:off x="1517904" y="1188720"/>
-            <a:ext cx="2468879" cy="310896"/>
+            <a:off x="1426464" y="1188720"/>
+            <a:ext cx="2587752" cy="310896"/>
           </a:xfrm>
           <a:prstGeom prst="rect">
             <a:avLst/>
@@ -8882,15 +8872,12 @@
           <a:noFill/>
         </p:spPr>
         <p:txBody>
-          <a:bodyPr wrap="none">
+          <a:bodyPr wrap="square">
             <a:spAutoFit/>
           </a:bodyPr>
           <a:lstStyle/>
           <a:p>
-            <a:endParaRPr/>
-          </a:p>
-          <a:p>
-            <a:pPr algn="l">
+            <a:pPr>
               <a:spcBef>
                 <a:spcPts val="0"/>
               </a:spcBef>
@@ -8899,11 +8886,10 @@
               </a:spcAft>
             </a:pPr>
             <a:r>
-              <a:rPr sz="1000" b="1">
+              <a:rPr b="1" sz="1000">
                 <a:solidFill>
                   <a:srgbClr val="FFFFFF"/>
                 </a:solidFill>
-                <a:latin typeface="Calibri"/>
               </a:rPr>
               <a:t>Input fields</a:t>
             </a:r>
@@ -8918,8 +8904,8 @@
         </p:nvSpPr>
         <p:spPr>
           <a:xfrm>
-            <a:off x="4114800" y="1170432"/>
-            <a:ext cx="2743200" cy="347472"/>
+            <a:off x="4069080" y="1170432"/>
+            <a:ext cx="2697480" cy="347472"/>
           </a:xfrm>
           <a:prstGeom prst="rect">
             <a:avLst/>
@@ -8928,9 +8914,7 @@
             <a:srgbClr val="C8102E"/>
           </a:solidFill>
           <a:ln>
-            <a:solidFill>
-              <a:srgbClr val="DDDDDD"/>
-            </a:solidFill>
+            <a:noFill/>
           </a:ln>
         </p:spPr>
         <p:style>
@@ -8952,7 +8936,6 @@
           <a:lstStyle/>
           <a:p>
             <a:pPr algn="ctr"/>
-            <a:endParaRPr/>
           </a:p>
         </p:txBody>
       </p:sp>
@@ -8964,8 +8947,8 @@
         </p:nvSpPr>
         <p:spPr>
           <a:xfrm>
-            <a:off x="4169663" y="1188720"/>
-            <a:ext cx="2651760" cy="310896"/>
+            <a:off x="4123944" y="1188720"/>
+            <a:ext cx="2587752" cy="310896"/>
           </a:xfrm>
           <a:prstGeom prst="rect">
             <a:avLst/>
@@ -8973,15 +8956,12 @@
           <a:noFill/>
         </p:spPr>
         <p:txBody>
-          <a:bodyPr wrap="none">
+          <a:bodyPr wrap="square">
             <a:spAutoFit/>
           </a:bodyPr>
           <a:lstStyle/>
           <a:p>
-            <a:endParaRPr/>
-          </a:p>
-          <a:p>
-            <a:pPr algn="l">
+            <a:pPr>
               <a:spcBef>
                 <a:spcPts val="0"/>
               </a:spcBef>
@@ -8990,13 +8970,12 @@
               </a:spcAft>
             </a:pPr>
             <a:r>
-              <a:rPr sz="1000" b="1">
+              <a:rPr b="1" sz="1000">
                 <a:solidFill>
                   <a:srgbClr val="FFFFFF"/>
                 </a:solidFill>
-                <a:latin typeface="Calibri"/>
-              </a:rPr>
-              <a:t>Source system (prototype)</a:t>
+              </a:rPr>
+              <a:t>Source</a:t>
             </a:r>
           </a:p>
         </p:txBody>
@@ -9009,8 +8988,8 @@
         </p:nvSpPr>
         <p:spPr>
           <a:xfrm>
-            <a:off x="6949440" y="1170432"/>
-            <a:ext cx="2560320" cy="347472"/>
+            <a:off x="6766560" y="1170432"/>
+            <a:ext cx="2697480" cy="347472"/>
           </a:xfrm>
           <a:prstGeom prst="rect">
             <a:avLst/>
@@ -9019,9 +8998,7 @@
             <a:srgbClr val="C8102E"/>
           </a:solidFill>
           <a:ln>
-            <a:solidFill>
-              <a:srgbClr val="DDDDDD"/>
-            </a:solidFill>
+            <a:noFill/>
           </a:ln>
         </p:spPr>
         <p:style>
@@ -9043,7 +9020,6 @@
           <a:lstStyle/>
           <a:p>
             <a:pPr algn="ctr"/>
-            <a:endParaRPr/>
           </a:p>
         </p:txBody>
       </p:sp>
@@ -9055,8 +9031,8 @@
         </p:nvSpPr>
         <p:spPr>
           <a:xfrm>
-            <a:off x="7004303" y="1188720"/>
-            <a:ext cx="2468879" cy="310896"/>
+            <a:off x="6821424" y="1188720"/>
+            <a:ext cx="2587752" cy="310896"/>
           </a:xfrm>
           <a:prstGeom prst="rect">
             <a:avLst/>
@@ -9064,15 +9040,12 @@
           <a:noFill/>
         </p:spPr>
         <p:txBody>
-          <a:bodyPr wrap="none">
+          <a:bodyPr wrap="square">
             <a:spAutoFit/>
           </a:bodyPr>
           <a:lstStyle/>
           <a:p>
-            <a:endParaRPr/>
-          </a:p>
-          <a:p>
-            <a:pPr algn="l">
+            <a:pPr>
               <a:spcBef>
                 <a:spcPts val="0"/>
               </a:spcBef>
@@ -9081,13 +9054,12 @@
               </a:spcAft>
             </a:pPr>
             <a:r>
-              <a:rPr sz="1000" b="1">
+              <a:rPr b="1" sz="1000">
                 <a:solidFill>
                   <a:srgbClr val="FFFFFF"/>
                 </a:solidFill>
-                <a:latin typeface="Calibri"/>
-              </a:rPr>
-              <a:t>Who computes it</a:t>
+              </a:rPr>
+              <a:t>Who computes</a:t>
             </a:r>
           </a:p>
         </p:txBody>
@@ -9100,8 +9072,8 @@
         </p:nvSpPr>
         <p:spPr>
           <a:xfrm>
-            <a:off x="9601200" y="1170432"/>
-            <a:ext cx="2423160" cy="347472"/>
+            <a:off x="9464040" y="1170432"/>
+            <a:ext cx="2542032" cy="347472"/>
           </a:xfrm>
           <a:prstGeom prst="rect">
             <a:avLst/>
@@ -9110,9 +9082,7 @@
             <a:srgbClr val="C8102E"/>
           </a:solidFill>
           <a:ln>
-            <a:solidFill>
-              <a:srgbClr val="DDDDDD"/>
-            </a:solidFill>
+            <a:noFill/>
           </a:ln>
         </p:spPr>
         <p:style>
@@ -9134,7 +9104,6 @@
           <a:lstStyle/>
           <a:p>
             <a:pPr algn="ctr"/>
-            <a:endParaRPr/>
           </a:p>
         </p:txBody>
       </p:sp>
@@ -9146,8 +9115,8 @@
         </p:nvSpPr>
         <p:spPr>
           <a:xfrm>
-            <a:off x="9656064" y="1188720"/>
-            <a:ext cx="2331720" cy="310896"/>
+            <a:off x="9518904" y="1188720"/>
+            <a:ext cx="2432304" cy="310896"/>
           </a:xfrm>
           <a:prstGeom prst="rect">
             <a:avLst/>
@@ -9155,15 +9124,12 @@
           <a:noFill/>
         </p:spPr>
         <p:txBody>
-          <a:bodyPr wrap="none">
+          <a:bodyPr wrap="square">
             <a:spAutoFit/>
           </a:bodyPr>
           <a:lstStyle/>
           <a:p>
-            <a:endParaRPr/>
-          </a:p>
-          <a:p>
-            <a:pPr algn="l">
+            <a:pPr>
               <a:spcBef>
                 <a:spcPts val="0"/>
               </a:spcBef>
@@ -9172,13 +9138,12 @@
               </a:spcAft>
             </a:pPr>
             <a:r>
-              <a:rPr sz="1000" b="1">
+              <a:rPr b="1" sz="1000">
                 <a:solidFill>
                   <a:srgbClr val="FFFFFF"/>
                 </a:solidFill>
-                <a:latin typeface="Calibri"/>
-              </a:rPr>
-              <a:t>SQLite column stored</a:t>
+              </a:rPr>
+              <a:t>How tracked</a:t>
             </a:r>
           </a:p>
         </p:txBody>
@@ -9192,7 +9157,7 @@
         <p:spPr>
           <a:xfrm>
             <a:off x="182880" y="1572768"/>
-            <a:ext cx="1188720" cy="987552"/>
+            <a:ext cx="1188720" cy="1371600"/>
           </a:xfrm>
           <a:prstGeom prst="rect">
             <a:avLst/>
@@ -9201,9 +9166,7 @@
             <a:srgbClr val="F0F0F0"/>
           </a:solidFill>
           <a:ln>
-            <a:solidFill>
-              <a:srgbClr val="DDDDDD"/>
-            </a:solidFill>
+            <a:noFill/>
           </a:ln>
         </p:spPr>
         <p:style>
@@ -9225,20 +9188,96 @@
           <a:lstStyle/>
           <a:p>
             <a:pPr algn="ctr"/>
-            <a:endParaRPr/>
-          </a:p>
-        </p:txBody>
-      </p:sp>
-      <p:sp>
-        <p:nvSpPr>
-          <p:cNvPr id="18" name="Rectangle 17"/>
+          </a:p>
+        </p:txBody>
+      </p:sp>
+      <p:sp>
+        <p:nvSpPr>
+          <p:cNvPr id="18" name="TextBox 17"/>
+          <p:cNvSpPr txBox="1"/>
+          <p:nvPr/>
+        </p:nvSpPr>
+        <p:spPr>
+          <a:xfrm>
+            <a:off x="237744" y="1645920"/>
+            <a:ext cx="1078992" cy="1225296"/>
+          </a:xfrm>
+          <a:prstGeom prst="rect">
+            <a:avLst/>
+          </a:prstGeom>
+          <a:noFill/>
+        </p:spPr>
+        <p:txBody>
+          <a:bodyPr wrap="square">
+            <a:spAutoFit/>
+          </a:bodyPr>
+          <a:lstStyle/>
+          <a:p>
+            <a:pPr>
+              <a:spcBef>
+                <a:spcPts val="0"/>
+              </a:spcBef>
+              <a:spcAft>
+                <a:spcPts val="0"/>
+              </a:spcAft>
+            </a:pPr>
+            <a:r>
+              <a:rPr b="1" sz="900">
+                <a:solidFill>
+                  <a:srgbClr val="C8102E"/>
+                </a:solidFill>
+              </a:rPr>
+              <a:t>#1</a:t>
+            </a:r>
+          </a:p>
+          <a:p>
+            <a:pPr>
+              <a:spcBef>
+                <a:spcPts val="0"/>
+              </a:spcBef>
+              <a:spcAft>
+                <a:spcPts val="0"/>
+              </a:spcAft>
+            </a:pPr>
+            <a:r>
+              <a:rPr b="1" sz="900">
+                <a:solidFill>
+                  <a:srgbClr val="C8102E"/>
+                </a:solidFill>
+              </a:rPr>
+              <a:t>Prep Time</a:t>
+            </a:r>
+          </a:p>
+          <a:p>
+            <a:pPr>
+              <a:spcBef>
+                <a:spcPts val="0"/>
+              </a:spcBef>
+              <a:spcAft>
+                <a:spcPts val="0"/>
+              </a:spcAft>
+            </a:pPr>
+            <a:r>
+              <a:rPr b="1" sz="900">
+                <a:solidFill>
+                  <a:srgbClr val="C8102E"/>
+                </a:solidFill>
+              </a:rPr>
+              <a:t>Saved</a:t>
+            </a:r>
+          </a:p>
+        </p:txBody>
+      </p:sp>
+      <p:sp>
+        <p:nvSpPr>
+          <p:cNvPr id="19" name="Rectangle 18"/>
           <p:cNvSpPr/>
           <p:nvPr/>
         </p:nvSpPr>
         <p:spPr>
           <a:xfrm>
-            <a:off x="1463040" y="1572768"/>
-            <a:ext cx="2560320" cy="987552"/>
+            <a:off x="1371600" y="1572768"/>
+            <a:ext cx="2697480" cy="1371600"/>
           </a:xfrm>
           <a:prstGeom prst="rect">
             <a:avLst/>
@@ -9247,9 +9286,7 @@
             <a:srgbClr val="F0F0F0"/>
           </a:solidFill>
           <a:ln>
-            <a:solidFill>
-              <a:srgbClr val="DDDDDD"/>
-            </a:solidFill>
+            <a:noFill/>
           </a:ln>
         </p:spPr>
         <p:style>
@@ -9271,20 +9308,96 @@
           <a:lstStyle/>
           <a:p>
             <a:pPr algn="ctr"/>
-            <a:endParaRPr/>
-          </a:p>
-        </p:txBody>
-      </p:sp>
-      <p:sp>
-        <p:nvSpPr>
-          <p:cNvPr id="19" name="Rectangle 18"/>
+          </a:p>
+        </p:txBody>
+      </p:sp>
+      <p:sp>
+        <p:nvSpPr>
+          <p:cNvPr id="20" name="TextBox 19"/>
+          <p:cNvSpPr txBox="1"/>
+          <p:nvPr/>
+        </p:nvSpPr>
+        <p:spPr>
+          <a:xfrm>
+            <a:off x="1426464" y="1645920"/>
+            <a:ext cx="2587752" cy="1225296"/>
+          </a:xfrm>
+          <a:prstGeom prst="rect">
+            <a:avLst/>
+          </a:prstGeom>
+          <a:noFill/>
+        </p:spPr>
+        <p:txBody>
+          <a:bodyPr wrap="square">
+            <a:spAutoFit/>
+          </a:bodyPr>
+          <a:lstStyle/>
+          <a:p>
+            <a:pPr>
+              <a:spcBef>
+                <a:spcPts val="0"/>
+              </a:spcBef>
+              <a:spcAft>
+                <a:spcPts val="0"/>
+              </a:spcAft>
+            </a:pPr>
+            <a:r>
+              <a:rPr b="0" sz="900">
+                <a:solidFill>
+                  <a:srgbClr val="1A1A1A"/>
+                </a:solidFill>
+              </a:rPr>
+              <a:t>meeting timestamp</a:t>
+            </a:r>
+          </a:p>
+          <a:p>
+            <a:pPr>
+              <a:spcBef>
+                <a:spcPts val="0"/>
+              </a:spcBef>
+              <a:spcAft>
+                <a:spcPts val="0"/>
+              </a:spcAft>
+            </a:pPr>
+            <a:r>
+              <a:rPr b="0" sz="900">
+                <a:solidFill>
+                  <a:srgbClr val="1A1A1A"/>
+                </a:solidFill>
+              </a:rPr>
+              <a:t>packet generation timestamp</a:t>
+            </a:r>
+          </a:p>
+          <a:p>
+            <a:pPr>
+              <a:spcBef>
+                <a:spcPts val="0"/>
+              </a:spcBef>
+              <a:spcAft>
+                <a:spcPts val="0"/>
+              </a:spcAft>
+            </a:pPr>
+            <a:r>
+              <a:rPr b="0" sz="900">
+                <a:solidFill>
+                  <a:srgbClr val="1A1A1A"/>
+                </a:solidFill>
+              </a:rPr>
+              <a:t>manual baseline (2.5 hrs)</a:t>
+            </a:r>
+          </a:p>
+        </p:txBody>
+      </p:sp>
+      <p:sp>
+        <p:nvSpPr>
+          <p:cNvPr id="21" name="Rectangle 20"/>
           <p:cNvSpPr/>
           <p:nvPr/>
         </p:nvSpPr>
         <p:spPr>
           <a:xfrm>
-            <a:off x="4114800" y="1572768"/>
-            <a:ext cx="2743200" cy="987552"/>
+            <a:off x="4069080" y="1572768"/>
+            <a:ext cx="2697480" cy="1371600"/>
           </a:xfrm>
           <a:prstGeom prst="rect">
             <a:avLst/>
@@ -9293,9 +9406,7 @@
             <a:srgbClr val="F0F0F0"/>
           </a:solidFill>
           <a:ln>
-            <a:solidFill>
-              <a:srgbClr val="DDDDDD"/>
-            </a:solidFill>
+            <a:noFill/>
           </a:ln>
         </p:spPr>
         <p:style>
@@ -9317,20 +9428,78 @@
           <a:lstStyle/>
           <a:p>
             <a:pPr algn="ctr"/>
-            <a:endParaRPr/>
-          </a:p>
-        </p:txBody>
-      </p:sp>
-      <p:sp>
-        <p:nvSpPr>
-          <p:cNvPr id="20" name="Rectangle 19"/>
+          </a:p>
+        </p:txBody>
+      </p:sp>
+      <p:sp>
+        <p:nvSpPr>
+          <p:cNvPr id="22" name="TextBox 21"/>
+          <p:cNvSpPr txBox="1"/>
+          <p:nvPr/>
+        </p:nvSpPr>
+        <p:spPr>
+          <a:xfrm>
+            <a:off x="4123944" y="1645920"/>
+            <a:ext cx="2587752" cy="1225296"/>
+          </a:xfrm>
+          <a:prstGeom prst="rect">
+            <a:avLst/>
+          </a:prstGeom>
+          <a:noFill/>
+        </p:spPr>
+        <p:txBody>
+          <a:bodyPr wrap="square">
+            <a:spAutoFit/>
+          </a:bodyPr>
+          <a:lstStyle/>
+          <a:p>
+            <a:pPr>
+              <a:spcBef>
+                <a:spcPts val="0"/>
+              </a:spcBef>
+              <a:spcAft>
+                <a:spcPts val="0"/>
+              </a:spcAft>
+            </a:pPr>
+            <a:r>
+              <a:rPr b="0" sz="900">
+                <a:solidFill>
+                  <a:srgbClr val="1A1A1A"/>
+                </a:solidFill>
+              </a:rPr>
+              <a:t>session logs (SQLite)</a:t>
+            </a:r>
+          </a:p>
+          <a:p>
+            <a:pPr>
+              <a:spcBef>
+                <a:spcPts val="0"/>
+              </a:spcBef>
+              <a:spcAft>
+                <a:spcPts val="0"/>
+              </a:spcAft>
+            </a:pPr>
+            <a:r>
+              <a:rPr b="0" sz="900">
+                <a:solidFill>
+                  <a:srgbClr val="1A1A1A"/>
+                </a:solidFill>
+              </a:rPr>
+              <a:t>human baseline</a:t>
+            </a:r>
+          </a:p>
+        </p:txBody>
+      </p:sp>
+      <p:sp>
+        <p:nvSpPr>
+          <p:cNvPr id="23" name="Rectangle 22"/>
           <p:cNvSpPr/>
           <p:nvPr/>
         </p:nvSpPr>
         <p:spPr>
           <a:xfrm>
-            <a:off x="6949440" y="1572768"/>
-            <a:ext cx="2560320" cy="987552"/>
+            <a:off x="6766560" y="1572768"/>
+            <a:ext cx="2697480" cy="1371600"/>
           </a:xfrm>
           <a:prstGeom prst="rect">
             <a:avLst/>
@@ -9339,9 +9508,7 @@
             <a:srgbClr val="F0F0F0"/>
           </a:solidFill>
           <a:ln>
-            <a:solidFill>
-              <a:srgbClr val="DDDDDD"/>
-            </a:solidFill>
+            <a:noFill/>
           </a:ln>
         </p:spPr>
         <p:style>
@@ -9363,20 +9530,78 @@
           <a:lstStyle/>
           <a:p>
             <a:pPr algn="ctr"/>
-            <a:endParaRPr/>
-          </a:p>
-        </p:txBody>
-      </p:sp>
-      <p:sp>
-        <p:nvSpPr>
-          <p:cNvPr id="21" name="Rectangle 20"/>
+          </a:p>
+        </p:txBody>
+      </p:sp>
+      <p:sp>
+        <p:nvSpPr>
+          <p:cNvPr id="24" name="TextBox 23"/>
+          <p:cNvSpPr txBox="1"/>
+          <p:nvPr/>
+        </p:nvSpPr>
+        <p:spPr>
+          <a:xfrm>
+            <a:off x="6821424" y="1645920"/>
+            <a:ext cx="2587752" cy="1225296"/>
+          </a:xfrm>
+          <a:prstGeom prst="rect">
+            <a:avLst/>
+          </a:prstGeom>
+          <a:noFill/>
+        </p:spPr>
+        <p:txBody>
+          <a:bodyPr wrap="square">
+            <a:spAutoFit/>
+          </a:bodyPr>
+          <a:lstStyle/>
+          <a:p>
+            <a:pPr>
+              <a:spcBef>
+                <a:spcPts val="0"/>
+              </a:spcBef>
+              <a:spcAft>
+                <a:spcPts val="0"/>
+              </a:spcAft>
+            </a:pPr>
+            <a:r>
+              <a:rPr b="0" sz="900">
+                <a:solidFill>
+                  <a:srgbClr val="1A1A1A"/>
+                </a:solidFill>
+              </a:rPr>
+              <a:t>Python (packet_generator.py)</a:t>
+            </a:r>
+          </a:p>
+          <a:p>
+            <a:pPr>
+              <a:spcBef>
+                <a:spcPts val="0"/>
+              </a:spcBef>
+              <a:spcAft>
+                <a:spcPts val="0"/>
+              </a:spcAft>
+            </a:pPr>
+            <a:r>
+              <a:rPr b="0" sz="900">
+                <a:solidFill>
+                  <a:srgbClr val="1A1A1A"/>
+                </a:solidFill>
+              </a:rPr>
+              <a:t>compared against fixed baseline</a:t>
+            </a:r>
+          </a:p>
+        </p:txBody>
+      </p:sp>
+      <p:sp>
+        <p:nvSpPr>
+          <p:cNvPr id="25" name="Rectangle 24"/>
           <p:cNvSpPr/>
           <p:nvPr/>
         </p:nvSpPr>
         <p:spPr>
           <a:xfrm>
-            <a:off x="9601200" y="1572768"/>
-            <a:ext cx="2423160" cy="987552"/>
+            <a:off x="9464040" y="1572768"/>
+            <a:ext cx="2542032" cy="1371600"/>
           </a:xfrm>
           <a:prstGeom prst="rect">
             <a:avLst/>
@@ -9385,9 +9610,7 @@
             <a:srgbClr val="F0F0F0"/>
           </a:solidFill>
           <a:ln>
-            <a:solidFill>
-              <a:srgbClr val="DDDDDD"/>
-            </a:solidFill>
+            <a:noFill/>
           </a:ln>
         </p:spPr>
         <p:style>
@@ -9409,20 +9632,19 @@
           <a:lstStyle/>
           <a:p>
             <a:pPr algn="ctr"/>
-            <a:endParaRPr/>
-          </a:p>
-        </p:txBody>
-      </p:sp>
-      <p:sp>
-        <p:nvSpPr>
-          <p:cNvPr id="22" name="TextBox 21"/>
+          </a:p>
+        </p:txBody>
+      </p:sp>
+      <p:sp>
+        <p:nvSpPr>
+          <p:cNvPr id="26" name="TextBox 25"/>
           <p:cNvSpPr txBox="1"/>
           <p:nvPr/>
         </p:nvSpPr>
         <p:spPr>
           <a:xfrm>
-            <a:off x="237744" y="1627632"/>
-            <a:ext cx="1097280" cy="868680"/>
+            <a:off x="9518904" y="1645920"/>
+            <a:ext cx="2432304" cy="1225296"/>
           </a:xfrm>
           <a:prstGeom prst="rect">
             <a:avLst/>
@@ -9435,10 +9657,7 @@
           </a:bodyPr>
           <a:lstStyle/>
           <a:p>
-            <a:endParaRPr/>
-          </a:p>
-          <a:p>
-            <a:pPr algn="l">
+            <a:pPr>
               <a:spcBef>
                 <a:spcPts val="0"/>
               </a:spcBef>
@@ -9447,51 +9666,16 @@
               </a:spcAft>
             </a:pPr>
             <a:r>
-              <a:rPr sz="900" b="1">
-                <a:solidFill>
-                  <a:srgbClr val="C8102E"/>
-                </a:solidFill>
-                <a:latin typeface="Calibri"/>
-              </a:rPr>
-              <a:t>§1
-Response Time</a:t>
-            </a:r>
-            <a:r>
-              <a:t/>
-            </a:r>
-            <a:br/>
-            <a:r>
-              <a:t>Response Time</a:t>
-            </a:r>
-          </a:p>
-        </p:txBody>
-      </p:sp>
-      <p:sp>
-        <p:nvSpPr>
-          <p:cNvPr id="23" name="TextBox 22"/>
-          <p:cNvSpPr txBox="1"/>
-          <p:nvPr/>
-        </p:nvSpPr>
-        <p:spPr>
-          <a:xfrm>
-            <a:off x="1517904" y="1627632"/>
-            <a:ext cx="2468879" cy="868680"/>
-          </a:xfrm>
-          <a:prstGeom prst="rect">
-            <a:avLst/>
-          </a:prstGeom>
-          <a:noFill/>
-        </p:spPr>
-        <p:txBody>
-          <a:bodyPr wrap="square">
-            <a:spAutoFit/>
-          </a:bodyPr>
-          <a:lstStyle/>
-          <a:p>
-            <a:endParaRPr/>
-          </a:p>
-          <a:p>
-            <a:pPr algn="l">
+              <a:rPr b="0" sz="900">
+                <a:solidFill>
+                  <a:srgbClr val="1A1A1A"/>
+                </a:solidFill>
+              </a:rPr>
+              <a:t>time-to-generate per packet</a:t>
+            </a:r>
+          </a:p>
+          <a:p>
+            <a:pPr>
               <a:spcBef>
                 <a:spcPts val="0"/>
               </a:spcBef>
@@ -9500,195 +9684,12 @@
               </a:spcAft>
             </a:pPr>
             <a:r>
-              <a:rPr sz="900" b="0">
-                <a:solidFill>
-                  <a:srgbClr val="1A1A1A"/>
-                </a:solidFill>
-                <a:latin typeface="Calibri"/>
-              </a:rPr>
-              <a:t>email.date
-email.from
-Subject (thread grouping)</a:t>
-            </a:r>
-            <a:r>
-              <a:t/>
-            </a:r>
-            <a:br/>
-            <a:r>
-              <a:t>email.from</a:t>
-            </a:r>
-            <a:br/>
-            <a:r>
-              <a:t>Subject (thread grouping)</a:t>
-            </a:r>
-          </a:p>
-        </p:txBody>
-      </p:sp>
-      <p:sp>
-        <p:nvSpPr>
-          <p:cNvPr id="24" name="TextBox 23"/>
-          <p:cNvSpPr txBox="1"/>
-          <p:nvPr/>
-        </p:nvSpPr>
-        <p:spPr>
-          <a:xfrm>
-            <a:off x="4169663" y="1627632"/>
-            <a:ext cx="2651760" cy="868680"/>
-          </a:xfrm>
-          <a:prstGeom prst="rect">
-            <a:avLst/>
-          </a:prstGeom>
-          <a:noFill/>
-        </p:spPr>
-        <p:txBody>
-          <a:bodyPr wrap="square">
-            <a:spAutoFit/>
-          </a:bodyPr>
-          <a:lstStyle/>
-          <a:p>
-            <a:endParaRPr/>
-          </a:p>
-          <a:p>
-            <a:pPr algn="l">
-              <a:spcBef>
-                <a:spcPts val="0"/>
-              </a:spcBef>
-              <a:spcAft>
-                <a:spcPts val="0"/>
-              </a:spcAft>
-            </a:pPr>
-            <a:r>
-              <a:rPr sz="900" b="0">
-                <a:solidFill>
-                  <a:srgbClr val="1A1A1A"/>
-                </a:solidFill>
-                <a:latin typeface="Calibri"/>
-              </a:rPr>
-              <a:t>data/emails/&lt;supplier&gt;.json
-111 synthetic emails
-6-month window</a:t>
-            </a:r>
-            <a:r>
-              <a:t/>
-            </a:r>
-            <a:br/>
-            <a:r>
-              <a:t>111 synthetic emails</a:t>
-            </a:r>
-            <a:br/>
-            <a:r>
-              <a:t>6-month window</a:t>
-            </a:r>
-          </a:p>
-        </p:txBody>
-      </p:sp>
-      <p:sp>
-        <p:nvSpPr>
-          <p:cNvPr id="25" name="TextBox 24"/>
-          <p:cNvSpPr txBox="1"/>
-          <p:nvPr/>
-        </p:nvSpPr>
-        <p:spPr>
-          <a:xfrm>
-            <a:off x="7004303" y="1627632"/>
-            <a:ext cx="2468879" cy="868680"/>
-          </a:xfrm>
-          <a:prstGeom prst="rect">
-            <a:avLst/>
-          </a:prstGeom>
-          <a:noFill/>
-        </p:spPr>
-        <p:txBody>
-          <a:bodyPr wrap="square">
-            <a:spAutoFit/>
-          </a:bodyPr>
-          <a:lstStyle/>
-          <a:p>
-            <a:endParaRPr/>
-          </a:p>
-          <a:p>
-            <a:pPr algn="l">
-              <a:spcBef>
-                <a:spcPts val="0"/>
-              </a:spcBef>
-              <a:spcAft>
-                <a:spcPts val="0"/>
-              </a:spcAft>
-            </a:pPr>
-            <a:r>
-              <a:rPr sz="900" b="0">
-                <a:solidFill>
-                  <a:srgbClr val="1A1A1A"/>
-                </a:solidFill>
-                <a:latin typeface="Calibri"/>
-              </a:rPr>
-              <a:t>Python (local)
-No API call
-supplier_analytics.py</a:t>
-            </a:r>
-            <a:r>
-              <a:t/>
-            </a:r>
-            <a:br/>
-            <a:r>
-              <a:t>No API call</a:t>
-            </a:r>
-            <a:br/>
-            <a:r>
-              <a:t>supplier_analytics.py</a:t>
-            </a:r>
-          </a:p>
-        </p:txBody>
-      </p:sp>
-      <p:sp>
-        <p:nvSpPr>
-          <p:cNvPr id="26" name="TextBox 25"/>
-          <p:cNvSpPr txBox="1"/>
-          <p:nvPr/>
-        </p:nvSpPr>
-        <p:spPr>
-          <a:xfrm>
-            <a:off x="9656064" y="1627632"/>
-            <a:ext cx="2331720" cy="868680"/>
-          </a:xfrm>
-          <a:prstGeom prst="rect">
-            <a:avLst/>
-          </a:prstGeom>
-          <a:noFill/>
-        </p:spPr>
-        <p:txBody>
-          <a:bodyPr wrap="square">
-            <a:spAutoFit/>
-          </a:bodyPr>
-          <a:lstStyle/>
-          <a:p>
-            <a:endParaRPr/>
-          </a:p>
-          <a:p>
-            <a:pPr algn="l">
-              <a:spcBef>
-                <a:spcPts val="0"/>
-              </a:spcBef>
-              <a:spcAft>
-                <a:spcPts val="0"/>
-              </a:spcAft>
-            </a:pPr>
-            <a:r>
-              <a:rPr sz="900" b="0">
-                <a:solidFill>
-                  <a:srgbClr val="1A1A1A"/>
-                </a:solidFill>
-                <a:latin typeface="Calibri"/>
-              </a:rPr>
-              <a:t>kpi_response_days
-REAL — avg days</a:t>
-            </a:r>
-            <a:r>
-              <a:t/>
-            </a:r>
-            <a:br/>
-            <a:r>
-              <a:t>REAL — avg days</a:t>
+              <a:rPr b="0" sz="900">
+                <a:solidFill>
+                  <a:srgbClr val="1A1A1A"/>
+                </a:solidFill>
+              </a:rPr>
+              <a:t>logged automatically on every run</a:t>
             </a:r>
           </a:p>
         </p:txBody>
@@ -9701,8 +9702,8 @@
         </p:nvSpPr>
         <p:spPr>
           <a:xfrm>
-            <a:off x="182880" y="2606039"/>
-            <a:ext cx="1188720" cy="987552"/>
+            <a:off x="182880" y="3017520"/>
+            <a:ext cx="1188720" cy="1371600"/>
           </a:xfrm>
           <a:prstGeom prst="rect">
             <a:avLst/>
@@ -9711,9 +9712,7 @@
             <a:srgbClr val="FFFFFF"/>
           </a:solidFill>
           <a:ln>
-            <a:solidFill>
-              <a:srgbClr val="DDDDDD"/>
-            </a:solidFill>
+            <a:noFill/>
           </a:ln>
         </p:spPr>
         <p:style>
@@ -9735,20 +9734,96 @@
           <a:lstStyle/>
           <a:p>
             <a:pPr algn="ctr"/>
-            <a:endParaRPr/>
-          </a:p>
-        </p:txBody>
-      </p:sp>
-      <p:sp>
-        <p:nvSpPr>
-          <p:cNvPr id="28" name="Rectangle 27"/>
+          </a:p>
+        </p:txBody>
+      </p:sp>
+      <p:sp>
+        <p:nvSpPr>
+          <p:cNvPr id="28" name="TextBox 27"/>
+          <p:cNvSpPr txBox="1"/>
+          <p:nvPr/>
+        </p:nvSpPr>
+        <p:spPr>
+          <a:xfrm>
+            <a:off x="237744" y="3090672"/>
+            <a:ext cx="1078992" cy="1225296"/>
+          </a:xfrm>
+          <a:prstGeom prst="rect">
+            <a:avLst/>
+          </a:prstGeom>
+          <a:noFill/>
+        </p:spPr>
+        <p:txBody>
+          <a:bodyPr wrap="square">
+            <a:spAutoFit/>
+          </a:bodyPr>
+          <a:lstStyle/>
+          <a:p>
+            <a:pPr>
+              <a:spcBef>
+                <a:spcPts val="0"/>
+              </a:spcBef>
+              <a:spcAft>
+                <a:spcPts val="0"/>
+              </a:spcAft>
+            </a:pPr>
+            <a:r>
+              <a:rPr b="1" sz="900">
+                <a:solidFill>
+                  <a:srgbClr val="C8102E"/>
+                </a:solidFill>
+              </a:rPr>
+              <a:t>#2</a:t>
+            </a:r>
+          </a:p>
+          <a:p>
+            <a:pPr>
+              <a:spcBef>
+                <a:spcPts val="0"/>
+              </a:spcBef>
+              <a:spcAft>
+                <a:spcPts val="0"/>
+              </a:spcAft>
+            </a:pPr>
+            <a:r>
+              <a:rPr b="1" sz="900">
+                <a:solidFill>
+                  <a:srgbClr val="C8102E"/>
+                </a:solidFill>
+              </a:rPr>
+              <a:t>Packet</a:t>
+            </a:r>
+          </a:p>
+          <a:p>
+            <a:pPr>
+              <a:spcBef>
+                <a:spcPts val="0"/>
+              </a:spcBef>
+              <a:spcAft>
+                <a:spcPts val="0"/>
+              </a:spcAft>
+            </a:pPr>
+            <a:r>
+              <a:rPr b="1" sz="900">
+                <a:solidFill>
+                  <a:srgbClr val="C8102E"/>
+                </a:solidFill>
+              </a:rPr>
+              <a:t>Adoption Rate</a:t>
+            </a:r>
+          </a:p>
+        </p:txBody>
+      </p:sp>
+      <p:sp>
+        <p:nvSpPr>
+          <p:cNvPr id="29" name="Rectangle 28"/>
           <p:cNvSpPr/>
           <p:nvPr/>
         </p:nvSpPr>
         <p:spPr>
           <a:xfrm>
-            <a:off x="1463040" y="2606039"/>
-            <a:ext cx="2560320" cy="987552"/>
+            <a:off x="1371600" y="3017520"/>
+            <a:ext cx="2697480" cy="1371600"/>
           </a:xfrm>
           <a:prstGeom prst="rect">
             <a:avLst/>
@@ -9757,9 +9832,7 @@
             <a:srgbClr val="FFFFFF"/>
           </a:solidFill>
           <a:ln>
-            <a:solidFill>
-              <a:srgbClr val="DDDDDD"/>
-            </a:solidFill>
+            <a:noFill/>
           </a:ln>
         </p:spPr>
         <p:style>
@@ -9781,20 +9854,96 @@
           <a:lstStyle/>
           <a:p>
             <a:pPr algn="ctr"/>
-            <a:endParaRPr/>
-          </a:p>
-        </p:txBody>
-      </p:sp>
-      <p:sp>
-        <p:nvSpPr>
-          <p:cNvPr id="29" name="Rectangle 28"/>
+          </a:p>
+        </p:txBody>
+      </p:sp>
+      <p:sp>
+        <p:nvSpPr>
+          <p:cNvPr id="30" name="TextBox 29"/>
+          <p:cNvSpPr txBox="1"/>
+          <p:nvPr/>
+        </p:nvSpPr>
+        <p:spPr>
+          <a:xfrm>
+            <a:off x="1426464" y="3090672"/>
+            <a:ext cx="2587752" cy="1225296"/>
+          </a:xfrm>
+          <a:prstGeom prst="rect">
+            <a:avLst/>
+          </a:prstGeom>
+          <a:noFill/>
+        </p:spPr>
+        <p:txBody>
+          <a:bodyPr wrap="square">
+            <a:spAutoFit/>
+          </a:bodyPr>
+          <a:lstStyle/>
+          <a:p>
+            <a:pPr>
+              <a:spcBef>
+                <a:spcPts val="0"/>
+              </a:spcBef>
+              <a:spcAft>
+                <a:spcPts val="0"/>
+              </a:spcAft>
+            </a:pPr>
+            <a:r>
+              <a:rPr b="0" sz="900">
+                <a:solidFill>
+                  <a:srgbClr val="1A1A1A"/>
+                </a:solidFill>
+              </a:rPr>
+              <a:t>packets generated (total)</a:t>
+            </a:r>
+          </a:p>
+          <a:p>
+            <a:pPr>
+              <a:spcBef>
+                <a:spcPts val="0"/>
+              </a:spcBef>
+              <a:spcAft>
+                <a:spcPts val="0"/>
+              </a:spcAft>
+            </a:pPr>
+            <a:r>
+              <a:rPr b="0" sz="900">
+                <a:solidFill>
+                  <a:srgbClr val="1A1A1A"/>
+                </a:solidFill>
+              </a:rPr>
+              <a:t>meetings in calendar (total)</a:t>
+            </a:r>
+          </a:p>
+          <a:p>
+            <a:pPr>
+              <a:spcBef>
+                <a:spcPts val="0"/>
+              </a:spcBef>
+              <a:spcAft>
+                <a:spcPts val="0"/>
+              </a:spcAft>
+            </a:pPr>
+            <a:r>
+              <a:rPr b="0" sz="900">
+                <a:solidFill>
+                  <a:srgbClr val="1A1A1A"/>
+                </a:solidFill>
+              </a:rPr>
+              <a:t>packets opened by manager</a:t>
+            </a:r>
+          </a:p>
+        </p:txBody>
+      </p:sp>
+      <p:sp>
+        <p:nvSpPr>
+          <p:cNvPr id="31" name="Rectangle 30"/>
           <p:cNvSpPr/>
           <p:nvPr/>
         </p:nvSpPr>
         <p:spPr>
           <a:xfrm>
-            <a:off x="4114800" y="2606039"/>
-            <a:ext cx="2743200" cy="987552"/>
+            <a:off x="4069080" y="3017520"/>
+            <a:ext cx="2697480" cy="1371600"/>
           </a:xfrm>
           <a:prstGeom prst="rect">
             <a:avLst/>
@@ -9803,9 +9952,7 @@
             <a:srgbClr val="FFFFFF"/>
           </a:solidFill>
           <a:ln>
-            <a:solidFill>
-              <a:srgbClr val="DDDDDD"/>
-            </a:solidFill>
+            <a:noFill/>
           </a:ln>
         </p:spPr>
         <p:style>
@@ -9827,20 +9974,78 @@
           <a:lstStyle/>
           <a:p>
             <a:pPr algn="ctr"/>
-            <a:endParaRPr/>
-          </a:p>
-        </p:txBody>
-      </p:sp>
-      <p:sp>
-        <p:nvSpPr>
-          <p:cNvPr id="30" name="Rectangle 29"/>
+          </a:p>
+        </p:txBody>
+      </p:sp>
+      <p:sp>
+        <p:nvSpPr>
+          <p:cNvPr id="32" name="TextBox 31"/>
+          <p:cNvSpPr txBox="1"/>
+          <p:nvPr/>
+        </p:nvSpPr>
+        <p:spPr>
+          <a:xfrm>
+            <a:off x="4123944" y="3090672"/>
+            <a:ext cx="2587752" cy="1225296"/>
+          </a:xfrm>
+          <a:prstGeom prst="rect">
+            <a:avLst/>
+          </a:prstGeom>
+          <a:noFill/>
+        </p:spPr>
+        <p:txBody>
+          <a:bodyPr wrap="square">
+            <a:spAutoFit/>
+          </a:bodyPr>
+          <a:lstStyle/>
+          <a:p>
+            <a:pPr>
+              <a:spcBef>
+                <a:spcPts val="0"/>
+              </a:spcBef>
+              <a:spcAft>
+                <a:spcPts val="0"/>
+              </a:spcAft>
+            </a:pPr>
+            <a:r>
+              <a:rPr b="0" sz="900">
+                <a:solidFill>
+                  <a:srgbClr val="1A1A1A"/>
+                </a:solidFill>
+              </a:rPr>
+              <a:t>SQLite session log</a:t>
+            </a:r>
+          </a:p>
+          <a:p>
+            <a:pPr>
+              <a:spcBef>
+                <a:spcPts val="0"/>
+              </a:spcBef>
+              <a:spcAft>
+                <a:spcPts val="0"/>
+              </a:spcAft>
+            </a:pPr>
+            <a:r>
+              <a:rPr b="0" sz="900">
+                <a:solidFill>
+                  <a:srgbClr val="1A1A1A"/>
+                </a:solidFill>
+              </a:rPr>
+              <a:t>calendar.csv</a:t>
+            </a:r>
+          </a:p>
+        </p:txBody>
+      </p:sp>
+      <p:sp>
+        <p:nvSpPr>
+          <p:cNvPr id="33" name="Rectangle 32"/>
           <p:cNvSpPr/>
           <p:nvPr/>
         </p:nvSpPr>
         <p:spPr>
           <a:xfrm>
-            <a:off x="6949440" y="2606039"/>
-            <a:ext cx="2560320" cy="987552"/>
+            <a:off x="6766560" y="3017520"/>
+            <a:ext cx="2697480" cy="1371600"/>
           </a:xfrm>
           <a:prstGeom prst="rect">
             <a:avLst/>
@@ -9849,9 +10054,7 @@
             <a:srgbClr val="FFFFFF"/>
           </a:solidFill>
           <a:ln>
-            <a:solidFill>
-              <a:srgbClr val="DDDDDD"/>
-            </a:solidFill>
+            <a:noFill/>
           </a:ln>
         </p:spPr>
         <p:style>
@@ -9873,20 +10076,78 @@
           <a:lstStyle/>
           <a:p>
             <a:pPr algn="ctr"/>
-            <a:endParaRPr/>
-          </a:p>
-        </p:txBody>
-      </p:sp>
-      <p:sp>
-        <p:nvSpPr>
-          <p:cNvPr id="31" name="Rectangle 30"/>
+          </a:p>
+        </p:txBody>
+      </p:sp>
+      <p:sp>
+        <p:nvSpPr>
+          <p:cNvPr id="34" name="TextBox 33"/>
+          <p:cNvSpPr txBox="1"/>
+          <p:nvPr/>
+        </p:nvSpPr>
+        <p:spPr>
+          <a:xfrm>
+            <a:off x="6821424" y="3090672"/>
+            <a:ext cx="2587752" cy="1225296"/>
+          </a:xfrm>
+          <a:prstGeom prst="rect">
+            <a:avLst/>
+          </a:prstGeom>
+          <a:noFill/>
+        </p:spPr>
+        <p:txBody>
+          <a:bodyPr wrap="square">
+            <a:spAutoFit/>
+          </a:bodyPr>
+          <a:lstStyle/>
+          <a:p>
+            <a:pPr>
+              <a:spcBef>
+                <a:spcPts val="0"/>
+              </a:spcBef>
+              <a:spcAft>
+                <a:spcPts val="0"/>
+              </a:spcAft>
+            </a:pPr>
+            <a:r>
+              <a:rPr b="0" sz="900">
+                <a:solidFill>
+                  <a:srgbClr val="1A1A1A"/>
+                </a:solidFill>
+              </a:rPr>
+              <a:t>Python</a:t>
+            </a:r>
+          </a:p>
+          <a:p>
+            <a:pPr>
+              <a:spcBef>
+                <a:spcPts val="0"/>
+              </a:spcBef>
+              <a:spcAft>
+                <a:spcPts val="0"/>
+              </a:spcAft>
+            </a:pPr>
+            <a:r>
+              <a:rPr b="0" sz="900">
+                <a:solidFill>
+                  <a:srgbClr val="1A1A1A"/>
+                </a:solidFill>
+              </a:rPr>
+              <a:t>packets used / meetings scheduled x 100</a:t>
+            </a:r>
+          </a:p>
+        </p:txBody>
+      </p:sp>
+      <p:sp>
+        <p:nvSpPr>
+          <p:cNvPr id="35" name="Rectangle 34"/>
           <p:cNvSpPr/>
           <p:nvPr/>
         </p:nvSpPr>
         <p:spPr>
           <a:xfrm>
-            <a:off x="9601200" y="2606039"/>
-            <a:ext cx="2423160" cy="987552"/>
+            <a:off x="9464040" y="3017520"/>
+            <a:ext cx="2542032" cy="1371600"/>
           </a:xfrm>
           <a:prstGeom prst="rect">
             <a:avLst/>
@@ -9895,9 +10156,7 @@
             <a:srgbClr val="FFFFFF"/>
           </a:solidFill>
           <a:ln>
-            <a:solidFill>
-              <a:srgbClr val="DDDDDD"/>
-            </a:solidFill>
+            <a:noFill/>
           </a:ln>
         </p:spPr>
         <p:style>
@@ -9919,20 +10178,19 @@
           <a:lstStyle/>
           <a:p>
             <a:pPr algn="ctr"/>
-            <a:endParaRPr/>
-          </a:p>
-        </p:txBody>
-      </p:sp>
-      <p:sp>
-        <p:nvSpPr>
-          <p:cNvPr id="32" name="TextBox 31"/>
+          </a:p>
+        </p:txBody>
+      </p:sp>
+      <p:sp>
+        <p:nvSpPr>
+          <p:cNvPr id="36" name="TextBox 35"/>
           <p:cNvSpPr txBox="1"/>
           <p:nvPr/>
         </p:nvSpPr>
         <p:spPr>
           <a:xfrm>
-            <a:off x="237744" y="2660903"/>
-            <a:ext cx="1097280" cy="868680"/>
+            <a:off x="9518904" y="3090672"/>
+            <a:ext cx="2432304" cy="1225296"/>
           </a:xfrm>
           <a:prstGeom prst="rect">
             <a:avLst/>
@@ -9945,10 +10203,7 @@
           </a:bodyPr>
           <a:lstStyle/>
           <a:p>
-            <a:endParaRPr/>
-          </a:p>
-          <a:p>
-            <a:pPr algn="l">
+            <a:pPr>
               <a:spcBef>
                 <a:spcPts val="0"/>
               </a:spcBef>
@@ -9957,51 +10212,16 @@
               </a:spcAft>
             </a:pPr>
             <a:r>
-              <a:rPr sz="900" b="1">
-                <a:solidFill>
-                  <a:srgbClr val="C8102E"/>
-                </a:solidFill>
-                <a:latin typeface="Calibri"/>
-              </a:rPr>
-              <a:t>§2
-Open Issues</a:t>
-            </a:r>
-            <a:r>
-              <a:t/>
-            </a:r>
-            <a:br/>
-            <a:r>
-              <a:t>Open Issues</a:t>
-            </a:r>
-          </a:p>
-        </p:txBody>
-      </p:sp>
-      <p:sp>
-        <p:nvSpPr>
-          <p:cNvPr id="33" name="TextBox 32"/>
-          <p:cNvSpPr txBox="1"/>
-          <p:nvPr/>
-        </p:nvSpPr>
-        <p:spPr>
-          <a:xfrm>
-            <a:off x="1517904" y="2660903"/>
-            <a:ext cx="2468879" cy="868680"/>
-          </a:xfrm>
-          <a:prstGeom prst="rect">
-            <a:avLst/>
-          </a:prstGeom>
-          <a:noFill/>
-        </p:spPr>
-        <p:txBody>
-          <a:bodyPr wrap="square">
-            <a:spAutoFit/>
-          </a:bodyPr>
-          <a:lstStyle/>
-          <a:p>
-            <a:endParaRPr/>
-          </a:p>
-          <a:p>
-            <a:pPr algn="l">
+              <a:rPr b="0" sz="900">
+                <a:solidFill>
+                  <a:srgbClr val="1A1A1A"/>
+                </a:solidFill>
+              </a:rPr>
+              <a:t>logged on every page load</a:t>
+            </a:r>
+          </a:p>
+          <a:p>
+            <a:pPr>
               <a:spcBef>
                 <a:spcPts val="0"/>
               </a:spcBef>
@@ -10010,195 +10230,12 @@
               </a:spcAft>
             </a:pPr>
             <a:r>
-              <a:rPr sz="900" b="0">
-                <a:solidFill>
-                  <a:srgbClr val="1A1A1A"/>
-                </a:solidFill>
-                <a:latin typeface="Calibri"/>
-              </a:rPr>
-              <a:t>Full email body text
-Contract clause text
-Issue type / status</a:t>
-            </a:r>
-            <a:r>
-              <a:t/>
-            </a:r>
-            <a:br/>
-            <a:r>
-              <a:t>Contract clause text</a:t>
-            </a:r>
-            <a:br/>
-            <a:r>
-              <a:t>Issue type / status</a:t>
-            </a:r>
-          </a:p>
-        </p:txBody>
-      </p:sp>
-      <p:sp>
-        <p:nvSpPr>
-          <p:cNvPr id="34" name="TextBox 33"/>
-          <p:cNvSpPr txBox="1"/>
-          <p:nvPr/>
-        </p:nvSpPr>
-        <p:spPr>
-          <a:xfrm>
-            <a:off x="4169663" y="2660903"/>
-            <a:ext cx="2651760" cy="868680"/>
-          </a:xfrm>
-          <a:prstGeom prst="rect">
-            <a:avLst/>
-          </a:prstGeom>
-          <a:noFill/>
-        </p:spPr>
-        <p:txBody>
-          <a:bodyPr wrap="square">
-            <a:spAutoFit/>
-          </a:bodyPr>
-          <a:lstStyle/>
-          <a:p>
-            <a:endParaRPr/>
-          </a:p>
-          <a:p>
-            <a:pPr algn="l">
-              <a:spcBef>
-                <a:spcPts val="0"/>
-              </a:spcBef>
-              <a:spcAft>
-                <a:spcPts val="0"/>
-              </a:spcAft>
-            </a:pPr>
-            <a:r>
-              <a:rPr sz="900" b="0">
-                <a:solidFill>
-                  <a:srgbClr val="1A1A1A"/>
-                </a:solidFill>
-                <a:latin typeface="Calibri"/>
-              </a:rPr>
-              <a:t>Same email JSONs
-+ data/contracts/*.md
-Fed to Claude in one prompt</a:t>
-            </a:r>
-            <a:r>
-              <a:t/>
-            </a:r>
-            <a:br/>
-            <a:r>
-              <a:t>+ data/contracts/*.md</a:t>
-            </a:r>
-            <a:br/>
-            <a:r>
-              <a:t>Fed to Claude in one prompt</a:t>
-            </a:r>
-          </a:p>
-        </p:txBody>
-      </p:sp>
-      <p:sp>
-        <p:nvSpPr>
-          <p:cNvPr id="35" name="TextBox 34"/>
-          <p:cNvSpPr txBox="1"/>
-          <p:nvPr/>
-        </p:nvSpPr>
-        <p:spPr>
-          <a:xfrm>
-            <a:off x="7004303" y="2660903"/>
-            <a:ext cx="2468879" cy="868680"/>
-          </a:xfrm>
-          <a:prstGeom prst="rect">
-            <a:avLst/>
-          </a:prstGeom>
-          <a:noFill/>
-        </p:spPr>
-        <p:txBody>
-          <a:bodyPr wrap="square">
-            <a:spAutoFit/>
-          </a:bodyPr>
-          <a:lstStyle/>
-          <a:p>
-            <a:endParaRPr/>
-          </a:p>
-          <a:p>
-            <a:pPr algn="l">
-              <a:spcBef>
-                <a:spcPts val="0"/>
-              </a:spcBef>
-              <a:spcAft>
-                <a:spcPts val="0"/>
-              </a:spcAft>
-            </a:pPr>
-            <a:r>
-              <a:rPr sz="900" b="0">
-                <a:solidFill>
-                  <a:srgbClr val="1A1A1A"/>
-                </a:solidFill>
-                <a:latin typeface="Calibri"/>
-              </a:rPr>
-              <a:t>Claude API
-extraction.py
-Returns structured JSON</a:t>
-            </a:r>
-            <a:r>
-              <a:t/>
-            </a:r>
-            <a:br/>
-            <a:r>
-              <a:t>extraction.py</a:t>
-            </a:r>
-            <a:br/>
-            <a:r>
-              <a:t>Returns structured JSON</a:t>
-            </a:r>
-          </a:p>
-        </p:txBody>
-      </p:sp>
-      <p:sp>
-        <p:nvSpPr>
-          <p:cNvPr id="36" name="TextBox 35"/>
-          <p:cNvSpPr txBox="1"/>
-          <p:nvPr/>
-        </p:nvSpPr>
-        <p:spPr>
-          <a:xfrm>
-            <a:off x="9656064" y="2660903"/>
-            <a:ext cx="2331720" cy="868680"/>
-          </a:xfrm>
-          <a:prstGeom prst="rect">
-            <a:avLst/>
-          </a:prstGeom>
-          <a:noFill/>
-        </p:spPr>
-        <p:txBody>
-          <a:bodyPr wrap="square">
-            <a:spAutoFit/>
-          </a:bodyPr>
-          <a:lstStyle/>
-          <a:p>
-            <a:endParaRPr/>
-          </a:p>
-          <a:p>
-            <a:pPr algn="l">
-              <a:spcBef>
-                <a:spcPts val="0"/>
-              </a:spcBef>
-              <a:spcAft>
-                <a:spcPts val="0"/>
-              </a:spcAft>
-            </a:pPr>
-            <a:r>
-              <a:rPr sz="900" b="0">
-                <a:solidFill>
-                  <a:srgbClr val="1A1A1A"/>
-                </a:solidFill>
-                <a:latin typeface="Calibri"/>
-              </a:rPr>
-              <a:t>kpi_open_issues
-INTEGER — count</a:t>
-            </a:r>
-            <a:r>
-              <a:t/>
-            </a:r>
-            <a:br/>
-            <a:r>
-              <a:t>INTEGER — count</a:t>
+              <a:rPr b="0" sz="900">
+                <a:solidFill>
+                  <a:srgbClr val="1A1A1A"/>
+                </a:solidFill>
+              </a:rPr>
+              <a:t>of Meeting Prep</a:t>
             </a:r>
           </a:p>
         </p:txBody>
@@ -10211,8 +10248,8 @@
         </p:nvSpPr>
         <p:spPr>
           <a:xfrm>
-            <a:off x="182880" y="3639311"/>
-            <a:ext cx="1188720" cy="987552"/>
+            <a:off x="182880" y="4462272"/>
+            <a:ext cx="1188720" cy="1371600"/>
           </a:xfrm>
           <a:prstGeom prst="rect">
             <a:avLst/>
@@ -10221,9 +10258,7 @@
             <a:srgbClr val="F0F0F0"/>
           </a:solidFill>
           <a:ln>
-            <a:solidFill>
-              <a:srgbClr val="DDDDDD"/>
-            </a:solidFill>
+            <a:noFill/>
           </a:ln>
         </p:spPr>
         <p:style>
@@ -10245,20 +10280,96 @@
           <a:lstStyle/>
           <a:p>
             <a:pPr algn="ctr"/>
-            <a:endParaRPr/>
-          </a:p>
-        </p:txBody>
-      </p:sp>
-      <p:sp>
-        <p:nvSpPr>
-          <p:cNvPr id="38" name="Rectangle 37"/>
+          </a:p>
+        </p:txBody>
+      </p:sp>
+      <p:sp>
+        <p:nvSpPr>
+          <p:cNvPr id="38" name="TextBox 37"/>
+          <p:cNvSpPr txBox="1"/>
+          <p:nvPr/>
+        </p:nvSpPr>
+        <p:spPr>
+          <a:xfrm>
+            <a:off x="237744" y="4535424"/>
+            <a:ext cx="1078992" cy="1225296"/>
+          </a:xfrm>
+          <a:prstGeom prst="rect">
+            <a:avLst/>
+          </a:prstGeom>
+          <a:noFill/>
+        </p:spPr>
+        <p:txBody>
+          <a:bodyPr wrap="square">
+            <a:spAutoFit/>
+          </a:bodyPr>
+          <a:lstStyle/>
+          <a:p>
+            <a:pPr>
+              <a:spcBef>
+                <a:spcPts val="0"/>
+              </a:spcBef>
+              <a:spcAft>
+                <a:spcPts val="0"/>
+              </a:spcAft>
+            </a:pPr>
+            <a:r>
+              <a:rPr b="1" sz="900">
+                <a:solidFill>
+                  <a:srgbClr val="C8102E"/>
+                </a:solidFill>
+              </a:rPr>
+              <a:t>#3</a:t>
+            </a:r>
+          </a:p>
+          <a:p>
+            <a:pPr>
+              <a:spcBef>
+                <a:spcPts val="0"/>
+              </a:spcBef>
+              <a:spcAft>
+                <a:spcPts val="0"/>
+              </a:spcAft>
+            </a:pPr>
+            <a:r>
+              <a:rPr b="1" sz="900">
+                <a:solidFill>
+                  <a:srgbClr val="C8102E"/>
+                </a:solidFill>
+              </a:rPr>
+              <a:t>Correction /</a:t>
+            </a:r>
+          </a:p>
+          <a:p>
+            <a:pPr>
+              <a:spcBef>
+                <a:spcPts val="0"/>
+              </a:spcBef>
+              <a:spcAft>
+                <a:spcPts val="0"/>
+              </a:spcAft>
+            </a:pPr>
+            <a:r>
+              <a:rPr b="1" sz="900">
+                <a:solidFill>
+                  <a:srgbClr val="C8102E"/>
+                </a:solidFill>
+              </a:rPr>
+              <a:t>Override Rate</a:t>
+            </a:r>
+          </a:p>
+        </p:txBody>
+      </p:sp>
+      <p:sp>
+        <p:nvSpPr>
+          <p:cNvPr id="39" name="Rectangle 38"/>
           <p:cNvSpPr/>
           <p:nvPr/>
         </p:nvSpPr>
         <p:spPr>
           <a:xfrm>
-            <a:off x="1463040" y="3639311"/>
-            <a:ext cx="2560320" cy="987552"/>
+            <a:off x="1371600" y="4462272"/>
+            <a:ext cx="2697480" cy="1371600"/>
           </a:xfrm>
           <a:prstGeom prst="rect">
             <a:avLst/>
@@ -10267,9 +10378,7 @@
             <a:srgbClr val="F0F0F0"/>
           </a:solidFill>
           <a:ln>
-            <a:solidFill>
-              <a:srgbClr val="DDDDDD"/>
-            </a:solidFill>
+            <a:noFill/>
           </a:ln>
         </p:spPr>
         <p:style>
@@ -10291,20 +10400,96 @@
           <a:lstStyle/>
           <a:p>
             <a:pPr algn="ctr"/>
-            <a:endParaRPr/>
-          </a:p>
-        </p:txBody>
-      </p:sp>
-      <p:sp>
-        <p:nvSpPr>
-          <p:cNvPr id="39" name="Rectangle 38"/>
+          </a:p>
+        </p:txBody>
+      </p:sp>
+      <p:sp>
+        <p:nvSpPr>
+          <p:cNvPr id="40" name="TextBox 39"/>
+          <p:cNvSpPr txBox="1"/>
+          <p:nvPr/>
+        </p:nvSpPr>
+        <p:spPr>
+          <a:xfrm>
+            <a:off x="1426464" y="4535424"/>
+            <a:ext cx="2587752" cy="1225296"/>
+          </a:xfrm>
+          <a:prstGeom prst="rect">
+            <a:avLst/>
+          </a:prstGeom>
+          <a:noFill/>
+        </p:spPr>
+        <p:txBody>
+          <a:bodyPr wrap="square">
+            <a:spAutoFit/>
+          </a:bodyPr>
+          <a:lstStyle/>
+          <a:p>
+            <a:pPr>
+              <a:spcBef>
+                <a:spcPts val="0"/>
+              </a:spcBef>
+              <a:spcAft>
+                <a:spcPts val="0"/>
+              </a:spcAft>
+            </a:pPr>
+            <a:r>
+              <a:rPr b="0" sz="900">
+                <a:solidFill>
+                  <a:srgbClr val="1A1A1A"/>
+                </a:solidFill>
+              </a:rPr>
+              <a:t>fields presented to manager</a:t>
+            </a:r>
+          </a:p>
+          <a:p>
+            <a:pPr>
+              <a:spcBef>
+                <a:spcPts val="0"/>
+              </a:spcBef>
+              <a:spcAft>
+                <a:spcPts val="0"/>
+              </a:spcAft>
+            </a:pPr>
+            <a:r>
+              <a:rPr b="0" sz="900">
+                <a:solidFill>
+                  <a:srgbClr val="1A1A1A"/>
+                </a:solidFill>
+              </a:rPr>
+              <a:t>fields flagged or corrected</a:t>
+            </a:r>
+          </a:p>
+          <a:p>
+            <a:pPr>
+              <a:spcBef>
+                <a:spcPts val="0"/>
+              </a:spcBef>
+              <a:spcAft>
+                <a:spcPts val="0"/>
+              </a:spcAft>
+            </a:pPr>
+            <a:r>
+              <a:rPr b="0" sz="900">
+                <a:solidFill>
+                  <a:srgbClr val="1A1A1A"/>
+                </a:solidFill>
+              </a:rPr>
+              <a:t>by manager</a:t>
+            </a:r>
+          </a:p>
+        </p:txBody>
+      </p:sp>
+      <p:sp>
+        <p:nvSpPr>
+          <p:cNvPr id="41" name="Rectangle 40"/>
           <p:cNvSpPr/>
           <p:nvPr/>
         </p:nvSpPr>
         <p:spPr>
           <a:xfrm>
-            <a:off x="4114800" y="3639311"/>
-            <a:ext cx="2743200" cy="987552"/>
+            <a:off x="4069080" y="4462272"/>
+            <a:ext cx="2697480" cy="1371600"/>
           </a:xfrm>
           <a:prstGeom prst="rect">
             <a:avLst/>
@@ -10313,9 +10498,7 @@
             <a:srgbClr val="F0F0F0"/>
           </a:solidFill>
           <a:ln>
-            <a:solidFill>
-              <a:srgbClr val="DDDDDD"/>
-            </a:solidFill>
+            <a:noFill/>
           </a:ln>
         </p:spPr>
         <p:style>
@@ -10337,20 +10520,96 @@
           <a:lstStyle/>
           <a:p>
             <a:pPr algn="ctr"/>
-            <a:endParaRPr/>
-          </a:p>
-        </p:txBody>
-      </p:sp>
-      <p:sp>
-        <p:nvSpPr>
-          <p:cNvPr id="40" name="Rectangle 39"/>
+          </a:p>
+        </p:txBody>
+      </p:sp>
+      <p:sp>
+        <p:nvSpPr>
+          <p:cNvPr id="42" name="TextBox 41"/>
+          <p:cNvSpPr txBox="1"/>
+          <p:nvPr/>
+        </p:nvSpPr>
+        <p:spPr>
+          <a:xfrm>
+            <a:off x="4123944" y="4535424"/>
+            <a:ext cx="2587752" cy="1225296"/>
+          </a:xfrm>
+          <a:prstGeom prst="rect">
+            <a:avLst/>
+          </a:prstGeom>
+          <a:noFill/>
+        </p:spPr>
+        <p:txBody>
+          <a:bodyPr wrap="square">
+            <a:spAutoFit/>
+          </a:bodyPr>
+          <a:lstStyle/>
+          <a:p>
+            <a:pPr>
+              <a:spcBef>
+                <a:spcPts val="0"/>
+              </a:spcBef>
+              <a:spcAft>
+                <a:spcPts val="0"/>
+              </a:spcAft>
+            </a:pPr>
+            <a:r>
+              <a:rPr b="0" sz="900">
+                <a:solidFill>
+                  <a:srgbClr val="1A1A1A"/>
+                </a:solidFill>
+              </a:rPr>
+              <a:t>correction_log.csv</a:t>
+            </a:r>
+          </a:p>
+          <a:p>
+            <a:pPr>
+              <a:spcBef>
+                <a:spcPts val="0"/>
+              </a:spcBef>
+              <a:spcAft>
+                <a:spcPts val="0"/>
+              </a:spcAft>
+            </a:pPr>
+            <a:r>
+              <a:rPr b="0" sz="900">
+                <a:solidFill>
+                  <a:srgbClr val="1A1A1A"/>
+                </a:solidFill>
+              </a:rPr>
+              <a:t>(populated when manager</a:t>
+            </a:r>
+          </a:p>
+          <a:p>
+            <a:pPr>
+              <a:spcBef>
+                <a:spcPts val="0"/>
+              </a:spcBef>
+              <a:spcAft>
+                <a:spcPts val="0"/>
+              </a:spcAft>
+            </a:pPr>
+            <a:r>
+              <a:rPr b="0" sz="900">
+                <a:solidFill>
+                  <a:srgbClr val="1A1A1A"/>
+                </a:solidFill>
+              </a:rPr>
+              <a:t>flags a field)</a:t>
+            </a:r>
+          </a:p>
+        </p:txBody>
+      </p:sp>
+      <p:sp>
+        <p:nvSpPr>
+          <p:cNvPr id="43" name="Rectangle 42"/>
           <p:cNvSpPr/>
           <p:nvPr/>
         </p:nvSpPr>
         <p:spPr>
           <a:xfrm>
-            <a:off x="6949440" y="3639311"/>
-            <a:ext cx="2560320" cy="987552"/>
+            <a:off x="6766560" y="4462272"/>
+            <a:ext cx="2697480" cy="1371600"/>
           </a:xfrm>
           <a:prstGeom prst="rect">
             <a:avLst/>
@@ -10359,9 +10618,7 @@
             <a:srgbClr val="F0F0F0"/>
           </a:solidFill>
           <a:ln>
-            <a:solidFill>
-              <a:srgbClr val="DDDDDD"/>
-            </a:solidFill>
+            <a:noFill/>
           </a:ln>
         </p:spPr>
         <p:style>
@@ -10383,20 +10640,96 @@
           <a:lstStyle/>
           <a:p>
             <a:pPr algn="ctr"/>
-            <a:endParaRPr/>
-          </a:p>
-        </p:txBody>
-      </p:sp>
-      <p:sp>
-        <p:nvSpPr>
-          <p:cNvPr id="41" name="Rectangle 40"/>
+          </a:p>
+        </p:txBody>
+      </p:sp>
+      <p:sp>
+        <p:nvSpPr>
+          <p:cNvPr id="44" name="TextBox 43"/>
+          <p:cNvSpPr txBox="1"/>
+          <p:nvPr/>
+        </p:nvSpPr>
+        <p:spPr>
+          <a:xfrm>
+            <a:off x="6821424" y="4535424"/>
+            <a:ext cx="2587752" cy="1225296"/>
+          </a:xfrm>
+          <a:prstGeom prst="rect">
+            <a:avLst/>
+          </a:prstGeom>
+          <a:noFill/>
+        </p:spPr>
+        <p:txBody>
+          <a:bodyPr wrap="square">
+            <a:spAutoFit/>
+          </a:bodyPr>
+          <a:lstStyle/>
+          <a:p>
+            <a:pPr>
+              <a:spcBef>
+                <a:spcPts val="0"/>
+              </a:spcBef>
+              <a:spcAft>
+                <a:spcPts val="0"/>
+              </a:spcAft>
+            </a:pPr>
+            <a:r>
+              <a:rPr b="0" sz="900">
+                <a:solidFill>
+                  <a:srgbClr val="1A1A1A"/>
+                </a:solidFill>
+              </a:rPr>
+              <a:t>Python</a:t>
+            </a:r>
+          </a:p>
+          <a:p>
+            <a:pPr>
+              <a:spcBef>
+                <a:spcPts val="0"/>
+              </a:spcBef>
+              <a:spcAft>
+                <a:spcPts val="0"/>
+              </a:spcAft>
+            </a:pPr>
+            <a:r>
+              <a:rPr b="0" sz="900">
+                <a:solidFill>
+                  <a:srgbClr val="1A1A1A"/>
+                </a:solidFill>
+              </a:rPr>
+              <a:t>fields flagged / total fields</a:t>
+            </a:r>
+          </a:p>
+          <a:p>
+            <a:pPr>
+              <a:spcBef>
+                <a:spcPts val="0"/>
+              </a:spcBef>
+              <a:spcAft>
+                <a:spcPts val="0"/>
+              </a:spcAft>
+            </a:pPr>
+            <a:r>
+              <a:rPr b="0" sz="900">
+                <a:solidFill>
+                  <a:srgbClr val="1A1A1A"/>
+                </a:solidFill>
+              </a:rPr>
+              <a:t>presented x 100</a:t>
+            </a:r>
+          </a:p>
+        </p:txBody>
+      </p:sp>
+      <p:sp>
+        <p:nvSpPr>
+          <p:cNvPr id="45" name="Rectangle 44"/>
           <p:cNvSpPr/>
           <p:nvPr/>
         </p:nvSpPr>
         <p:spPr>
           <a:xfrm>
-            <a:off x="9601200" y="3639311"/>
-            <a:ext cx="2423160" cy="987552"/>
+            <a:off x="9464040" y="4462272"/>
+            <a:ext cx="2542032" cy="1371600"/>
           </a:xfrm>
           <a:prstGeom prst="rect">
             <a:avLst/>
@@ -10405,9 +10738,7 @@
             <a:srgbClr val="F0F0F0"/>
           </a:solidFill>
           <a:ln>
-            <a:solidFill>
-              <a:srgbClr val="DDDDDD"/>
-            </a:solidFill>
+            <a:noFill/>
           </a:ln>
         </p:spPr>
         <p:style>
@@ -10429,20 +10760,19 @@
           <a:lstStyle/>
           <a:p>
             <a:pPr algn="ctr"/>
-            <a:endParaRPr/>
-          </a:p>
-        </p:txBody>
-      </p:sp>
-      <p:sp>
-        <p:nvSpPr>
-          <p:cNvPr id="42" name="TextBox 41"/>
+          </a:p>
+        </p:txBody>
+      </p:sp>
+      <p:sp>
+        <p:nvSpPr>
+          <p:cNvPr id="46" name="TextBox 45"/>
           <p:cNvSpPr txBox="1"/>
           <p:nvPr/>
         </p:nvSpPr>
         <p:spPr>
           <a:xfrm>
-            <a:off x="237744" y="3694175"/>
-            <a:ext cx="1097280" cy="868680"/>
+            <a:off x="9518904" y="4535424"/>
+            <a:ext cx="2432304" cy="1225296"/>
           </a:xfrm>
           <a:prstGeom prst="rect">
             <a:avLst/>
@@ -10455,10 +10785,7 @@
           </a:bodyPr>
           <a:lstStyle/>
           <a:p>
-            <a:endParaRPr/>
-          </a:p>
-          <a:p>
-            <a:pPr algn="l">
+            <a:pPr>
               <a:spcBef>
                 <a:spcPts val="0"/>
               </a:spcBef>
@@ -10467,51 +10794,16 @@
               </a:spcAft>
             </a:pPr>
             <a:r>
-              <a:rPr sz="900" b="1">
-                <a:solidFill>
-                  <a:srgbClr val="C8102E"/>
-                </a:solidFill>
-                <a:latin typeface="Calibri"/>
-              </a:rPr>
-              <a:t>§3
-Price Delta</a:t>
-            </a:r>
-            <a:r>
-              <a:t/>
-            </a:r>
-            <a:br/>
-            <a:r>
-              <a:t>Price Delta</a:t>
-            </a:r>
-          </a:p>
-        </p:txBody>
-      </p:sp>
-      <p:sp>
-        <p:nvSpPr>
-          <p:cNvPr id="43" name="TextBox 42"/>
-          <p:cNvSpPr txBox="1"/>
-          <p:nvPr/>
-        </p:nvSpPr>
-        <p:spPr>
-          <a:xfrm>
-            <a:off x="1517904" y="3694175"/>
-            <a:ext cx="2468879" cy="868680"/>
-          </a:xfrm>
-          <a:prstGeom prst="rect">
-            <a:avLst/>
-          </a:prstGeom>
-          <a:noFill/>
-        </p:spPr>
-        <p:txBody>
-          <a:bodyPr wrap="square">
-            <a:spAutoFit/>
-          </a:bodyPr>
-          <a:lstStyle/>
-          <a:p>
-            <a:endParaRPr/>
-          </a:p>
-          <a:p>
-            <a:pPr algn="l">
+              <a:rPr b="0" sz="900">
+                <a:solidFill>
+                  <a:srgbClr val="1A1A1A"/>
+                </a:solidFill>
+              </a:rPr>
+              <a:t>manager clicks flag on any field</a:t>
+            </a:r>
+          </a:p>
+          <a:p>
+            <a:pPr>
               <a:spcBef>
                 <a:spcPts val="0"/>
               </a:spcBef>
@@ -10520,56 +10812,16 @@
               </a:spcAft>
             </a:pPr>
             <a:r>
-              <a:rPr sz="900" b="0">
-                <a:solidFill>
-                  <a:srgbClr val="1A1A1A"/>
-                </a:solidFill>
-                <a:latin typeface="Calibri"/>
-              </a:rPr>
-              <a:t>latest_price_quoted.value
-latest_price_quoted.unit
-contract_base_price_numeric</a:t>
-            </a:r>
-            <a:r>
-              <a:t/>
-            </a:r>
-            <a:br/>
-            <a:r>
-              <a:t>latest_price_quoted.unit</a:t>
-            </a:r>
-            <a:br/>
-            <a:r>
-              <a:t>contract_base_price_numeric</a:t>
-            </a:r>
-          </a:p>
-        </p:txBody>
-      </p:sp>
-      <p:sp>
-        <p:nvSpPr>
-          <p:cNvPr id="44" name="TextBox 43"/>
-          <p:cNvSpPr txBox="1"/>
-          <p:nvPr/>
-        </p:nvSpPr>
-        <p:spPr>
-          <a:xfrm>
-            <a:off x="4169663" y="3694175"/>
-            <a:ext cx="2651760" cy="868680"/>
-          </a:xfrm>
-          <a:prstGeom prst="rect">
-            <a:avLst/>
-          </a:prstGeom>
-          <a:noFill/>
-        </p:spPr>
-        <p:txBody>
-          <a:bodyPr wrap="square">
-            <a:spAutoFit/>
-          </a:bodyPr>
-          <a:lstStyle/>
-          <a:p>
-            <a:endParaRPr/>
-          </a:p>
-          <a:p>
-            <a:pPr algn="l">
+              <a:rPr b="0" sz="900">
+                <a:solidFill>
+                  <a:srgbClr val="1A1A1A"/>
+                </a:solidFill>
+              </a:rPr>
+              <a:t>saved to correction_log.csv</a:t>
+            </a:r>
+          </a:p>
+          <a:p>
+            <a:pPr>
               <a:spcBef>
                 <a:spcPts val="0"/>
               </a:spcBef>
@@ -10578,1202 +10830,12 @@
               </a:spcAft>
             </a:pPr>
             <a:r>
-              <a:rPr sz="900" b="0">
-                <a:solidFill>
-                  <a:srgbClr val="1A1A1A"/>
-                </a:solidFill>
-                <a:latin typeface="Calibri"/>
-              </a:rPr>
-              <a:t>Price: Claude extraction
-from email body
-Base: contract Pricing section</a:t>
-            </a:r>
-            <a:r>
-              <a:t/>
-            </a:r>
-            <a:br/>
-            <a:r>
-              <a:t>from email body</a:t>
-            </a:r>
-            <a:br/>
-            <a:r>
-              <a:t>Base: contract Pricing section</a:t>
-            </a:r>
-          </a:p>
-        </p:txBody>
-      </p:sp>
-      <p:sp>
-        <p:nvSpPr>
-          <p:cNvPr id="45" name="TextBox 44"/>
-          <p:cNvSpPr txBox="1"/>
-          <p:nvPr/>
-        </p:nvSpPr>
-        <p:spPr>
-          <a:xfrm>
-            <a:off x="7004303" y="3694175"/>
-            <a:ext cx="2468879" cy="868680"/>
-          </a:xfrm>
-          <a:prstGeom prst="rect">
-            <a:avLst/>
-          </a:prstGeom>
-          <a:noFill/>
-        </p:spPr>
-        <p:txBody>
-          <a:bodyPr wrap="square">
-            <a:spAutoFit/>
-          </a:bodyPr>
-          <a:lstStyle/>
-          <a:p>
-            <a:endParaRPr/>
-          </a:p>
-          <a:p>
-            <a:pPr algn="l">
-              <a:spcBef>
-                <a:spcPts val="0"/>
-              </a:spcBef>
-              <a:spcAft>
-                <a:spcPts val="0"/>
-              </a:spcAft>
-            </a:pPr>
-            <a:r>
-              <a:rPr sz="900" b="0">
-                <a:solidFill>
-                  <a:srgbClr val="1A1A1A"/>
-                </a:solidFill>
-                <a:latin typeface="Calibri"/>
-              </a:rPr>
-              <a:t>Claude (price from email)
-Python delta calc (local)
-packet_generator.py</a:t>
-            </a:r>
-            <a:r>
-              <a:t/>
-            </a:r>
-            <a:br/>
-            <a:r>
-              <a:t>Python delta calc (local)</a:t>
-            </a:r>
-            <a:br/>
-            <a:r>
-              <a:t>packet_generator.py</a:t>
-            </a:r>
-          </a:p>
-        </p:txBody>
-      </p:sp>
-      <p:sp>
-        <p:nvSpPr>
-          <p:cNvPr id="46" name="TextBox 45"/>
-          <p:cNvSpPr txBox="1"/>
-          <p:nvPr/>
-        </p:nvSpPr>
-        <p:spPr>
-          <a:xfrm>
-            <a:off x="9656064" y="3694175"/>
-            <a:ext cx="2331720" cy="868680"/>
-          </a:xfrm>
-          <a:prstGeom prst="rect">
-            <a:avLst/>
-          </a:prstGeom>
-          <a:noFill/>
-        </p:spPr>
-        <p:txBody>
-          <a:bodyPr wrap="square">
-            <a:spAutoFit/>
-          </a:bodyPr>
-          <a:lstStyle/>
-          <a:p>
-            <a:endParaRPr/>
-          </a:p>
-          <a:p>
-            <a:pPr algn="l">
-              <a:spcBef>
-                <a:spcPts val="0"/>
-              </a:spcBef>
-              <a:spcAft>
-                <a:spcPts val="0"/>
-              </a:spcAft>
-            </a:pPr>
-            <a:r>
-              <a:rPr sz="900" b="0">
-                <a:solidFill>
-                  <a:srgbClr val="1A1A1A"/>
-                </a:solidFill>
-                <a:latin typeface="Calibri"/>
-              </a:rPr>
-              <a:t>kpi_price_delta_pct
-REAL — % delta</a:t>
-            </a:r>
-            <a:r>
-              <a:t/>
-            </a:r>
-            <a:br/>
-            <a:r>
-              <a:t>REAL — % delta</a:t>
-            </a:r>
-          </a:p>
-        </p:txBody>
-      </p:sp>
-      <p:sp>
-        <p:nvSpPr>
-          <p:cNvPr id="47" name="Rectangle 46"/>
-          <p:cNvSpPr/>
-          <p:nvPr/>
-        </p:nvSpPr>
-        <p:spPr>
-          <a:xfrm>
-            <a:off x="182880" y="4672583"/>
-            <a:ext cx="1188720" cy="987552"/>
-          </a:xfrm>
-          <a:prstGeom prst="rect">
-            <a:avLst/>
-          </a:prstGeom>
-          <a:solidFill>
-            <a:srgbClr val="FFFFFF"/>
-          </a:solidFill>
-          <a:ln>
-            <a:solidFill>
-              <a:srgbClr val="DDDDDD"/>
-            </a:solidFill>
-          </a:ln>
-        </p:spPr>
-        <p:style>
-          <a:lnRef idx="1">
-            <a:schemeClr val="accent1"/>
-          </a:lnRef>
-          <a:fillRef idx="3">
-            <a:schemeClr val="accent1"/>
-          </a:fillRef>
-          <a:effectRef idx="2">
-            <a:schemeClr val="accent1"/>
-          </a:effectRef>
-          <a:fontRef idx="minor">
-            <a:schemeClr val="lt1"/>
-          </a:fontRef>
-        </p:style>
-        <p:txBody>
-          <a:bodyPr rtlCol="0" anchor="ctr"/>
-          <a:lstStyle/>
-          <a:p>
-            <a:pPr algn="ctr"/>
-            <a:endParaRPr/>
-          </a:p>
-        </p:txBody>
-      </p:sp>
-      <p:sp>
-        <p:nvSpPr>
-          <p:cNvPr id="48" name="Rectangle 47"/>
-          <p:cNvSpPr/>
-          <p:nvPr/>
-        </p:nvSpPr>
-        <p:spPr>
-          <a:xfrm>
-            <a:off x="1463040" y="4672583"/>
-            <a:ext cx="2560320" cy="987552"/>
-          </a:xfrm>
-          <a:prstGeom prst="rect">
-            <a:avLst/>
-          </a:prstGeom>
-          <a:solidFill>
-            <a:srgbClr val="FFFFFF"/>
-          </a:solidFill>
-          <a:ln>
-            <a:solidFill>
-              <a:srgbClr val="DDDDDD"/>
-            </a:solidFill>
-          </a:ln>
-        </p:spPr>
-        <p:style>
-          <a:lnRef idx="1">
-            <a:schemeClr val="accent1"/>
-          </a:lnRef>
-          <a:fillRef idx="3">
-            <a:schemeClr val="accent1"/>
-          </a:fillRef>
-          <a:effectRef idx="2">
-            <a:schemeClr val="accent1"/>
-          </a:effectRef>
-          <a:fontRef idx="minor">
-            <a:schemeClr val="lt1"/>
-          </a:fontRef>
-        </p:style>
-        <p:txBody>
-          <a:bodyPr rtlCol="0" anchor="ctr"/>
-          <a:lstStyle/>
-          <a:p>
-            <a:pPr algn="ctr"/>
-            <a:endParaRPr/>
-          </a:p>
-        </p:txBody>
-      </p:sp>
-      <p:sp>
-        <p:nvSpPr>
-          <p:cNvPr id="49" name="Rectangle 48"/>
-          <p:cNvSpPr/>
-          <p:nvPr/>
-        </p:nvSpPr>
-        <p:spPr>
-          <a:xfrm>
-            <a:off x="4114800" y="4672583"/>
-            <a:ext cx="2743200" cy="987552"/>
-          </a:xfrm>
-          <a:prstGeom prst="rect">
-            <a:avLst/>
-          </a:prstGeom>
-          <a:solidFill>
-            <a:srgbClr val="FFFFFF"/>
-          </a:solidFill>
-          <a:ln>
-            <a:solidFill>
-              <a:srgbClr val="DDDDDD"/>
-            </a:solidFill>
-          </a:ln>
-        </p:spPr>
-        <p:style>
-          <a:lnRef idx="1">
-            <a:schemeClr val="accent1"/>
-          </a:lnRef>
-          <a:fillRef idx="3">
-            <a:schemeClr val="accent1"/>
-          </a:fillRef>
-          <a:effectRef idx="2">
-            <a:schemeClr val="accent1"/>
-          </a:effectRef>
-          <a:fontRef idx="minor">
-            <a:schemeClr val="lt1"/>
-          </a:fontRef>
-        </p:style>
-        <p:txBody>
-          <a:bodyPr rtlCol="0" anchor="ctr"/>
-          <a:lstStyle/>
-          <a:p>
-            <a:pPr algn="ctr"/>
-            <a:endParaRPr/>
-          </a:p>
-        </p:txBody>
-      </p:sp>
-      <p:sp>
-        <p:nvSpPr>
-          <p:cNvPr id="50" name="Rectangle 49"/>
-          <p:cNvSpPr/>
-          <p:nvPr/>
-        </p:nvSpPr>
-        <p:spPr>
-          <a:xfrm>
-            <a:off x="6949440" y="4672583"/>
-            <a:ext cx="2560320" cy="987552"/>
-          </a:xfrm>
-          <a:prstGeom prst="rect">
-            <a:avLst/>
-          </a:prstGeom>
-          <a:solidFill>
-            <a:srgbClr val="FFFFFF"/>
-          </a:solidFill>
-          <a:ln>
-            <a:solidFill>
-              <a:srgbClr val="DDDDDD"/>
-            </a:solidFill>
-          </a:ln>
-        </p:spPr>
-        <p:style>
-          <a:lnRef idx="1">
-            <a:schemeClr val="accent1"/>
-          </a:lnRef>
-          <a:fillRef idx="3">
-            <a:schemeClr val="accent1"/>
-          </a:fillRef>
-          <a:effectRef idx="2">
-            <a:schemeClr val="accent1"/>
-          </a:effectRef>
-          <a:fontRef idx="minor">
-            <a:schemeClr val="lt1"/>
-          </a:fontRef>
-        </p:style>
-        <p:txBody>
-          <a:bodyPr rtlCol="0" anchor="ctr"/>
-          <a:lstStyle/>
-          <a:p>
-            <a:pPr algn="ctr"/>
-            <a:endParaRPr/>
-          </a:p>
-        </p:txBody>
-      </p:sp>
-      <p:sp>
-        <p:nvSpPr>
-          <p:cNvPr id="51" name="Rectangle 50"/>
-          <p:cNvSpPr/>
-          <p:nvPr/>
-        </p:nvSpPr>
-        <p:spPr>
-          <a:xfrm>
-            <a:off x="9601200" y="4672583"/>
-            <a:ext cx="2423160" cy="987552"/>
-          </a:xfrm>
-          <a:prstGeom prst="rect">
-            <a:avLst/>
-          </a:prstGeom>
-          <a:solidFill>
-            <a:srgbClr val="FFFFFF"/>
-          </a:solidFill>
-          <a:ln>
-            <a:solidFill>
-              <a:srgbClr val="DDDDDD"/>
-            </a:solidFill>
-          </a:ln>
-        </p:spPr>
-        <p:style>
-          <a:lnRef idx="1">
-            <a:schemeClr val="accent1"/>
-          </a:lnRef>
-          <a:fillRef idx="3">
-            <a:schemeClr val="accent1"/>
-          </a:fillRef>
-          <a:effectRef idx="2">
-            <a:schemeClr val="accent1"/>
-          </a:effectRef>
-          <a:fontRef idx="minor">
-            <a:schemeClr val="lt1"/>
-          </a:fontRef>
-        </p:style>
-        <p:txBody>
-          <a:bodyPr rtlCol="0" anchor="ctr"/>
-          <a:lstStyle/>
-          <a:p>
-            <a:pPr algn="ctr"/>
-            <a:endParaRPr/>
-          </a:p>
-        </p:txBody>
-      </p:sp>
-      <p:sp>
-        <p:nvSpPr>
-          <p:cNvPr id="52" name="TextBox 51"/>
-          <p:cNvSpPr txBox="1"/>
-          <p:nvPr/>
-        </p:nvSpPr>
-        <p:spPr>
-          <a:xfrm>
-            <a:off x="237744" y="4727447"/>
-            <a:ext cx="1097280" cy="868680"/>
-          </a:xfrm>
-          <a:prstGeom prst="rect">
-            <a:avLst/>
-          </a:prstGeom>
-          <a:noFill/>
-        </p:spPr>
-        <p:txBody>
-          <a:bodyPr wrap="square">
-            <a:spAutoFit/>
-          </a:bodyPr>
-          <a:lstStyle/>
-          <a:p>
-            <a:endParaRPr/>
-          </a:p>
-          <a:p>
-            <a:pPr algn="l">
-              <a:spcBef>
-                <a:spcPts val="0"/>
-              </a:spcBef>
-              <a:spcAft>
-                <a:spcPts val="0"/>
-              </a:spcAft>
-            </a:pPr>
-            <a:r>
-              <a:rPr sz="900" b="1">
-                <a:solidFill>
-                  <a:srgbClr val="C8102E"/>
-                </a:solidFill>
-                <a:latin typeface="Calibri"/>
-              </a:rPr>
-              <a:t>§4
-Days to Renewal</a:t>
-            </a:r>
-            <a:r>
-              <a:t/>
-            </a:r>
-            <a:br/>
-            <a:r>
-              <a:t>Days to Renewal</a:t>
-            </a:r>
-          </a:p>
-        </p:txBody>
-      </p:sp>
-      <p:sp>
-        <p:nvSpPr>
-          <p:cNvPr id="53" name="TextBox 52"/>
-          <p:cNvSpPr txBox="1"/>
-          <p:nvPr/>
-        </p:nvSpPr>
-        <p:spPr>
-          <a:xfrm>
-            <a:off x="1517904" y="4727447"/>
-            <a:ext cx="2468879" cy="868680"/>
-          </a:xfrm>
-          <a:prstGeom prst="rect">
-            <a:avLst/>
-          </a:prstGeom>
-          <a:noFill/>
-        </p:spPr>
-        <p:txBody>
-          <a:bodyPr wrap="square">
-            <a:spAutoFit/>
-          </a:bodyPr>
-          <a:lstStyle/>
-          <a:p>
-            <a:endParaRPr/>
-          </a:p>
-          <a:p>
-            <a:pPr algn="l">
-              <a:spcBef>
-                <a:spcPts val="0"/>
-              </a:spcBef>
-              <a:spcAft>
-                <a:spcPts val="0"/>
-              </a:spcAft>
-            </a:pPr>
-            <a:r>
-              <a:rPr sz="900" b="0">
-                <a:solidFill>
-                  <a:srgbClr val="1A1A1A"/>
-                </a:solidFill>
-                <a:latin typeface="Calibri"/>
-              </a:rPr>
-              <a:t>contract.renewal_date
-system date (today)
-contract.status</a:t>
-            </a:r>
-            <a:r>
-              <a:t/>
-            </a:r>
-            <a:br/>
-            <a:r>
-              <a:t>system date (today)</a:t>
-            </a:r>
-            <a:br/>
-            <a:r>
-              <a:t>contract.status</a:t>
-            </a:r>
-          </a:p>
-        </p:txBody>
-      </p:sp>
-      <p:sp>
-        <p:nvSpPr>
-          <p:cNvPr id="54" name="TextBox 53"/>
-          <p:cNvSpPr txBox="1"/>
-          <p:nvPr/>
-        </p:nvSpPr>
-        <p:spPr>
-          <a:xfrm>
-            <a:off x="4169663" y="4727447"/>
-            <a:ext cx="2651760" cy="868680"/>
-          </a:xfrm>
-          <a:prstGeom prst="rect">
-            <a:avLst/>
-          </a:prstGeom>
-          <a:noFill/>
-        </p:spPr>
-        <p:txBody>
-          <a:bodyPr wrap="square">
-            <a:spAutoFit/>
-          </a:bodyPr>
-          <a:lstStyle/>
-          <a:p>
-            <a:endParaRPr/>
-          </a:p>
-          <a:p>
-            <a:pPr algn="l">
-              <a:spcBef>
-                <a:spcPts val="0"/>
-              </a:spcBef>
-              <a:spcAft>
-                <a:spcPts val="0"/>
-              </a:spcAft>
-            </a:pPr>
-            <a:r>
-              <a:rPr sz="900" b="0">
-                <a:solidFill>
-                  <a:srgbClr val="1A1A1A"/>
-                </a:solidFill>
-                <a:latin typeface="Calibri"/>
-              </a:rPr>
-              <a:t>data/contracts/*.md
-Renewal Date field
-Status: active/expired/draft</a:t>
-            </a:r>
-            <a:r>
-              <a:t/>
-            </a:r>
-            <a:br/>
-            <a:r>
-              <a:t>Renewal Date field</a:t>
-            </a:r>
-            <a:br/>
-            <a:r>
-              <a:t>Status: active/expired/draft</a:t>
-            </a:r>
-          </a:p>
-        </p:txBody>
-      </p:sp>
-      <p:sp>
-        <p:nvSpPr>
-          <p:cNvPr id="55" name="TextBox 54"/>
-          <p:cNvSpPr txBox="1"/>
-          <p:nvPr/>
-        </p:nvSpPr>
-        <p:spPr>
-          <a:xfrm>
-            <a:off x="7004303" y="4727447"/>
-            <a:ext cx="2468879" cy="868680"/>
-          </a:xfrm>
-          <a:prstGeom prst="rect">
-            <a:avLst/>
-          </a:prstGeom>
-          <a:noFill/>
-        </p:spPr>
-        <p:txBody>
-          <a:bodyPr wrap="square">
-            <a:spAutoFit/>
-          </a:bodyPr>
-          <a:lstStyle/>
-          <a:p>
-            <a:endParaRPr/>
-          </a:p>
-          <a:p>
-            <a:pPr algn="l">
-              <a:spcBef>
-                <a:spcPts val="0"/>
-              </a:spcBef>
-              <a:spcAft>
-                <a:spcPts val="0"/>
-              </a:spcAft>
-            </a:pPr>
-            <a:r>
-              <a:rPr sz="900" b="0">
-                <a:solidFill>
-                  <a:srgbClr val="1A1A1A"/>
-                </a:solidFill>
-                <a:latin typeface="Calibri"/>
-              </a:rPr>
-              <a:t>Python (local)
-date arithmetic only
-No API call</a:t>
-            </a:r>
-            <a:r>
-              <a:t/>
-            </a:r>
-            <a:br/>
-            <a:r>
-              <a:t>date arithmetic only</a:t>
-            </a:r>
-            <a:br/>
-            <a:r>
-              <a:t>No API call</a:t>
-            </a:r>
-          </a:p>
-        </p:txBody>
-      </p:sp>
-      <p:sp>
-        <p:nvSpPr>
-          <p:cNvPr id="56" name="TextBox 55"/>
-          <p:cNvSpPr txBox="1"/>
-          <p:nvPr/>
-        </p:nvSpPr>
-        <p:spPr>
-          <a:xfrm>
-            <a:off x="9656064" y="4727447"/>
-            <a:ext cx="2331720" cy="868680"/>
-          </a:xfrm>
-          <a:prstGeom prst="rect">
-            <a:avLst/>
-          </a:prstGeom>
-          <a:noFill/>
-        </p:spPr>
-        <p:txBody>
-          <a:bodyPr wrap="square">
-            <a:spAutoFit/>
-          </a:bodyPr>
-          <a:lstStyle/>
-          <a:p>
-            <a:endParaRPr/>
-          </a:p>
-          <a:p>
-            <a:pPr algn="l">
-              <a:spcBef>
-                <a:spcPts val="0"/>
-              </a:spcBef>
-              <a:spcAft>
-                <a:spcPts val="0"/>
-              </a:spcAft>
-            </a:pPr>
-            <a:r>
-              <a:rPr sz="900" b="0">
-                <a:solidFill>
-                  <a:srgbClr val="1A1A1A"/>
-                </a:solidFill>
-                <a:latin typeface="Calibri"/>
-              </a:rPr>
-              <a:t>kpi_days_to_renewal
-INTEGER — days</a:t>
-            </a:r>
-            <a:r>
-              <a:t/>
-            </a:r>
-            <a:br/>
-            <a:r>
-              <a:t>INTEGER — days</a:t>
-            </a:r>
-          </a:p>
-        </p:txBody>
-      </p:sp>
-      <p:sp>
-        <p:nvSpPr>
-          <p:cNvPr id="57" name="Rectangle 56"/>
-          <p:cNvSpPr/>
-          <p:nvPr/>
-        </p:nvSpPr>
-        <p:spPr>
-          <a:xfrm>
-            <a:off x="182880" y="5705855"/>
-            <a:ext cx="1188720" cy="987552"/>
-          </a:xfrm>
-          <a:prstGeom prst="rect">
-            <a:avLst/>
-          </a:prstGeom>
-          <a:solidFill>
-            <a:srgbClr val="F0F0F0"/>
-          </a:solidFill>
-          <a:ln>
-            <a:solidFill>
-              <a:srgbClr val="DDDDDD"/>
-            </a:solidFill>
-          </a:ln>
-        </p:spPr>
-        <p:style>
-          <a:lnRef idx="1">
-            <a:schemeClr val="accent1"/>
-          </a:lnRef>
-          <a:fillRef idx="3">
-            <a:schemeClr val="accent1"/>
-          </a:fillRef>
-          <a:effectRef idx="2">
-            <a:schemeClr val="accent1"/>
-          </a:effectRef>
-          <a:fontRef idx="minor">
-            <a:schemeClr val="lt1"/>
-          </a:fontRef>
-        </p:style>
-        <p:txBody>
-          <a:bodyPr rtlCol="0" anchor="ctr"/>
-          <a:lstStyle/>
-          <a:p>
-            <a:pPr algn="ctr"/>
-            <a:endParaRPr/>
-          </a:p>
-        </p:txBody>
-      </p:sp>
-      <p:sp>
-        <p:nvSpPr>
-          <p:cNvPr id="58" name="Rectangle 57"/>
-          <p:cNvSpPr/>
-          <p:nvPr/>
-        </p:nvSpPr>
-        <p:spPr>
-          <a:xfrm>
-            <a:off x="1463040" y="5705855"/>
-            <a:ext cx="2560320" cy="987552"/>
-          </a:xfrm>
-          <a:prstGeom prst="rect">
-            <a:avLst/>
-          </a:prstGeom>
-          <a:solidFill>
-            <a:srgbClr val="F0F0F0"/>
-          </a:solidFill>
-          <a:ln>
-            <a:solidFill>
-              <a:srgbClr val="DDDDDD"/>
-            </a:solidFill>
-          </a:ln>
-        </p:spPr>
-        <p:style>
-          <a:lnRef idx="1">
-            <a:schemeClr val="accent1"/>
-          </a:lnRef>
-          <a:fillRef idx="3">
-            <a:schemeClr val="accent1"/>
-          </a:fillRef>
-          <a:effectRef idx="2">
-            <a:schemeClr val="accent1"/>
-          </a:effectRef>
-          <a:fontRef idx="minor">
-            <a:schemeClr val="lt1"/>
-          </a:fontRef>
-        </p:style>
-        <p:txBody>
-          <a:bodyPr rtlCol="0" anchor="ctr"/>
-          <a:lstStyle/>
-          <a:p>
-            <a:pPr algn="ctr"/>
-            <a:endParaRPr/>
-          </a:p>
-        </p:txBody>
-      </p:sp>
-      <p:sp>
-        <p:nvSpPr>
-          <p:cNvPr id="59" name="Rectangle 58"/>
-          <p:cNvSpPr/>
-          <p:nvPr/>
-        </p:nvSpPr>
-        <p:spPr>
-          <a:xfrm>
-            <a:off x="4114800" y="5705855"/>
-            <a:ext cx="2743200" cy="987552"/>
-          </a:xfrm>
-          <a:prstGeom prst="rect">
-            <a:avLst/>
-          </a:prstGeom>
-          <a:solidFill>
-            <a:srgbClr val="F0F0F0"/>
-          </a:solidFill>
-          <a:ln>
-            <a:solidFill>
-              <a:srgbClr val="DDDDDD"/>
-            </a:solidFill>
-          </a:ln>
-        </p:spPr>
-        <p:style>
-          <a:lnRef idx="1">
-            <a:schemeClr val="accent1"/>
-          </a:lnRef>
-          <a:fillRef idx="3">
-            <a:schemeClr val="accent1"/>
-          </a:fillRef>
-          <a:effectRef idx="2">
-            <a:schemeClr val="accent1"/>
-          </a:effectRef>
-          <a:fontRef idx="minor">
-            <a:schemeClr val="lt1"/>
-          </a:fontRef>
-        </p:style>
-        <p:txBody>
-          <a:bodyPr rtlCol="0" anchor="ctr"/>
-          <a:lstStyle/>
-          <a:p>
-            <a:pPr algn="ctr"/>
-            <a:endParaRPr/>
-          </a:p>
-        </p:txBody>
-      </p:sp>
-      <p:sp>
-        <p:nvSpPr>
-          <p:cNvPr id="60" name="Rectangle 59"/>
-          <p:cNvSpPr/>
-          <p:nvPr/>
-        </p:nvSpPr>
-        <p:spPr>
-          <a:xfrm>
-            <a:off x="6949440" y="5705855"/>
-            <a:ext cx="2560320" cy="987552"/>
-          </a:xfrm>
-          <a:prstGeom prst="rect">
-            <a:avLst/>
-          </a:prstGeom>
-          <a:solidFill>
-            <a:srgbClr val="F0F0F0"/>
-          </a:solidFill>
-          <a:ln>
-            <a:solidFill>
-              <a:srgbClr val="DDDDDD"/>
-            </a:solidFill>
-          </a:ln>
-        </p:spPr>
-        <p:style>
-          <a:lnRef idx="1">
-            <a:schemeClr val="accent1"/>
-          </a:lnRef>
-          <a:fillRef idx="3">
-            <a:schemeClr val="accent1"/>
-          </a:fillRef>
-          <a:effectRef idx="2">
-            <a:schemeClr val="accent1"/>
-          </a:effectRef>
-          <a:fontRef idx="minor">
-            <a:schemeClr val="lt1"/>
-          </a:fontRef>
-        </p:style>
-        <p:txBody>
-          <a:bodyPr rtlCol="0" anchor="ctr"/>
-          <a:lstStyle/>
-          <a:p>
-            <a:pPr algn="ctr"/>
-            <a:endParaRPr/>
-          </a:p>
-        </p:txBody>
-      </p:sp>
-      <p:sp>
-        <p:nvSpPr>
-          <p:cNvPr id="61" name="Rectangle 60"/>
-          <p:cNvSpPr/>
-          <p:nvPr/>
-        </p:nvSpPr>
-        <p:spPr>
-          <a:xfrm>
-            <a:off x="9601200" y="5705855"/>
-            <a:ext cx="2423160" cy="987552"/>
-          </a:xfrm>
-          <a:prstGeom prst="rect">
-            <a:avLst/>
-          </a:prstGeom>
-          <a:solidFill>
-            <a:srgbClr val="F0F0F0"/>
-          </a:solidFill>
-          <a:ln>
-            <a:solidFill>
-              <a:srgbClr val="DDDDDD"/>
-            </a:solidFill>
-          </a:ln>
-        </p:spPr>
-        <p:style>
-          <a:lnRef idx="1">
-            <a:schemeClr val="accent1"/>
-          </a:lnRef>
-          <a:fillRef idx="3">
-            <a:schemeClr val="accent1"/>
-          </a:fillRef>
-          <a:effectRef idx="2">
-            <a:schemeClr val="accent1"/>
-          </a:effectRef>
-          <a:fontRef idx="minor">
-            <a:schemeClr val="lt1"/>
-          </a:fontRef>
-        </p:style>
-        <p:txBody>
-          <a:bodyPr rtlCol="0" anchor="ctr"/>
-          <a:lstStyle/>
-          <a:p>
-            <a:pPr algn="ctr"/>
-            <a:endParaRPr/>
-          </a:p>
-        </p:txBody>
-      </p:sp>
-      <p:sp>
-        <p:nvSpPr>
-          <p:cNvPr id="62" name="TextBox 61"/>
-          <p:cNvSpPr txBox="1"/>
-          <p:nvPr/>
-        </p:nvSpPr>
-        <p:spPr>
-          <a:xfrm>
-            <a:off x="237744" y="5760719"/>
-            <a:ext cx="1097280" cy="868680"/>
-          </a:xfrm>
-          <a:prstGeom prst="rect">
-            <a:avLst/>
-          </a:prstGeom>
-          <a:noFill/>
-        </p:spPr>
-        <p:txBody>
-          <a:bodyPr wrap="square">
-            <a:spAutoFit/>
-          </a:bodyPr>
-          <a:lstStyle/>
-          <a:p>
-            <a:endParaRPr/>
-          </a:p>
-          <a:p>
-            <a:pPr algn="l">
-              <a:spcBef>
-                <a:spcPts val="0"/>
-              </a:spcBef>
-              <a:spcAft>
-                <a:spcPts val="0"/>
-              </a:spcAft>
-            </a:pPr>
-            <a:r>
-              <a:rPr sz="900" b="1">
-                <a:solidFill>
-                  <a:srgbClr val="C8102E"/>
-                </a:solidFill>
-                <a:latin typeface="Calibri"/>
-              </a:rPr>
-              <a:t>§5
-Correction Rate</a:t>
-            </a:r>
-            <a:r>
-              <a:t/>
-            </a:r>
-            <a:br/>
-            <a:r>
-              <a:t>Correction Rate</a:t>
-            </a:r>
-          </a:p>
-        </p:txBody>
-      </p:sp>
-      <p:sp>
-        <p:nvSpPr>
-          <p:cNvPr id="63" name="TextBox 62"/>
-          <p:cNvSpPr txBox="1"/>
-          <p:nvPr/>
-        </p:nvSpPr>
-        <p:spPr>
-          <a:xfrm>
-            <a:off x="1517904" y="5760719"/>
-            <a:ext cx="2468879" cy="868680"/>
-          </a:xfrm>
-          <a:prstGeom prst="rect">
-            <a:avLst/>
-          </a:prstGeom>
-          <a:noFill/>
-        </p:spPr>
-        <p:txBody>
-          <a:bodyPr wrap="square">
-            <a:spAutoFit/>
-          </a:bodyPr>
-          <a:lstStyle/>
-          <a:p>
-            <a:endParaRPr/>
-          </a:p>
-          <a:p>
-            <a:pPr algn="l">
-              <a:spcBef>
-                <a:spcPts val="0"/>
-              </a:spcBef>
-              <a:spcAft>
-                <a:spcPts val="0"/>
-              </a:spcAft>
-            </a:pPr>
-            <a:r>
-              <a:rPr sz="900" b="0">
-                <a:solidFill>
-                  <a:srgbClr val="1A1A1A"/>
-                </a:solidFill>
-                <a:latin typeface="Calibri"/>
-              </a:rPr>
-              <a:t>Checkbox state per field
-8 trackable fields per packet
-Manager flags in UI</a:t>
-            </a:r>
-            <a:r>
-              <a:t/>
-            </a:r>
-            <a:br/>
-            <a:r>
-              <a:t>8 trackable fields per packet</a:t>
-            </a:r>
-            <a:br/>
-            <a:r>
-              <a:t>Manager flags in UI</a:t>
-            </a:r>
-          </a:p>
-        </p:txBody>
-      </p:sp>
-      <p:sp>
-        <p:nvSpPr>
-          <p:cNvPr id="64" name="TextBox 63"/>
-          <p:cNvSpPr txBox="1"/>
-          <p:nvPr/>
-        </p:nvSpPr>
-        <p:spPr>
-          <a:xfrm>
-            <a:off x="4169663" y="5760719"/>
-            <a:ext cx="2651760" cy="868680"/>
-          </a:xfrm>
-          <a:prstGeom prst="rect">
-            <a:avLst/>
-          </a:prstGeom>
-          <a:noFill/>
-        </p:spPr>
-        <p:txBody>
-          <a:bodyPr wrap="square">
-            <a:spAutoFit/>
-          </a:bodyPr>
-          <a:lstStyle/>
-          <a:p>
-            <a:endParaRPr/>
-          </a:p>
-          <a:p>
-            <a:pPr algn="l">
-              <a:spcBef>
-                <a:spcPts val="0"/>
-              </a:spcBef>
-              <a:spcAft>
-                <a:spcPts val="0"/>
-              </a:spcAft>
-            </a:pPr>
-            <a:r>
-              <a:rPr sz="900" b="0">
-                <a:solidFill>
-                  <a:srgbClr val="1A1A1A"/>
-                </a:solidFill>
-                <a:latin typeface="Calibri"/>
-              </a:rPr>
-              <a:t>Streamlit session state
-correction_log.csv (on Save)
-Joined to SQLite on save</a:t>
-            </a:r>
-            <a:r>
-              <a:t/>
-            </a:r>
-            <a:br/>
-            <a:r>
-              <a:t>correction_log.csv (on Save)</a:t>
-            </a:r>
-            <a:br/>
-            <a:r>
-              <a:t>Joined to SQLite on save</a:t>
-            </a:r>
-          </a:p>
-        </p:txBody>
-      </p:sp>
-      <p:sp>
-        <p:nvSpPr>
-          <p:cNvPr id="65" name="TextBox 64"/>
-          <p:cNvSpPr txBox="1"/>
-          <p:nvPr/>
-        </p:nvSpPr>
-        <p:spPr>
-          <a:xfrm>
-            <a:off x="7004303" y="5760719"/>
-            <a:ext cx="2468879" cy="868680"/>
-          </a:xfrm>
-          <a:prstGeom prst="rect">
-            <a:avLst/>
-          </a:prstGeom>
-          <a:noFill/>
-        </p:spPr>
-        <p:txBody>
-          <a:bodyPr wrap="square">
-            <a:spAutoFit/>
-          </a:bodyPr>
-          <a:lstStyle/>
-          <a:p>
-            <a:endParaRPr/>
-          </a:p>
-          <a:p>
-            <a:pPr algn="l">
-              <a:spcBef>
-                <a:spcPts val="0"/>
-              </a:spcBef>
-              <a:spcAft>
-                <a:spcPts val="0"/>
-              </a:spcAft>
-            </a:pPr>
-            <a:r>
-              <a:rPr sz="900" b="0">
-                <a:solidFill>
-                  <a:srgbClr val="1A1A1A"/>
-                </a:solidFill>
-                <a:latin typeface="Calibri"/>
-              </a:rPr>
-              <a:t>UI interaction only
-Python writes log
-No model involved</a:t>
-            </a:r>
-            <a:r>
-              <a:t/>
-            </a:r>
-            <a:br/>
-            <a:r>
-              <a:t>Python writes log</a:t>
-            </a:r>
-            <a:br/>
-            <a:r>
-              <a:t>No model involved</a:t>
-            </a:r>
-          </a:p>
-        </p:txBody>
-      </p:sp>
-      <p:sp>
-        <p:nvSpPr>
-          <p:cNvPr id="66" name="TextBox 65"/>
-          <p:cNvSpPr txBox="1"/>
-          <p:nvPr/>
-        </p:nvSpPr>
-        <p:spPr>
-          <a:xfrm>
-            <a:off x="9656064" y="5760719"/>
-            <a:ext cx="2331720" cy="868680"/>
-          </a:xfrm>
-          <a:prstGeom prst="rect">
-            <a:avLst/>
-          </a:prstGeom>
-          <a:noFill/>
-        </p:spPr>
-        <p:txBody>
-          <a:bodyPr wrap="square">
-            <a:spAutoFit/>
-          </a:bodyPr>
-          <a:lstStyle/>
-          <a:p>
-            <a:endParaRPr/>
-          </a:p>
-          <a:p>
-            <a:pPr algn="l">
-              <a:spcBef>
-                <a:spcPts val="0"/>
-              </a:spcBef>
-              <a:spcAft>
-                <a:spcPts val="0"/>
-              </a:spcAft>
-            </a:pPr>
-            <a:r>
-              <a:rPr sz="900" b="0">
-                <a:solidFill>
-                  <a:srgbClr val="1A1A1A"/>
-                </a:solidFill>
-                <a:latin typeface="Calibri"/>
-              </a:rPr>
-              <a:t>kpi_correction_rate_pct
-REAL — % flagged</a:t>
-            </a:r>
-            <a:r>
-              <a:t/>
-            </a:r>
-            <a:br/>
-            <a:r>
-              <a:t>REAL — % flagged</a:t>
-            </a:r>
-          </a:p>
-        </p:txBody>
-      </p:sp>
-      <p:sp>
-        <p:nvSpPr>
-          <p:cNvPr id="67" name="TextBox 66"/>
-          <p:cNvSpPr txBox="1"/>
-          <p:nvPr/>
-        </p:nvSpPr>
-        <p:spPr>
-          <a:xfrm>
-            <a:off x="182880" y="6510528"/>
-            <a:ext cx="11795760" cy="256032"/>
-          </a:xfrm>
-          <a:prstGeom prst="rect">
-            <a:avLst/>
-          </a:prstGeom>
-          <a:noFill/>
-        </p:spPr>
-        <p:txBody>
-          <a:bodyPr wrap="none">
-            <a:spAutoFit/>
-          </a:bodyPr>
-          <a:lstStyle/>
-          <a:p>
-            <a:endParaRPr/>
-          </a:p>
-          <a:p>
-            <a:pPr algn="l">
-              <a:spcBef>
-                <a:spcPts val="0"/>
-              </a:spcBef>
-              <a:spcAft>
-                <a:spcPts val="0"/>
-              </a:spcAft>
-            </a:pPr>
-            <a:r>
-              <a:rPr sz="1000" b="0">
-                <a:solidFill>
-                  <a:srgbClr val="555555"/>
-                </a:solidFill>
-                <a:latin typeface="Calibri"/>
-              </a:rPr>
-              <a:t>§1, §3, §4 are pure Python (no API cost). §2 is the only metric that requires a Claude call. §5 is populated only when the manager actively saves corrections.</a:t>
+              <a:rPr b="0" sz="900">
+                <a:solidFill>
+                  <a:srgbClr val="1A1A1A"/>
+                </a:solidFill>
+              </a:rPr>
+              <a:t>automatically</a:t>
             </a:r>
           </a:p>
         </p:txBody>

</xml_diff>